<commit_message>
Finalize git course 2P
</commit_message>
<xml_diff>
--- a/sql_course_2p/2_database_design/2_database_design.pptx
+++ b/sql_course_2p/2_database_design/2_database_design.pptx
@@ -256,7 +256,7 @@
           <a:p>
             <a:fld id="{61CE90D0-176A-4BE5-B54F-392F0A16E3B3}" type="datetimeFigureOut">
               <a:rPr lang="en-NL" smtClean="0"/>
-              <a:t>31/01/2025</a:t>
+              <a:t>14/09/2026</a:t>
             </a:fld>
             <a:endParaRPr lang="en-NL"/>
           </a:p>
@@ -677,34 +677,6 @@
           <a:bodyPr/>
           <a:lstStyle/>
           <a:p>
-            <a:r>
-              <a:rPr lang="en-US" dirty="0"/>
-              <a:t>VRAAG: Hoe </a:t>
-            </a:r>
-            <a:r>
-              <a:rPr lang="en-US" dirty="0" err="1"/>
-              <a:t>draai</a:t>
-            </a:r>
-            <a:r>
-              <a:rPr lang="en-US" dirty="0"/>
-              <a:t> je de </a:t>
-            </a:r>
-            <a:r>
-              <a:rPr lang="en-US" dirty="0" err="1"/>
-              <a:t>selectie</a:t>
-            </a:r>
-            <a:r>
-              <a:rPr lang="en-US" dirty="0"/>
-              <a:t> </a:t>
-            </a:r>
-            <a:r>
-              <a:rPr lang="en-US" dirty="0" err="1"/>
-              <a:t>precies</a:t>
-            </a:r>
-            <a:r>
-              <a:rPr lang="en-US" dirty="0"/>
-              <a:t> om?</a:t>
-            </a:r>
             <a:endParaRPr lang="en-NL" dirty="0"/>
           </a:p>
         </p:txBody>
@@ -1375,11 +1347,11 @@
           <a:p>
             <a:r>
               <a:rPr lang="en-US" dirty="0"/>
-              <a:t>LET OP: </a:t>
+              <a:t>LET OP: Een NULL </a:t>
             </a:r>
             <a:r>
               <a:rPr lang="en-US" dirty="0" err="1"/>
-              <a:t>Werkt</a:t>
+              <a:t>waarde</a:t>
             </a:r>
             <a:r>
               <a:rPr lang="en-US" dirty="0"/>
@@ -1387,31 +1359,7 @@
             </a:r>
             <a:r>
               <a:rPr lang="en-US" dirty="0" err="1"/>
-              <a:t>deze</a:t>
-            </a:r>
-            <a:r>
-              <a:rPr lang="en-US" dirty="0"/>
-              <a:t> check </a:t>
-            </a:r>
-            <a:r>
-              <a:rPr lang="en-US" dirty="0" err="1"/>
-              <a:t>goed</a:t>
-            </a:r>
-            <a:r>
-              <a:rPr lang="en-US" dirty="0"/>
-              <a:t>? Wat </a:t>
-            </a:r>
-            <a:r>
-              <a:rPr lang="en-US" dirty="0" err="1"/>
-              <a:t>gebeurt</a:t>
-            </a:r>
-            <a:r>
-              <a:rPr lang="en-US" dirty="0"/>
-              <a:t> er </a:t>
-            </a:r>
-            <a:r>
-              <a:rPr lang="en-US" dirty="0" err="1"/>
-              <a:t>bij</a:t>
+              <a:t>voldoet</a:t>
             </a:r>
             <a:r>
               <a:rPr lang="en-US" dirty="0"/>
@@ -1419,19 +1367,19 @@
             </a:r>
             <a:r>
               <a:rPr lang="en-US" dirty="0" err="1"/>
-              <a:t>een</a:t>
+              <a:t>aan</a:t>
             </a:r>
             <a:r>
               <a:rPr lang="en-US" dirty="0"/>
-              <a:t> NULL </a:t>
+              <a:t> </a:t>
             </a:r>
             <a:r>
               <a:rPr lang="en-US" dirty="0" err="1"/>
-              <a:t>waarde</a:t>
+              <a:t>deze</a:t>
             </a:r>
             <a:r>
               <a:rPr lang="en-US" dirty="0"/>
-              <a:t>?</a:t>
+              <a:t> check!</a:t>
             </a:r>
             <a:endParaRPr lang="en-NL" dirty="0"/>
           </a:p>
@@ -1535,66 +1483,6 @@
           <a:bodyPr/>
           <a:lstStyle/>
           <a:p>
-            <a:r>
-              <a:rPr lang="en-US" dirty="0"/>
-              <a:t>LET OP: </a:t>
-            </a:r>
-            <a:r>
-              <a:rPr lang="en-US" dirty="0" err="1"/>
-              <a:t>Werkt</a:t>
-            </a:r>
-            <a:r>
-              <a:rPr lang="en-US" dirty="0"/>
-              <a:t> </a:t>
-            </a:r>
-            <a:r>
-              <a:rPr lang="en-US" dirty="0" err="1"/>
-              <a:t>deze</a:t>
-            </a:r>
-            <a:r>
-              <a:rPr lang="en-US" dirty="0"/>
-              <a:t> check </a:t>
-            </a:r>
-            <a:r>
-              <a:rPr lang="en-US" dirty="0" err="1"/>
-              <a:t>goed</a:t>
-            </a:r>
-            <a:r>
-              <a:rPr lang="en-US" dirty="0"/>
-              <a:t>? Wat </a:t>
-            </a:r>
-            <a:r>
-              <a:rPr lang="en-US" dirty="0" err="1"/>
-              <a:t>gebeurt</a:t>
-            </a:r>
-            <a:r>
-              <a:rPr lang="en-US" dirty="0"/>
-              <a:t> er </a:t>
-            </a:r>
-            <a:r>
-              <a:rPr lang="en-US" dirty="0" err="1"/>
-              <a:t>bij</a:t>
-            </a:r>
-            <a:r>
-              <a:rPr lang="en-US" dirty="0"/>
-              <a:t> </a:t>
-            </a:r>
-            <a:r>
-              <a:rPr lang="en-US" dirty="0" err="1"/>
-              <a:t>een</a:t>
-            </a:r>
-            <a:r>
-              <a:rPr lang="en-US" dirty="0"/>
-              <a:t> NULL </a:t>
-            </a:r>
-            <a:r>
-              <a:rPr lang="en-US" dirty="0" err="1"/>
-              <a:t>waarde</a:t>
-            </a:r>
-            <a:r>
-              <a:rPr lang="en-US" dirty="0"/>
-              <a:t>?</a:t>
-            </a:r>
             <a:endParaRPr lang="en-NL" dirty="0"/>
           </a:p>
         </p:txBody>
@@ -3984,7 +3872,7 @@
           <a:p>
             <a:fld id="{7B15CBDA-B49C-4B0F-9869-5B15867EA611}" type="datetimeFigureOut">
               <a:rPr lang="en-NL" smtClean="0"/>
-              <a:t>31/01/2025</a:t>
+              <a:t>14/09/2026</a:t>
             </a:fld>
             <a:endParaRPr lang="en-NL"/>
           </a:p>
@@ -4184,7 +4072,7 @@
           <a:p>
             <a:fld id="{7B15CBDA-B49C-4B0F-9869-5B15867EA611}" type="datetimeFigureOut">
               <a:rPr lang="en-NL" smtClean="0"/>
-              <a:t>31/01/2025</a:t>
+              <a:t>14/09/2026</a:t>
             </a:fld>
             <a:endParaRPr lang="en-NL"/>
           </a:p>
@@ -4394,7 +4282,7 @@
           <a:p>
             <a:fld id="{7B15CBDA-B49C-4B0F-9869-5B15867EA611}" type="datetimeFigureOut">
               <a:rPr lang="en-NL" smtClean="0"/>
-              <a:t>31/01/2025</a:t>
+              <a:t>14/09/2026</a:t>
             </a:fld>
             <a:endParaRPr lang="en-NL"/>
           </a:p>
@@ -4594,7 +4482,7 @@
           <a:p>
             <a:fld id="{7B15CBDA-B49C-4B0F-9869-5B15867EA611}" type="datetimeFigureOut">
               <a:rPr lang="en-NL" smtClean="0"/>
-              <a:t>31/01/2025</a:t>
+              <a:t>14/09/2026</a:t>
             </a:fld>
             <a:endParaRPr lang="en-NL"/>
           </a:p>
@@ -4870,7 +4758,7 @@
           <a:p>
             <a:fld id="{7B15CBDA-B49C-4B0F-9869-5B15867EA611}" type="datetimeFigureOut">
               <a:rPr lang="en-NL" smtClean="0"/>
-              <a:t>31/01/2025</a:t>
+              <a:t>14/09/2026</a:t>
             </a:fld>
             <a:endParaRPr lang="en-NL"/>
           </a:p>
@@ -5138,7 +5026,7 @@
           <a:p>
             <a:fld id="{7B15CBDA-B49C-4B0F-9869-5B15867EA611}" type="datetimeFigureOut">
               <a:rPr lang="en-NL" smtClean="0"/>
-              <a:t>31/01/2025</a:t>
+              <a:t>14/09/2026</a:t>
             </a:fld>
             <a:endParaRPr lang="en-NL"/>
           </a:p>
@@ -5553,7 +5441,7 @@
           <a:p>
             <a:fld id="{7B15CBDA-B49C-4B0F-9869-5B15867EA611}" type="datetimeFigureOut">
               <a:rPr lang="en-NL" smtClean="0"/>
-              <a:t>31/01/2025</a:t>
+              <a:t>14/09/2026</a:t>
             </a:fld>
             <a:endParaRPr lang="en-NL"/>
           </a:p>
@@ -5695,7 +5583,7 @@
           <a:p>
             <a:fld id="{7B15CBDA-B49C-4B0F-9869-5B15867EA611}" type="datetimeFigureOut">
               <a:rPr lang="en-NL" smtClean="0"/>
-              <a:t>31/01/2025</a:t>
+              <a:t>14/09/2026</a:t>
             </a:fld>
             <a:endParaRPr lang="en-NL"/>
           </a:p>
@@ -5808,7 +5696,7 @@
           <a:p>
             <a:fld id="{7B15CBDA-B49C-4B0F-9869-5B15867EA611}" type="datetimeFigureOut">
               <a:rPr lang="en-NL" smtClean="0"/>
-              <a:t>31/01/2025</a:t>
+              <a:t>14/09/2026</a:t>
             </a:fld>
             <a:endParaRPr lang="en-NL"/>
           </a:p>
@@ -6121,7 +6009,7 @@
           <a:p>
             <a:fld id="{7B15CBDA-B49C-4B0F-9869-5B15867EA611}" type="datetimeFigureOut">
               <a:rPr lang="en-NL" smtClean="0"/>
-              <a:t>31/01/2025</a:t>
+              <a:t>14/09/2026</a:t>
             </a:fld>
             <a:endParaRPr lang="en-NL"/>
           </a:p>
@@ -6410,7 +6298,7 @@
           <a:p>
             <a:fld id="{7B15CBDA-B49C-4B0F-9869-5B15867EA611}" type="datetimeFigureOut">
               <a:rPr lang="en-NL" smtClean="0"/>
-              <a:t>31/01/2025</a:t>
+              <a:t>14/09/2026</a:t>
             </a:fld>
             <a:endParaRPr lang="en-NL"/>
           </a:p>
@@ -6653,7 +6541,7 @@
           <a:p>
             <a:fld id="{7B15CBDA-B49C-4B0F-9869-5B15867EA611}" type="datetimeFigureOut">
               <a:rPr lang="en-NL" smtClean="0"/>
-              <a:t>31/01/2025</a:t>
+              <a:t>14/09/2026</a:t>
             </a:fld>
             <a:endParaRPr lang="en-NL"/>
           </a:p>
@@ -9553,7 +9441,7 @@
             </a:pPr>
             <a:r>
               <a:rPr lang="nl-NL" sz="2000" noProof="0" dirty="0"/>
-              <a:t>Elke cel bevat één enkele waarde.</a:t>
+              <a:t>Elke cel bevat één waarde.</a:t>
             </a:r>
           </a:p>
           <a:p>
@@ -15158,7 +15046,7 @@
             </a:pPr>
             <a:r>
               <a:rPr lang="nl-NL" sz="2000" noProof="0" dirty="0"/>
-              <a:t>1NF :		Enkele waarde per cel, alle rijen uniek.</a:t>
+              <a:t>1NF :		Eén waarde per cel, alle rijen uniek.</a:t>
             </a:r>
           </a:p>
           <a:p>
@@ -15885,7 +15773,7 @@
             </a:pPr>
             <a:r>
               <a:rPr lang="nl-NL" sz="2000" noProof="0" dirty="0"/>
-              <a:t>Tabellen en relaties definiëren.</a:t>
+              <a:t>Tabellen en relaties in SQL.</a:t>
             </a:r>
           </a:p>
           <a:p>
@@ -16244,7 +16132,12 @@
             <p:ph idx="1"/>
           </p:nvPr>
         </p:nvSpPr>
-        <p:spPr/>
+        <p:spPr>
+          <a:xfrm>
+            <a:off x="838199" y="1825625"/>
+            <a:ext cx="10739617" cy="4351338"/>
+          </a:xfrm>
+        </p:spPr>
         <p:txBody>
           <a:bodyPr>
             <a:noAutofit/>
@@ -16317,7 +16210,7 @@
             <a:pPr lvl="1"/>
             <a:r>
               <a:rPr lang="nl-NL" sz="2000" noProof="0" dirty="0"/>
-              <a:t>Relatie transacties en producten:	veel op veel... maar transactie regels is één op veel.</a:t>
+              <a:t>Relatie transacties en producten:	veel op veel... maar één op veel per transactieregel.</a:t>
             </a:r>
           </a:p>
           <a:p>
@@ -16382,28 +16275,62 @@
             </a:endParaRPr>
           </a:p>
           <a:p>
-            <a:pPr lvl="1"/>
-            <a:r>
-              <a:rPr lang="nl-NL" sz="2000" noProof="0" dirty="0"/>
-              <a:t>Voldoet aan 1NF:			Ja, unieke rijen met enkele waardes.</a:t>
-            </a:r>
-          </a:p>
-          <a:p>
-            <a:pPr lvl="1"/>
-            <a:r>
-              <a:rPr lang="nl-NL" sz="2000" noProof="0" dirty="0"/>
-              <a:t>Voldoet aan 2NF:			Nee, transactie data niet (</a:t>
-            </a:r>
-            <a:r>
-              <a:rPr lang="nl-NL" sz="2000" noProof="0" dirty="0" err="1">
+            <a:pPr marL="457200" lvl="1" indent="0">
+              <a:buNone/>
+            </a:pPr>
+            <a:r>
+              <a:rPr lang="nl-NL" sz="2000" noProof="0" dirty="0">
                 <a:latin typeface="Courier New" panose="02070309020205020404" pitchFamily="49" charset="0"/>
                 <a:cs typeface="Courier New" panose="02070309020205020404" pitchFamily="49" charset="0"/>
               </a:rPr>
-              <a:t>KlantId</a:t>
-            </a:r>
+              <a:t>					</a:t>
+            </a:r>
+            <a:r>
+              <a:rPr lang="nl-NL" sz="2000" dirty="0" err="1">
+                <a:latin typeface="Courier New" panose="02070309020205020404" pitchFamily="49" charset="0"/>
+                <a:cs typeface="Courier New" panose="02070309020205020404" pitchFamily="49" charset="0"/>
+              </a:rPr>
+              <a:t>TransactieId</a:t>
+            </a:r>
+            <a:r>
+              <a:rPr lang="nl-NL" sz="2000" dirty="0"/>
+              <a:t> + </a:t>
+            </a:r>
+            <a:r>
+              <a:rPr lang="nl-NL" sz="2000" dirty="0" err="1">
+                <a:latin typeface="Courier New" panose="02070309020205020404" pitchFamily="49" charset="0"/>
+                <a:cs typeface="Courier New" panose="02070309020205020404" pitchFamily="49" charset="0"/>
+              </a:rPr>
+              <a:t>KlantID</a:t>
+            </a:r>
+            <a:r>
+              <a:rPr lang="nl-NL" sz="2000" dirty="0"/>
+              <a:t> + </a:t>
+            </a:r>
+            <a:r>
+              <a:rPr lang="nl-NL" sz="2000" dirty="0" err="1">
+                <a:latin typeface="Courier New" panose="02070309020205020404" pitchFamily="49" charset="0"/>
+                <a:cs typeface="Courier New" panose="02070309020205020404" pitchFamily="49" charset="0"/>
+              </a:rPr>
+              <a:t>ProductId</a:t>
+            </a:r>
+            <a:endParaRPr lang="nl-NL" noProof="0" dirty="0">
+              <a:latin typeface="Courier New" panose="02070309020205020404" pitchFamily="49" charset="0"/>
+              <a:cs typeface="Courier New" panose="02070309020205020404" pitchFamily="49" charset="0"/>
+            </a:endParaRPr>
+          </a:p>
+          <a:p>
+            <a:pPr lvl="1"/>
             <a:r>
               <a:rPr lang="nl-NL" sz="2000" noProof="0" dirty="0"/>
-              <a:t>, </a:t>
+              <a:t>Voldoet aan 1NF:			Ja, unieke rijen met enkele waardes.</a:t>
+            </a:r>
+          </a:p>
+          <a:p>
+            <a:pPr lvl="1"/>
+            <a:r>
+              <a:rPr lang="nl-NL" sz="2000" noProof="0" dirty="0"/>
+              <a:t>Voldoet aan 2NF:			Nee, </a:t>
             </a:r>
             <a:r>
               <a:rPr lang="nl-NL" sz="2000" noProof="0" dirty="0" err="1">
@@ -16414,10 +16341,22 @@
             </a:r>
             <a:r>
               <a:rPr lang="nl-NL" sz="2000" dirty="0">
+                <a:cs typeface="Courier New" panose="02070309020205020404" pitchFamily="49" charset="0"/>
+              </a:rPr>
+              <a:t> hangt alleen af van </a:t>
+            </a:r>
+            <a:r>
+              <a:rPr lang="nl-NL" sz="2000" dirty="0" err="1">
                 <a:latin typeface="Courier New" panose="02070309020205020404" pitchFamily="49" charset="0"/>
                 <a:cs typeface="Courier New" panose="02070309020205020404" pitchFamily="49" charset="0"/>
               </a:rPr>
-              <a:t>).</a:t>
+              <a:t>TransactieId</a:t>
+            </a:r>
+            <a:r>
+              <a:rPr lang="nl-NL" sz="2000" dirty="0">
+                <a:cs typeface="Courier New" panose="02070309020205020404" pitchFamily="49" charset="0"/>
+              </a:rPr>
+              <a:t>.</a:t>
             </a:r>
             <a:endParaRPr lang="nl-NL" sz="2000" noProof="0" dirty="0"/>
           </a:p>
@@ -16432,18 +16371,18 @@
                 <a:latin typeface="Courier New" panose="02070309020205020404" pitchFamily="49" charset="0"/>
                 <a:cs typeface="Courier New" panose="02070309020205020404" pitchFamily="49" charset="0"/>
               </a:rPr>
-              <a:t>Prijs</a:t>
+              <a:t>Regelnummer</a:t>
             </a:r>
             <a:r>
               <a:rPr lang="nl-NL" sz="2000" noProof="0" dirty="0"/>
-              <a:t> hangt af van </a:t>
-            </a:r>
-            <a:r>
-              <a:rPr lang="nl-NL" sz="2000" noProof="0" dirty="0" err="1">
+              <a:t> indirect gebaseerd op </a:t>
+            </a:r>
+            <a:r>
+              <a:rPr lang="nl-NL" sz="2000" dirty="0" err="1">
                 <a:latin typeface="Courier New" panose="02070309020205020404" pitchFamily="49" charset="0"/>
                 <a:cs typeface="Courier New" panose="02070309020205020404" pitchFamily="49" charset="0"/>
               </a:rPr>
-              <a:t>ProductId</a:t>
+              <a:t>TransactieId</a:t>
             </a:r>
             <a:r>
               <a:rPr lang="nl-NL" sz="2000" noProof="0" dirty="0"/>
@@ -18621,7 +18560,7 @@
           <a:p>
             <a:r>
               <a:rPr lang="nl-NL" sz="4400" noProof="0" dirty="0"/>
-              <a:t>Tabellen en relaties definiëren</a:t>
+              <a:t>Tabellen en relaties in SQL</a:t>
             </a:r>
           </a:p>
         </p:txBody>
@@ -20894,7 +20833,7 @@
           <a:p>
             <a:r>
               <a:rPr lang="nl-NL" sz="3600" noProof="0" dirty="0"/>
-              <a:t>Verwijzende sleutel</a:t>
+              <a:t>Gekoppelde sleutel</a:t>
             </a:r>
           </a:p>
         </p:txBody>
@@ -21327,7 +21266,7 @@
             </a:pPr>
             <a:r>
               <a:rPr lang="nl-NL" sz="2000" noProof="0" dirty="0"/>
-              <a:t>Sleutel om relatie vast te leggen.</a:t>
+              <a:t>Sleutel om een relatie vast te leggen.</a:t>
             </a:r>
           </a:p>
           <a:p>
@@ -21506,7 +21445,7 @@
           <a:p>
             <a:r>
               <a:rPr lang="nl-NL" sz="3600" noProof="0" dirty="0"/>
-              <a:t>Wijzigingen in verwijzingen</a:t>
+              <a:t>Wijzigingen in gekoppelde tabellen</a:t>
             </a:r>
           </a:p>
         </p:txBody>
@@ -23915,7 +23854,7 @@
           <a:p>
             <a:r>
               <a:rPr lang="nl-NL" sz="3600" noProof="0" dirty="0"/>
-              <a:t>Namen voor controles</a:t>
+              <a:t>Controles een naam geven</a:t>
             </a:r>
           </a:p>
         </p:txBody>
@@ -28539,15 +28478,7 @@
             </a:pPr>
             <a:r>
               <a:rPr lang="nl-NL" sz="2000" noProof="0" dirty="0"/>
-              <a:t>Een view is een </a:t>
-            </a:r>
-            <a:r>
-              <a:rPr lang="nl-NL" sz="2000" u="sng" noProof="0" dirty="0"/>
-              <a:t>opgeslagen query</a:t>
-            </a:r>
-            <a:r>
-              <a:rPr lang="nl-NL" sz="2000" noProof="0" dirty="0"/>
-              <a:t> in de database.</a:t>
+              <a:t>Een view is een query die wordt opgeslagen in de database.</a:t>
             </a:r>
           </a:p>
           <a:p>
@@ -28589,7 +28520,7 @@
             </a:pPr>
             <a:r>
               <a:rPr lang="nl-NL" sz="2000" noProof="0" dirty="0"/>
-              <a:t>View werkt als tabel binnen </a:t>
+              <a:t>In </a:t>
             </a:r>
             <a:r>
               <a:rPr lang="nl-NL" sz="2000" noProof="0" dirty="0">
@@ -28603,15 +28534,7 @@
             </a:r>
             <a:r>
               <a:rPr lang="nl-NL" sz="2000" noProof="0" dirty="0"/>
-              <a:t> </a:t>
-            </a:r>
-            <a:r>
-              <a:rPr lang="nl-NL" sz="2000" noProof="0" dirty="0" err="1"/>
-              <a:t>queries</a:t>
-            </a:r>
-            <a:r>
-              <a:rPr lang="nl-NL" sz="2000" noProof="0" dirty="0"/>
-              <a:t>.</a:t>
+              <a:t> queries werkt een view als een tabel.</a:t>
             </a:r>
           </a:p>
         </p:txBody>
@@ -32160,7 +32083,7 @@
             </a:pPr>
             <a:r>
               <a:rPr lang="nl-NL" sz="2000" noProof="0" dirty="0"/>
-              <a:t>Een index kan een query flink versnellen, omdat niet alle waardes gescand worden.</a:t>
+              <a:t>Een index kan een query flink versnellen, omdat niet de hele tabel ingelezen wordt.</a:t>
             </a:r>
           </a:p>
           <a:p>
@@ -32177,7 +32100,7 @@
             </a:pPr>
             <a:r>
               <a:rPr lang="nl-NL" sz="2000" noProof="0" dirty="0"/>
-              <a:t>Een index maak je aan voor een of meer kolommen (vb. </a:t>
+              <a:t>Een index maak je aan op een of meer kolommen (vb. </a:t>
             </a:r>
             <a:r>
               <a:rPr lang="nl-NL" sz="2000" noProof="0" dirty="0">
@@ -32205,7 +32128,7 @@
             </a:pPr>
             <a:r>
               <a:rPr lang="nl-NL" sz="2000" noProof="0" dirty="0"/>
-              <a:t>Een index koppelt unieke waardes aan rijen, waardoor minder data ingelezen wordt.</a:t>
+              <a:t>De index koppelt unieke waardes aan rijen.</a:t>
             </a:r>
           </a:p>
           <a:p>
@@ -32222,7 +32145,21 @@
             </a:pPr>
             <a:r>
               <a:rPr lang="nl-NL" sz="2000" noProof="0" dirty="0"/>
-              <a:t>Welke indices nuttig zijn hangt af van het gebruik van de tabel.</a:t>
+              <a:t>Let </a:t>
+            </a:r>
+            <a:r>
+              <a:rPr lang="nl-NL" sz="2000" noProof="0"/>
+              <a:t>op:</a:t>
+            </a:r>
+          </a:p>
+          <a:p>
+            <a:pPr marL="0" indent="0">
+              <a:buFont typeface="Arial" panose="020B0604020202020204" pitchFamily="34" charset="0"/>
+              <a:buNone/>
+            </a:pPr>
+            <a:r>
+              <a:rPr lang="nl-NL" sz="2000" noProof="0" dirty="0"/>
+              <a:t>Query bepaalt of index gebruikt wordt of niet!</a:t>
             </a:r>
           </a:p>
           <a:p>
@@ -33877,6 +33814,79 @@
           </a:p>
         </p:txBody>
       </p:sp>
+      <p:sp>
+        <p:nvSpPr>
+          <p:cNvPr id="3" name="TextBox 2">
+            <a:extLst>
+              <a:ext uri="{FF2B5EF4-FFF2-40B4-BE49-F238E27FC236}">
+                <a16:creationId xmlns:a16="http://schemas.microsoft.com/office/drawing/2014/main" id="{745963E4-11DA-D263-ADE9-11B9DCCEF3B7}"/>
+              </a:ext>
+            </a:extLst>
+          </p:cNvPr>
+          <p:cNvSpPr txBox="1"/>
+          <p:nvPr/>
+        </p:nvSpPr>
+        <p:spPr>
+          <a:xfrm>
+            <a:off x="2543856" y="1690688"/>
+            <a:ext cx="882678" cy="369332"/>
+          </a:xfrm>
+          <a:prstGeom prst="rect">
+            <a:avLst/>
+          </a:prstGeom>
+          <a:noFill/>
+        </p:spPr>
+        <p:txBody>
+          <a:bodyPr wrap="none" rtlCol="0">
+            <a:spAutoFit/>
+          </a:bodyPr>
+          <a:lstStyle/>
+          <a:p>
+            <a:r>
+              <a:rPr lang="en-US" dirty="0" err="1"/>
+              <a:t>waarde</a:t>
+            </a:r>
+            <a:endParaRPr lang="en-US" dirty="0"/>
+          </a:p>
+        </p:txBody>
+      </p:sp>
+      <p:sp>
+        <p:nvSpPr>
+          <p:cNvPr id="4" name="TextBox 3">
+            <a:extLst>
+              <a:ext uri="{FF2B5EF4-FFF2-40B4-BE49-F238E27FC236}">
+                <a16:creationId xmlns:a16="http://schemas.microsoft.com/office/drawing/2014/main" id="{1440BCE6-27F3-0C5C-8B3C-07D9D53E9AF5}"/>
+              </a:ext>
+            </a:extLst>
+          </p:cNvPr>
+          <p:cNvSpPr txBox="1"/>
+          <p:nvPr/>
+        </p:nvSpPr>
+        <p:spPr>
+          <a:xfrm>
+            <a:off x="2543855" y="2010740"/>
+            <a:ext cx="882677" cy="369332"/>
+          </a:xfrm>
+          <a:prstGeom prst="rect">
+            <a:avLst/>
+          </a:prstGeom>
+          <a:noFill/>
+        </p:spPr>
+        <p:txBody>
+          <a:bodyPr wrap="square" rtlCol="0">
+            <a:spAutoFit/>
+          </a:bodyPr>
+          <a:lstStyle/>
+          <a:p>
+            <a:pPr algn="r"/>
+            <a:r>
+              <a:rPr lang="en-US" dirty="0" err="1"/>
+              <a:t>rij</a:t>
+            </a:r>
+            <a:endParaRPr lang="en-US" dirty="0"/>
+          </a:p>
+        </p:txBody>
+      </p:sp>
     </p:spTree>
     <p:extLst>
       <p:ext uri="{BB962C8B-B14F-4D97-AF65-F5344CB8AC3E}">
@@ -35094,8 +35104,8 @@
         </p:nvSpPr>
         <p:spPr>
           <a:xfrm>
-            <a:off x="2059877" y="4389075"/>
-            <a:ext cx="7651525" cy="1026988"/>
+            <a:off x="2468192" y="4389074"/>
+            <a:ext cx="7243210" cy="1908597"/>
           </a:xfrm>
           <a:prstGeom prst="rect">
             <a:avLst/>
@@ -35103,7 +35113,7 @@
         </p:spPr>
         <p:txBody>
           <a:bodyPr vert="horz" lIns="91440" tIns="45720" rIns="91440" bIns="45720" rtlCol="0">
-            <a:normAutofit fontScale="92500" lnSpcReduction="20000"/>
+            <a:normAutofit lnSpcReduction="10000"/>
           </a:bodyPr>
           <a:lstStyle>
             <a:lvl1pPr marL="228600" indent="-228600" algn="l" defTabSz="914400" rtl="0" eaLnBrk="1" latinLnBrk="0" hangingPunct="1">
@@ -35270,9 +35280,21 @@
             </a:lvl9pPr>
           </a:lstStyle>
           <a:p>
-            <a:pPr marL="0" indent="0" algn="ctr">
+            <a:pPr marL="0" indent="0">
               <a:buFont typeface="Arial" panose="020B0604020202020204" pitchFamily="34" charset="0"/>
               <a:buNone/>
+            </a:pPr>
+            <a:r>
+              <a:rPr lang="nl-NL" sz="2000" noProof="0" dirty="0">
+                <a:cs typeface="Courier New" panose="02070309020205020404" pitchFamily="49" charset="0"/>
+              </a:rPr>
+              <a:t>Met index:</a:t>
+            </a:r>
+          </a:p>
+          <a:p>
+            <a:pPr>
+              <a:buFontTx/>
+              <a:buChar char="-"/>
             </a:pPr>
             <a:r>
               <a:rPr lang="nl-NL" sz="2000" noProof="0" dirty="0">
@@ -35282,7 +35304,19 @@
             </a:r>
           </a:p>
           <a:p>
-            <a:pPr marL="0" indent="0" algn="ctr">
+            <a:pPr>
+              <a:buFontTx/>
+              <a:buChar char="-"/>
+            </a:pPr>
+            <a:r>
+              <a:rPr lang="nl-NL" sz="2000" noProof="0" dirty="0">
+                <a:cs typeface="Courier New" panose="02070309020205020404" pitchFamily="49" charset="0"/>
+              </a:rPr>
+              <a:t>Verzamel alleen de rijen uit de correcte groep.</a:t>
+            </a:r>
+          </a:p>
+          <a:p>
+            <a:pPr marL="0" indent="0">
               <a:buFont typeface="Arial" panose="020B0604020202020204" pitchFamily="34" charset="0"/>
               <a:buNone/>
             </a:pPr>
@@ -35291,7 +35325,7 @@
             </a:endParaRPr>
           </a:p>
           <a:p>
-            <a:pPr marL="0" indent="0" algn="ctr">
+            <a:pPr marL="0" indent="0">
               <a:buFont typeface="Arial" panose="020B0604020202020204" pitchFamily="34" charset="0"/>
               <a:buNone/>
             </a:pPr>
@@ -35299,7 +35333,7 @@
               <a:rPr lang="nl-NL" sz="2000" noProof="0" dirty="0">
                 <a:cs typeface="Courier New" panose="02070309020205020404" pitchFamily="49" charset="0"/>
               </a:rPr>
-              <a:t>Minder werk om te scannen...</a:t>
+              <a:t>Veel minder data in te lezen!</a:t>
             </a:r>
             <a:endParaRPr lang="nl-NL" sz="2000" noProof="0" dirty="0"/>
           </a:p>
@@ -35398,6 +35432,267 @@
           </a:p>
         </p:txBody>
       </p:sp>
+      <p:sp>
+        <p:nvSpPr>
+          <p:cNvPr id="7" name="TextBox 6">
+            <a:extLst>
+              <a:ext uri="{FF2B5EF4-FFF2-40B4-BE49-F238E27FC236}">
+                <a16:creationId xmlns:a16="http://schemas.microsoft.com/office/drawing/2014/main" id="{74387390-231E-0BD3-9D57-FA183679B1C8}"/>
+              </a:ext>
+            </a:extLst>
+          </p:cNvPr>
+          <p:cNvSpPr txBox="1"/>
+          <p:nvPr/>
+        </p:nvSpPr>
+        <p:spPr>
+          <a:xfrm>
+            <a:off x="2543856" y="1690688"/>
+            <a:ext cx="882678" cy="369332"/>
+          </a:xfrm>
+          <a:prstGeom prst="rect">
+            <a:avLst/>
+          </a:prstGeom>
+          <a:noFill/>
+        </p:spPr>
+        <p:txBody>
+          <a:bodyPr wrap="none" rtlCol="0">
+            <a:spAutoFit/>
+          </a:bodyPr>
+          <a:lstStyle/>
+          <a:p>
+            <a:r>
+              <a:rPr lang="en-US" dirty="0" err="1"/>
+              <a:t>waarde</a:t>
+            </a:r>
+            <a:endParaRPr lang="en-US" dirty="0"/>
+          </a:p>
+        </p:txBody>
+      </p:sp>
+      <p:sp>
+        <p:nvSpPr>
+          <p:cNvPr id="11" name="TextBox 10">
+            <a:extLst>
+              <a:ext uri="{FF2B5EF4-FFF2-40B4-BE49-F238E27FC236}">
+                <a16:creationId xmlns:a16="http://schemas.microsoft.com/office/drawing/2014/main" id="{8BC8108A-ADD9-E4F3-FF53-12049DD053B1}"/>
+              </a:ext>
+            </a:extLst>
+          </p:cNvPr>
+          <p:cNvSpPr txBox="1"/>
+          <p:nvPr/>
+        </p:nvSpPr>
+        <p:spPr>
+          <a:xfrm>
+            <a:off x="2543855" y="2010740"/>
+            <a:ext cx="882677" cy="369332"/>
+          </a:xfrm>
+          <a:prstGeom prst="rect">
+            <a:avLst/>
+          </a:prstGeom>
+          <a:noFill/>
+        </p:spPr>
+        <p:txBody>
+          <a:bodyPr wrap="square" rtlCol="0">
+            <a:spAutoFit/>
+          </a:bodyPr>
+          <a:lstStyle/>
+          <a:p>
+            <a:pPr algn="r"/>
+            <a:r>
+              <a:rPr lang="en-US" dirty="0" err="1"/>
+              <a:t>rij</a:t>
+            </a:r>
+            <a:endParaRPr lang="en-US" dirty="0"/>
+          </a:p>
+        </p:txBody>
+      </p:sp>
+      <p:sp>
+        <p:nvSpPr>
+          <p:cNvPr id="14" name="Rectangle 13">
+            <a:extLst>
+              <a:ext uri="{FF2B5EF4-FFF2-40B4-BE49-F238E27FC236}">
+                <a16:creationId xmlns:a16="http://schemas.microsoft.com/office/drawing/2014/main" id="{144638F9-76AB-D1BB-C295-CA50E73E7B9C}"/>
+              </a:ext>
+            </a:extLst>
+          </p:cNvPr>
+          <p:cNvSpPr/>
+          <p:nvPr/>
+        </p:nvSpPr>
+        <p:spPr>
+          <a:xfrm>
+            <a:off x="4322941" y="1732892"/>
+            <a:ext cx="593188" cy="647180"/>
+          </a:xfrm>
+          <a:prstGeom prst="rect">
+            <a:avLst/>
+          </a:prstGeom>
+          <a:noFill/>
+          <a:ln>
+            <a:solidFill>
+              <a:schemeClr val="accent2"/>
+            </a:solidFill>
+          </a:ln>
+        </p:spPr>
+        <p:style>
+          <a:lnRef idx="2">
+            <a:schemeClr val="accent1">
+              <a:shade val="15000"/>
+            </a:schemeClr>
+          </a:lnRef>
+          <a:fillRef idx="1">
+            <a:schemeClr val="accent1"/>
+          </a:fillRef>
+          <a:effectRef idx="0">
+            <a:schemeClr val="accent1"/>
+          </a:effectRef>
+          <a:fontRef idx="minor">
+            <a:schemeClr val="lt1"/>
+          </a:fontRef>
+        </p:style>
+        <p:txBody>
+          <a:bodyPr rtlCol="0" anchor="ctr"/>
+          <a:lstStyle/>
+          <a:p>
+            <a:pPr algn="ctr"/>
+            <a:endParaRPr lang="nl-NL" noProof="0" dirty="0"/>
+          </a:p>
+        </p:txBody>
+      </p:sp>
+      <p:sp>
+        <p:nvSpPr>
+          <p:cNvPr id="17" name="Rectangle 16">
+            <a:extLst>
+              <a:ext uri="{FF2B5EF4-FFF2-40B4-BE49-F238E27FC236}">
+                <a16:creationId xmlns:a16="http://schemas.microsoft.com/office/drawing/2014/main" id="{64C9D467-B1FD-6BC1-B5E1-1617912E941B}"/>
+              </a:ext>
+            </a:extLst>
+          </p:cNvPr>
+          <p:cNvSpPr/>
+          <p:nvPr/>
+        </p:nvSpPr>
+        <p:spPr>
+          <a:xfrm>
+            <a:off x="7873476" y="1732892"/>
+            <a:ext cx="593188" cy="647180"/>
+          </a:xfrm>
+          <a:prstGeom prst="rect">
+            <a:avLst/>
+          </a:prstGeom>
+          <a:noFill/>
+          <a:ln>
+            <a:solidFill>
+              <a:schemeClr val="accent2"/>
+            </a:solidFill>
+          </a:ln>
+        </p:spPr>
+        <p:style>
+          <a:lnRef idx="2">
+            <a:schemeClr val="accent1">
+              <a:shade val="15000"/>
+            </a:schemeClr>
+          </a:lnRef>
+          <a:fillRef idx="1">
+            <a:schemeClr val="accent1"/>
+          </a:fillRef>
+          <a:effectRef idx="0">
+            <a:schemeClr val="accent1"/>
+          </a:effectRef>
+          <a:fontRef idx="minor">
+            <a:schemeClr val="lt1"/>
+          </a:fontRef>
+        </p:style>
+        <p:txBody>
+          <a:bodyPr rtlCol="0" anchor="ctr"/>
+          <a:lstStyle/>
+          <a:p>
+            <a:pPr algn="ctr"/>
+            <a:endParaRPr lang="nl-NL" noProof="0" dirty="0"/>
+          </a:p>
+        </p:txBody>
+      </p:sp>
+      <p:cxnSp>
+        <p:nvCxnSpPr>
+          <p:cNvPr id="19" name="Connector: Elbow 18">
+            <a:extLst>
+              <a:ext uri="{FF2B5EF4-FFF2-40B4-BE49-F238E27FC236}">
+                <a16:creationId xmlns:a16="http://schemas.microsoft.com/office/drawing/2014/main" id="{F1A6EA45-F632-4290-6F94-AFECF75209E0}"/>
+              </a:ext>
+            </a:extLst>
+          </p:cNvPr>
+          <p:cNvCxnSpPr>
+            <a:stCxn id="16" idx="0"/>
+            <a:endCxn id="14" idx="2"/>
+          </p:cNvCxnSpPr>
+          <p:nvPr/>
+        </p:nvCxnSpPr>
+        <p:spPr>
+          <a:xfrm rot="16200000" flipV="1">
+            <a:off x="4461770" y="2537838"/>
+            <a:ext cx="693779" cy="378248"/>
+          </a:xfrm>
+          <a:prstGeom prst="bentConnector3">
+            <a:avLst/>
+          </a:prstGeom>
+          <a:ln>
+            <a:tailEnd type="triangle"/>
+          </a:ln>
+        </p:spPr>
+        <p:style>
+          <a:lnRef idx="2">
+            <a:schemeClr val="accent2"/>
+          </a:lnRef>
+          <a:fillRef idx="0">
+            <a:schemeClr val="accent2"/>
+          </a:fillRef>
+          <a:effectRef idx="1">
+            <a:schemeClr val="accent2"/>
+          </a:effectRef>
+          <a:fontRef idx="minor">
+            <a:schemeClr val="tx1"/>
+          </a:fontRef>
+        </p:style>
+      </p:cxnSp>
+      <p:cxnSp>
+        <p:nvCxnSpPr>
+          <p:cNvPr id="21" name="Connector: Elbow 20">
+            <a:extLst>
+              <a:ext uri="{FF2B5EF4-FFF2-40B4-BE49-F238E27FC236}">
+                <a16:creationId xmlns:a16="http://schemas.microsoft.com/office/drawing/2014/main" id="{9F39301A-1FBC-87F1-E9A3-8A2AE9103DFE}"/>
+              </a:ext>
+            </a:extLst>
+          </p:cNvPr>
+          <p:cNvCxnSpPr>
+            <a:stCxn id="16" idx="0"/>
+            <a:endCxn id="17" idx="2"/>
+          </p:cNvCxnSpPr>
+          <p:nvPr/>
+        </p:nvCxnSpPr>
+        <p:spPr>
+          <a:xfrm rot="5400000" flipH="1" flipV="1">
+            <a:off x="6237037" y="1140819"/>
+            <a:ext cx="693779" cy="3172287"/>
+          </a:xfrm>
+          <a:prstGeom prst="bentConnector3">
+            <a:avLst/>
+          </a:prstGeom>
+          <a:ln>
+            <a:tailEnd type="triangle"/>
+          </a:ln>
+        </p:spPr>
+        <p:style>
+          <a:lnRef idx="2">
+            <a:schemeClr val="accent2"/>
+          </a:lnRef>
+          <a:fillRef idx="0">
+            <a:schemeClr val="accent2"/>
+          </a:fillRef>
+          <a:effectRef idx="1">
+            <a:schemeClr val="accent2"/>
+          </a:effectRef>
+          <a:fontRef idx="minor">
+            <a:schemeClr val="tx1"/>
+          </a:fontRef>
+        </p:style>
+      </p:cxnSp>
     </p:spTree>
     <p:extLst>
       <p:ext uri="{BB962C8B-B14F-4D97-AF65-F5344CB8AC3E}">
@@ -37328,6 +37623,79 @@
           </a:graphicData>
         </a:graphic>
       </p:graphicFrame>
+      <p:sp>
+        <p:nvSpPr>
+          <p:cNvPr id="6" name="TextBox 5">
+            <a:extLst>
+              <a:ext uri="{FF2B5EF4-FFF2-40B4-BE49-F238E27FC236}">
+                <a16:creationId xmlns:a16="http://schemas.microsoft.com/office/drawing/2014/main" id="{802182A9-E62E-A725-7676-4EF980DAA30D}"/>
+              </a:ext>
+            </a:extLst>
+          </p:cNvPr>
+          <p:cNvSpPr txBox="1"/>
+          <p:nvPr/>
+        </p:nvSpPr>
+        <p:spPr>
+          <a:xfrm>
+            <a:off x="2543856" y="1690688"/>
+            <a:ext cx="882678" cy="369332"/>
+          </a:xfrm>
+          <a:prstGeom prst="rect">
+            <a:avLst/>
+          </a:prstGeom>
+          <a:noFill/>
+        </p:spPr>
+        <p:txBody>
+          <a:bodyPr wrap="none" rtlCol="0">
+            <a:spAutoFit/>
+          </a:bodyPr>
+          <a:lstStyle/>
+          <a:p>
+            <a:r>
+              <a:rPr lang="en-US" dirty="0" err="1"/>
+              <a:t>waarde</a:t>
+            </a:r>
+            <a:endParaRPr lang="en-US" dirty="0"/>
+          </a:p>
+        </p:txBody>
+      </p:sp>
+      <p:sp>
+        <p:nvSpPr>
+          <p:cNvPr id="7" name="TextBox 6">
+            <a:extLst>
+              <a:ext uri="{FF2B5EF4-FFF2-40B4-BE49-F238E27FC236}">
+                <a16:creationId xmlns:a16="http://schemas.microsoft.com/office/drawing/2014/main" id="{4B00E3B2-BBCD-D80F-CD36-53235EB43949}"/>
+              </a:ext>
+            </a:extLst>
+          </p:cNvPr>
+          <p:cNvSpPr txBox="1"/>
+          <p:nvPr/>
+        </p:nvSpPr>
+        <p:spPr>
+          <a:xfrm>
+            <a:off x="2543855" y="2010740"/>
+            <a:ext cx="882677" cy="369332"/>
+          </a:xfrm>
+          <a:prstGeom prst="rect">
+            <a:avLst/>
+          </a:prstGeom>
+          <a:noFill/>
+        </p:spPr>
+        <p:txBody>
+          <a:bodyPr wrap="square" rtlCol="0">
+            <a:spAutoFit/>
+          </a:bodyPr>
+          <a:lstStyle/>
+          <a:p>
+            <a:pPr algn="r"/>
+            <a:r>
+              <a:rPr lang="en-US" dirty="0" err="1"/>
+              <a:t>rij</a:t>
+            </a:r>
+            <a:endParaRPr lang="en-US" dirty="0"/>
+          </a:p>
+        </p:txBody>
+      </p:sp>
     </p:spTree>
     <p:extLst>
       <p:ext uri="{BB962C8B-B14F-4D97-AF65-F5344CB8AC3E}">
@@ -39796,7 +40164,7 @@
           <p:nvPr>
             <p:extLst>
               <p:ext uri="{D42A27DB-BD31-4B8C-83A1-F6EECF244321}">
-                <p14:modId xmlns:p14="http://schemas.microsoft.com/office/powerpoint/2010/main" val="3041615698"/>
+                <p14:modId xmlns:p14="http://schemas.microsoft.com/office/powerpoint/2010/main" val="2438666545"/>
               </p:ext>
             </p:extLst>
           </p:nvPr>
@@ -39901,7 +40269,7 @@
                     <a:p>
                       <a:r>
                         <a:rPr lang="nl-NL" noProof="0" dirty="0"/>
-                        <a:t>Een klant heeft één telefoonnummer.</a:t>
+                        <a:t>Een klant heeft één BSN.</a:t>
                       </a:r>
                     </a:p>
                     <a:p>
@@ -39910,7 +40278,7 @@
                     <a:p>
                       <a:r>
                         <a:rPr lang="nl-NL" noProof="0" dirty="0"/>
-                        <a:t>Een telefoonnummer hoort bij één klant.</a:t>
+                        <a:t>Een BSN hoort bij één klant.</a:t>
                       </a:r>
                     </a:p>
                   </a:txBody>
@@ -39923,7 +40291,13 @@
                     <a:p>
                       <a:r>
                         <a:rPr lang="nl-NL" noProof="0" dirty="0"/>
-                        <a:t>Kan in dezelfde tabel (</a:t>
+                        <a:t>Opnemen als attribuut in de tabel.</a:t>
+                      </a:r>
+                    </a:p>
+                    <a:p>
+                      <a:r>
+                        <a:rPr lang="nl-NL" noProof="0" dirty="0"/>
+                        <a:t>(</a:t>
                       </a:r>
                       <a:r>
                         <a:rPr lang="nl-NL" noProof="0" dirty="0">
@@ -39934,7 +40308,7 @@
                       </a:r>
                       <a:r>
                         <a:rPr lang="nl-NL" noProof="0" dirty="0"/>
-                        <a:t>).</a:t>
+                        <a:t>)</a:t>
                       </a:r>
                     </a:p>
                   </a:txBody>
@@ -39964,7 +40338,7 @@
 </file>
 
 <file path=ppt/slides/slide60.xml><?xml version="1.0" encoding="utf-8"?>
-<p:sld xmlns:a="http://schemas.openxmlformats.org/drawingml/2006/main" xmlns:r="http://schemas.openxmlformats.org/officeDocument/2006/relationships" xmlns:p="http://schemas.openxmlformats.org/presentationml/2006/main">
+<p:sld xmlns:a="http://schemas.openxmlformats.org/drawingml/2006/main" xmlns:r="http://schemas.openxmlformats.org/officeDocument/2006/relationships" xmlns:p="http://schemas.openxmlformats.org/presentationml/2006/main" show="0">
   <p:cSld>
     <p:spTree>
       <p:nvGrpSpPr>
@@ -40520,7 +40894,7 @@
           <p:nvPr>
             <p:extLst>
               <p:ext uri="{D42A27DB-BD31-4B8C-83A1-F6EECF244321}">
-                <p14:modId xmlns:p14="http://schemas.microsoft.com/office/powerpoint/2010/main" val="3744462594"/>
+                <p14:modId xmlns:p14="http://schemas.microsoft.com/office/powerpoint/2010/main" val="270708489"/>
               </p:ext>
             </p:extLst>
           </p:nvPr>
@@ -40625,7 +40999,7 @@
                     <a:p>
                       <a:r>
                         <a:rPr lang="nl-NL" noProof="0" dirty="0"/>
-                        <a:t>Een klant heeft één telefoonnummer.</a:t>
+                        <a:t>Een klant heeft één BSN.</a:t>
                       </a:r>
                     </a:p>
                     <a:p>
@@ -40634,7 +41008,7 @@
                     <a:p>
                       <a:r>
                         <a:rPr lang="nl-NL" noProof="0" dirty="0"/>
-                        <a:t>Een telefoonnummer hoort bij één klant.</a:t>
+                        <a:t>Een BSN hoort bij één klant.</a:t>
                       </a:r>
                     </a:p>
                   </a:txBody>
@@ -40647,7 +41021,13 @@
                     <a:p>
                       <a:r>
                         <a:rPr lang="nl-NL" noProof="0" dirty="0"/>
-                        <a:t>Kan in dezelfde tabel (</a:t>
+                        <a:t>Opnemen als attribuut in de tabel.</a:t>
+                      </a:r>
+                    </a:p>
+                    <a:p>
+                      <a:r>
+                        <a:rPr lang="nl-NL" noProof="0" dirty="0"/>
+                        <a:t>(</a:t>
                       </a:r>
                       <a:r>
                         <a:rPr lang="nl-NL" noProof="0" dirty="0">
@@ -40658,7 +41038,7 @@
                       </a:r>
                       <a:r>
                         <a:rPr lang="nl-NL" noProof="0" dirty="0"/>
-                        <a:t>).</a:t>
+                        <a:t>)</a:t>
                       </a:r>
                     </a:p>
                   </a:txBody>
@@ -40977,7 +41357,7 @@
           <p:nvPr>
             <p:extLst>
               <p:ext uri="{D42A27DB-BD31-4B8C-83A1-F6EECF244321}">
-                <p14:modId xmlns:p14="http://schemas.microsoft.com/office/powerpoint/2010/main" val="2040415428"/>
+                <p14:modId xmlns:p14="http://schemas.microsoft.com/office/powerpoint/2010/main" val="2078126496"/>
               </p:ext>
             </p:extLst>
           </p:nvPr>
@@ -41100,7 +41480,7 @@
                           <a:latin typeface="Courier New" panose="02070309020205020404" pitchFamily="49" charset="0"/>
                           <a:cs typeface="Courier New" panose="02070309020205020404" pitchFamily="49" charset="0"/>
                         </a:rPr>
-                        <a:t>CST0001</a:t>
+                        <a:t>CST0003</a:t>
                       </a:r>
                     </a:p>
                   </a:txBody>
@@ -41186,7 +41566,7 @@
                           <a:latin typeface="Courier New" panose="02070309020205020404" pitchFamily="49" charset="0"/>
                           <a:cs typeface="Courier New" panose="02070309020205020404" pitchFamily="49" charset="0"/>
                         </a:rPr>
-                        <a:t>CST0001</a:t>
+                        <a:t>CST0003</a:t>
                       </a:r>
                     </a:p>
                   </a:txBody>
@@ -41288,7 +41668,7 @@
                           <a:latin typeface="Courier New" panose="02070309020205020404" pitchFamily="49" charset="0"/>
                           <a:cs typeface="Courier New" panose="02070309020205020404" pitchFamily="49" charset="0"/>
                         </a:rPr>
-                        <a:t>CST0002</a:t>
+                        <a:t>CST0003</a:t>
                       </a:r>
                     </a:p>
                   </a:txBody>
@@ -41922,7 +42302,7 @@
           <p:nvPr>
             <p:extLst>
               <p:ext uri="{D42A27DB-BD31-4B8C-83A1-F6EECF244321}">
-                <p14:modId xmlns:p14="http://schemas.microsoft.com/office/powerpoint/2010/main" val="3313395057"/>
+                <p14:modId xmlns:p14="http://schemas.microsoft.com/office/powerpoint/2010/main" val="1341604374"/>
               </p:ext>
             </p:extLst>
           </p:nvPr>
@@ -42027,7 +42407,7 @@
                     <a:p>
                       <a:r>
                         <a:rPr lang="nl-NL" noProof="0" dirty="0"/>
-                        <a:t>Een klant heeft één telefoonnummer.</a:t>
+                        <a:t>Een klant heeft één BSN.</a:t>
                       </a:r>
                     </a:p>
                     <a:p>
@@ -42036,7 +42416,7 @@
                     <a:p>
                       <a:r>
                         <a:rPr lang="nl-NL" noProof="0" dirty="0"/>
-                        <a:t>Een telefoonnummer hoort bij één klant.</a:t>
+                        <a:t>Een BSN hoort bij één klant.</a:t>
                       </a:r>
                     </a:p>
                   </a:txBody>
@@ -42049,7 +42429,13 @@
                     <a:p>
                       <a:r>
                         <a:rPr lang="nl-NL" noProof="0" dirty="0"/>
-                        <a:t>Kan in dezelfde tabel (</a:t>
+                        <a:t>Opnemen als attribuut in de tabel.</a:t>
+                      </a:r>
+                    </a:p>
+                    <a:p>
+                      <a:r>
+                        <a:rPr lang="nl-NL" noProof="0" dirty="0"/>
+                        <a:t>(</a:t>
                       </a:r>
                       <a:r>
                         <a:rPr lang="nl-NL" noProof="0" dirty="0">
@@ -42060,7 +42446,7 @@
                       </a:r>
                       <a:r>
                         <a:rPr lang="nl-NL" noProof="0" dirty="0"/>
-                        <a:t>).</a:t>
+                        <a:t>)</a:t>
                       </a:r>
                     </a:p>
                   </a:txBody>

</xml_diff>

<commit_message>
Update SQL P2 database design
</commit_message>
<xml_diff>
--- a/sql_course_2p/2_database_design/2_database_design.pptx
+++ b/sql_course_2p/2_database_design/2_database_design.pptx
@@ -34,40 +34,40 @@
     <p:sldId id="266" r:id="rId25"/>
     <p:sldId id="316" r:id="rId26"/>
     <p:sldId id="396" r:id="rId27"/>
-    <p:sldId id="397" r:id="rId28"/>
-    <p:sldId id="357" r:id="rId29"/>
-    <p:sldId id="319" r:id="rId30"/>
-    <p:sldId id="323" r:id="rId31"/>
-    <p:sldId id="296" r:id="rId32"/>
-    <p:sldId id="335" r:id="rId33"/>
-    <p:sldId id="362" r:id="rId34"/>
-    <p:sldId id="337" r:id="rId35"/>
-    <p:sldId id="363" r:id="rId36"/>
-    <p:sldId id="364" r:id="rId37"/>
-    <p:sldId id="334" r:id="rId38"/>
-    <p:sldId id="365" r:id="rId39"/>
-    <p:sldId id="390" r:id="rId40"/>
-    <p:sldId id="366" r:id="rId41"/>
-    <p:sldId id="391" r:id="rId42"/>
-    <p:sldId id="393" r:id="rId43"/>
-    <p:sldId id="333" r:id="rId44"/>
-    <p:sldId id="392" r:id="rId45"/>
-    <p:sldId id="343" r:id="rId46"/>
-    <p:sldId id="377" r:id="rId47"/>
-    <p:sldId id="380" r:id="rId48"/>
-    <p:sldId id="378" r:id="rId49"/>
-    <p:sldId id="398" r:id="rId50"/>
-    <p:sldId id="394" r:id="rId51"/>
-    <p:sldId id="367" r:id="rId52"/>
-    <p:sldId id="372" r:id="rId53"/>
-    <p:sldId id="374" r:id="rId54"/>
-    <p:sldId id="373" r:id="rId55"/>
-    <p:sldId id="297" r:id="rId56"/>
-    <p:sldId id="376" r:id="rId57"/>
-    <p:sldId id="375" r:id="rId58"/>
-    <p:sldId id="341" r:id="rId59"/>
-    <p:sldId id="342" r:id="rId60"/>
-    <p:sldId id="322" r:id="rId61"/>
+    <p:sldId id="401" r:id="rId28"/>
+    <p:sldId id="397" r:id="rId29"/>
+    <p:sldId id="357" r:id="rId30"/>
+    <p:sldId id="319" r:id="rId31"/>
+    <p:sldId id="323" r:id="rId32"/>
+    <p:sldId id="296" r:id="rId33"/>
+    <p:sldId id="335" r:id="rId34"/>
+    <p:sldId id="362" r:id="rId35"/>
+    <p:sldId id="337" r:id="rId36"/>
+    <p:sldId id="363" r:id="rId37"/>
+    <p:sldId id="364" r:id="rId38"/>
+    <p:sldId id="334" r:id="rId39"/>
+    <p:sldId id="365" r:id="rId40"/>
+    <p:sldId id="390" r:id="rId41"/>
+    <p:sldId id="366" r:id="rId42"/>
+    <p:sldId id="391" r:id="rId43"/>
+    <p:sldId id="393" r:id="rId44"/>
+    <p:sldId id="333" r:id="rId45"/>
+    <p:sldId id="392" r:id="rId46"/>
+    <p:sldId id="343" r:id="rId47"/>
+    <p:sldId id="377" r:id="rId48"/>
+    <p:sldId id="380" r:id="rId49"/>
+    <p:sldId id="378" r:id="rId50"/>
+    <p:sldId id="398" r:id="rId51"/>
+    <p:sldId id="394" r:id="rId52"/>
+    <p:sldId id="367" r:id="rId53"/>
+    <p:sldId id="372" r:id="rId54"/>
+    <p:sldId id="374" r:id="rId55"/>
+    <p:sldId id="373" r:id="rId56"/>
+    <p:sldId id="297" r:id="rId57"/>
+    <p:sldId id="376" r:id="rId58"/>
+    <p:sldId id="375" r:id="rId59"/>
+    <p:sldId id="341" r:id="rId60"/>
+    <p:sldId id="342" r:id="rId61"/>
   </p:sldIdLst>
   <p:sldSz cx="12192000" cy="6858000"/>
   <p:notesSz cx="6858000" cy="9144000"/>
@@ -256,7 +256,7 @@
           <a:p>
             <a:fld id="{61CE90D0-176A-4BE5-B54F-392F0A16E3B3}" type="datetimeFigureOut">
               <a:rPr lang="en-NL" smtClean="0"/>
-              <a:t>14/09/2026</a:t>
+              <a:t>13/10/2026</a:t>
             </a:fld>
             <a:endParaRPr lang="en-NL"/>
           </a:p>
@@ -698,7 +698,7 @@
           <a:p>
             <a:fld id="{F847AAA1-0A2D-4E17-BD7E-ECD1F2F24FF1}" type="slidenum">
               <a:rPr lang="en-NL" smtClean="0"/>
-              <a:t>30</a:t>
+              <a:t>31</a:t>
             </a:fld>
             <a:endParaRPr lang="en-NL"/>
           </a:p>
@@ -782,7 +782,7 @@
           <a:p>
             <a:fld id="{F847AAA1-0A2D-4E17-BD7E-ECD1F2F24FF1}" type="slidenum">
               <a:rPr lang="en-NL" smtClean="0"/>
-              <a:t>31</a:t>
+              <a:t>32</a:t>
             </a:fld>
             <a:endParaRPr lang="en-NL"/>
           </a:p>
@@ -866,7 +866,7 @@
           <a:p>
             <a:fld id="{F847AAA1-0A2D-4E17-BD7E-ECD1F2F24FF1}" type="slidenum">
               <a:rPr lang="en-NL" smtClean="0"/>
-              <a:t>32</a:t>
+              <a:t>33</a:t>
             </a:fld>
             <a:endParaRPr lang="en-NL"/>
           </a:p>
@@ -974,7 +974,7 @@
           <a:p>
             <a:fld id="{F847AAA1-0A2D-4E17-BD7E-ECD1F2F24FF1}" type="slidenum">
               <a:rPr lang="en-NL" smtClean="0"/>
-              <a:t>33</a:t>
+              <a:t>34</a:t>
             </a:fld>
             <a:endParaRPr lang="en-NL"/>
           </a:p>
@@ -1066,7 +1066,7 @@
           <a:p>
             <a:fld id="{F847AAA1-0A2D-4E17-BD7E-ECD1F2F24FF1}" type="slidenum">
               <a:rPr lang="en-NL" smtClean="0"/>
-              <a:t>34</a:t>
+              <a:t>35</a:t>
             </a:fld>
             <a:endParaRPr lang="en-NL"/>
           </a:p>
@@ -1174,7 +1174,7 @@
           <a:p>
             <a:fld id="{F847AAA1-0A2D-4E17-BD7E-ECD1F2F24FF1}" type="slidenum">
               <a:rPr lang="en-NL" smtClean="0"/>
-              <a:t>35</a:t>
+              <a:t>36</a:t>
             </a:fld>
             <a:endParaRPr lang="en-NL"/>
           </a:p>
@@ -1282,7 +1282,7 @@
           <a:p>
             <a:fld id="{F847AAA1-0A2D-4E17-BD7E-ECD1F2F24FF1}" type="slidenum">
               <a:rPr lang="en-NL" smtClean="0"/>
-              <a:t>36</a:t>
+              <a:t>37</a:t>
             </a:fld>
             <a:endParaRPr lang="en-NL"/>
           </a:p>
@@ -1402,7 +1402,7 @@
           <a:p>
             <a:fld id="{F847AAA1-0A2D-4E17-BD7E-ECD1F2F24FF1}" type="slidenum">
               <a:rPr lang="en-NL" smtClean="0"/>
-              <a:t>37</a:t>
+              <a:t>38</a:t>
             </a:fld>
             <a:endParaRPr lang="en-NL"/>
           </a:p>
@@ -1510,7 +1510,7 @@
           <a:p>
             <a:fld id="{F847AAA1-0A2D-4E17-BD7E-ECD1F2F24FF1}" type="slidenum">
               <a:rPr lang="en-NL" smtClean="0"/>
-              <a:t>38</a:t>
+              <a:t>39</a:t>
             </a:fld>
             <a:endParaRPr lang="en-NL"/>
           </a:p>
@@ -1618,7 +1618,7 @@
           <a:p>
             <a:fld id="{F847AAA1-0A2D-4E17-BD7E-ECD1F2F24FF1}" type="slidenum">
               <a:rPr lang="en-NL" smtClean="0"/>
-              <a:t>39</a:t>
+              <a:t>40</a:t>
             </a:fld>
             <a:endParaRPr lang="en-NL"/>
           </a:p>
@@ -1810,7 +1810,7 @@
           <a:p>
             <a:fld id="{F847AAA1-0A2D-4E17-BD7E-ECD1F2F24FF1}" type="slidenum">
               <a:rPr lang="en-NL" smtClean="0"/>
-              <a:t>40</a:t>
+              <a:t>41</a:t>
             </a:fld>
             <a:endParaRPr lang="en-NL"/>
           </a:p>
@@ -1918,7 +1918,7 @@
           <a:p>
             <a:fld id="{F847AAA1-0A2D-4E17-BD7E-ECD1F2F24FF1}" type="slidenum">
               <a:rPr lang="en-NL" smtClean="0"/>
-              <a:t>41</a:t>
+              <a:t>42</a:t>
             </a:fld>
             <a:endParaRPr lang="en-NL"/>
           </a:p>
@@ -2026,7 +2026,7 @@
           <a:p>
             <a:fld id="{F847AAA1-0A2D-4E17-BD7E-ECD1F2F24FF1}" type="slidenum">
               <a:rPr lang="en-NL" smtClean="0"/>
-              <a:t>42</a:t>
+              <a:t>43</a:t>
             </a:fld>
             <a:endParaRPr lang="en-NL"/>
           </a:p>
@@ -2110,7 +2110,7 @@
           <a:p>
             <a:fld id="{F847AAA1-0A2D-4E17-BD7E-ECD1F2F24FF1}" type="slidenum">
               <a:rPr lang="en-NL" smtClean="0"/>
-              <a:t>43</a:t>
+              <a:t>44</a:t>
             </a:fld>
             <a:endParaRPr lang="en-NL"/>
           </a:p>
@@ -2218,7 +2218,7 @@
           <a:p>
             <a:fld id="{F847AAA1-0A2D-4E17-BD7E-ECD1F2F24FF1}" type="slidenum">
               <a:rPr lang="en-NL" smtClean="0"/>
-              <a:t>44</a:t>
+              <a:t>45</a:t>
             </a:fld>
             <a:endParaRPr lang="en-NL"/>
           </a:p>
@@ -2326,7 +2326,7 @@
           <a:p>
             <a:fld id="{F847AAA1-0A2D-4E17-BD7E-ECD1F2F24FF1}" type="slidenum">
               <a:rPr lang="en-NL" smtClean="0"/>
-              <a:t>51</a:t>
+              <a:t>52</a:t>
             </a:fld>
             <a:endParaRPr lang="en-NL"/>
           </a:p>
@@ -2434,7 +2434,7 @@
           <a:p>
             <a:fld id="{F847AAA1-0A2D-4E17-BD7E-ECD1F2F24FF1}" type="slidenum">
               <a:rPr lang="en-NL" smtClean="0"/>
-              <a:t>52</a:t>
+              <a:t>53</a:t>
             </a:fld>
             <a:endParaRPr lang="en-NL"/>
           </a:p>
@@ -2542,7 +2542,7 @@
           <a:p>
             <a:fld id="{F847AAA1-0A2D-4E17-BD7E-ECD1F2F24FF1}" type="slidenum">
               <a:rPr lang="en-NL" smtClean="0"/>
-              <a:t>53</a:t>
+              <a:t>54</a:t>
             </a:fld>
             <a:endParaRPr lang="en-NL"/>
           </a:p>
@@ -2650,7 +2650,7 @@
           <a:p>
             <a:fld id="{F847AAA1-0A2D-4E17-BD7E-ECD1F2F24FF1}" type="slidenum">
               <a:rPr lang="en-NL" smtClean="0"/>
-              <a:t>54</a:t>
+              <a:t>55</a:t>
             </a:fld>
             <a:endParaRPr lang="en-NL"/>
           </a:p>
@@ -2734,7 +2734,7 @@
           <a:p>
             <a:fld id="{F847AAA1-0A2D-4E17-BD7E-ECD1F2F24FF1}" type="slidenum">
               <a:rPr lang="en-NL" smtClean="0"/>
-              <a:t>55</a:t>
+              <a:t>56</a:t>
             </a:fld>
             <a:endParaRPr lang="en-NL"/>
           </a:p>
@@ -2950,7 +2950,7 @@
           <a:p>
             <a:fld id="{F847AAA1-0A2D-4E17-BD7E-ECD1F2F24FF1}" type="slidenum">
               <a:rPr lang="en-NL" smtClean="0"/>
-              <a:t>56</a:t>
+              <a:t>57</a:t>
             </a:fld>
             <a:endParaRPr lang="en-NL"/>
           </a:p>
@@ -3058,7 +3058,7 @@
           <a:p>
             <a:fld id="{F847AAA1-0A2D-4E17-BD7E-ECD1F2F24FF1}" type="slidenum">
               <a:rPr lang="en-NL" smtClean="0"/>
-              <a:t>57</a:t>
+              <a:t>58</a:t>
             </a:fld>
             <a:endParaRPr lang="en-NL"/>
           </a:p>
@@ -3142,7 +3142,7 @@
           <a:p>
             <a:fld id="{F847AAA1-0A2D-4E17-BD7E-ECD1F2F24FF1}" type="slidenum">
               <a:rPr lang="en-NL" smtClean="0"/>
-              <a:t>58</a:t>
+              <a:t>59</a:t>
             </a:fld>
             <a:endParaRPr lang="en-NL"/>
           </a:p>
@@ -3704,7 +3704,7 @@
           <a:p>
             <a:fld id="{F847AAA1-0A2D-4E17-BD7E-ECD1F2F24FF1}" type="slidenum">
               <a:rPr lang="en-NL" smtClean="0"/>
-              <a:t>29</a:t>
+              <a:t>30</a:t>
             </a:fld>
             <a:endParaRPr lang="en-NL"/>
           </a:p>
@@ -3872,7 +3872,7 @@
           <a:p>
             <a:fld id="{7B15CBDA-B49C-4B0F-9869-5B15867EA611}" type="datetimeFigureOut">
               <a:rPr lang="en-NL" smtClean="0"/>
-              <a:t>14/09/2026</a:t>
+              <a:t>13/10/2026</a:t>
             </a:fld>
             <a:endParaRPr lang="en-NL"/>
           </a:p>
@@ -4072,7 +4072,7 @@
           <a:p>
             <a:fld id="{7B15CBDA-B49C-4B0F-9869-5B15867EA611}" type="datetimeFigureOut">
               <a:rPr lang="en-NL" smtClean="0"/>
-              <a:t>14/09/2026</a:t>
+              <a:t>13/10/2026</a:t>
             </a:fld>
             <a:endParaRPr lang="en-NL"/>
           </a:p>
@@ -4282,7 +4282,7 @@
           <a:p>
             <a:fld id="{7B15CBDA-B49C-4B0F-9869-5B15867EA611}" type="datetimeFigureOut">
               <a:rPr lang="en-NL" smtClean="0"/>
-              <a:t>14/09/2026</a:t>
+              <a:t>13/10/2026</a:t>
             </a:fld>
             <a:endParaRPr lang="en-NL"/>
           </a:p>
@@ -4482,7 +4482,7 @@
           <a:p>
             <a:fld id="{7B15CBDA-B49C-4B0F-9869-5B15867EA611}" type="datetimeFigureOut">
               <a:rPr lang="en-NL" smtClean="0"/>
-              <a:t>14/09/2026</a:t>
+              <a:t>13/10/2026</a:t>
             </a:fld>
             <a:endParaRPr lang="en-NL"/>
           </a:p>
@@ -4758,7 +4758,7 @@
           <a:p>
             <a:fld id="{7B15CBDA-B49C-4B0F-9869-5B15867EA611}" type="datetimeFigureOut">
               <a:rPr lang="en-NL" smtClean="0"/>
-              <a:t>14/09/2026</a:t>
+              <a:t>13/10/2026</a:t>
             </a:fld>
             <a:endParaRPr lang="en-NL"/>
           </a:p>
@@ -5026,7 +5026,7 @@
           <a:p>
             <a:fld id="{7B15CBDA-B49C-4B0F-9869-5B15867EA611}" type="datetimeFigureOut">
               <a:rPr lang="en-NL" smtClean="0"/>
-              <a:t>14/09/2026</a:t>
+              <a:t>13/10/2026</a:t>
             </a:fld>
             <a:endParaRPr lang="en-NL"/>
           </a:p>
@@ -5441,7 +5441,7 @@
           <a:p>
             <a:fld id="{7B15CBDA-B49C-4B0F-9869-5B15867EA611}" type="datetimeFigureOut">
               <a:rPr lang="en-NL" smtClean="0"/>
-              <a:t>14/09/2026</a:t>
+              <a:t>13/10/2026</a:t>
             </a:fld>
             <a:endParaRPr lang="en-NL"/>
           </a:p>
@@ -5583,7 +5583,7 @@
           <a:p>
             <a:fld id="{7B15CBDA-B49C-4B0F-9869-5B15867EA611}" type="datetimeFigureOut">
               <a:rPr lang="en-NL" smtClean="0"/>
-              <a:t>14/09/2026</a:t>
+              <a:t>13/10/2026</a:t>
             </a:fld>
             <a:endParaRPr lang="en-NL"/>
           </a:p>
@@ -5696,7 +5696,7 @@
           <a:p>
             <a:fld id="{7B15CBDA-B49C-4B0F-9869-5B15867EA611}" type="datetimeFigureOut">
               <a:rPr lang="en-NL" smtClean="0"/>
-              <a:t>14/09/2026</a:t>
+              <a:t>13/10/2026</a:t>
             </a:fld>
             <a:endParaRPr lang="en-NL"/>
           </a:p>
@@ -6009,7 +6009,7 @@
           <a:p>
             <a:fld id="{7B15CBDA-B49C-4B0F-9869-5B15867EA611}" type="datetimeFigureOut">
               <a:rPr lang="en-NL" smtClean="0"/>
-              <a:t>14/09/2026</a:t>
+              <a:t>13/10/2026</a:t>
             </a:fld>
             <a:endParaRPr lang="en-NL"/>
           </a:p>
@@ -6298,7 +6298,7 @@
           <a:p>
             <a:fld id="{7B15CBDA-B49C-4B0F-9869-5B15867EA611}" type="datetimeFigureOut">
               <a:rPr lang="en-NL" smtClean="0"/>
-              <a:t>14/09/2026</a:t>
+              <a:t>13/10/2026</a:t>
             </a:fld>
             <a:endParaRPr lang="en-NL"/>
           </a:p>
@@ -6541,7 +6541,7 @@
           <a:p>
             <a:fld id="{7B15CBDA-B49C-4B0F-9869-5B15867EA611}" type="datetimeFigureOut">
               <a:rPr lang="en-NL" smtClean="0"/>
-              <a:t>14/09/2026</a:t>
+              <a:t>13/10/2026</a:t>
             </a:fld>
             <a:endParaRPr lang="en-NL"/>
           </a:p>
@@ -9081,7 +9081,7 @@
             </a:pPr>
             <a:r>
               <a:rPr lang="nl-NL" sz="2000" noProof="0" dirty="0"/>
-              <a:t>Elke cel bevat één enkele waarde.</a:t>
+              <a:t>Elke cel bevat één waarde.</a:t>
             </a:r>
           </a:p>
           <a:p>
@@ -15773,7 +15773,7 @@
             </a:pPr>
             <a:r>
               <a:rPr lang="nl-NL" sz="2000" noProof="0" dirty="0"/>
-              <a:t>Tabellen en relaties in SQL.</a:t>
+              <a:t>Syntax tabellen en relaties aanmaken.</a:t>
             </a:r>
           </a:p>
           <a:p>
@@ -16210,7 +16210,7 @@
             <a:pPr lvl="1"/>
             <a:r>
               <a:rPr lang="nl-NL" sz="2000" noProof="0" dirty="0"/>
-              <a:t>Relatie transacties en producten:	veel op veel... maar één op veel per transactieregel.</a:t>
+              <a:t>Relatie transacties en producten:	veel op veel... maar één op veel per regel.</a:t>
             </a:r>
           </a:p>
           <a:p>
@@ -16694,9 +16694,9 @@
         <p:grpSpPr>
           <a:xfrm>
             <a:off x="838200" y="3750063"/>
-            <a:ext cx="6102998" cy="400110"/>
+            <a:ext cx="4943962" cy="400110"/>
             <a:chOff x="838200" y="3796152"/>
-            <a:chExt cx="6102998" cy="400110"/>
+            <a:chExt cx="4943962" cy="400110"/>
           </a:xfrm>
         </p:grpSpPr>
         <p:grpSp>
@@ -16811,7 +16811,7 @@
           <p:spPr>
             <a:xfrm>
               <a:off x="3000054" y="3796152"/>
-              <a:ext cx="3941144" cy="400110"/>
+              <a:ext cx="2782108" cy="400110"/>
             </a:xfrm>
             <a:prstGeom prst="rect">
               <a:avLst/>
@@ -16826,7 +16826,7 @@
             <a:p>
               <a:r>
                 <a:rPr lang="nl-NL" sz="2000" noProof="0" dirty="0"/>
-                <a:t>Koppelt precies 1 record in de tabel.</a:t>
+                <a:t>Koppelt precies 1 record.</a:t>
               </a:r>
             </a:p>
           </p:txBody>
@@ -16847,9 +16847,9 @@
         <p:grpSpPr>
           <a:xfrm>
             <a:off x="838200" y="5488374"/>
-            <a:ext cx="6587296" cy="400110"/>
+            <a:ext cx="5300021" cy="400110"/>
             <a:chOff x="838200" y="5488374"/>
-            <a:chExt cx="6587296" cy="400110"/>
+            <a:chExt cx="5300021" cy="400110"/>
           </a:xfrm>
         </p:grpSpPr>
         <p:grpSp>
@@ -17000,7 +17000,7 @@
           <p:spPr>
             <a:xfrm>
               <a:off x="3000054" y="5488374"/>
-              <a:ext cx="4425442" cy="400110"/>
+              <a:ext cx="3138167" cy="400110"/>
             </a:xfrm>
             <a:prstGeom prst="rect">
               <a:avLst/>
@@ -17015,7 +17015,7 @@
             <a:p>
               <a:r>
                 <a:rPr lang="nl-NL" sz="2000" noProof="0" dirty="0"/>
-                <a:t>Koppelt meer dan 1 records in een tabel.</a:t>
+                <a:t>Koppelt meer dan 1 records.</a:t>
               </a:r>
             </a:p>
           </p:txBody>
@@ -17036,9 +17036,9 @@
         <p:grpSpPr>
           <a:xfrm>
             <a:off x="838201" y="2011753"/>
-            <a:ext cx="5986171" cy="400110"/>
+            <a:ext cx="4698895" cy="400110"/>
             <a:chOff x="838201" y="2011753"/>
-            <a:chExt cx="5986171" cy="400110"/>
+            <a:chExt cx="4698895" cy="400110"/>
           </a:xfrm>
         </p:grpSpPr>
         <p:grpSp>
@@ -17201,7 +17201,7 @@
           <p:spPr>
             <a:xfrm>
               <a:off x="3000055" y="2011753"/>
-              <a:ext cx="3824317" cy="400110"/>
+              <a:ext cx="2537041" cy="400110"/>
             </a:xfrm>
             <a:prstGeom prst="rect">
               <a:avLst/>
@@ -17216,7 +17216,7 @@
             <a:p>
               <a:r>
                 <a:rPr lang="nl-NL" sz="2000" noProof="0" dirty="0"/>
-                <a:t>Koppelt 0 of 1 records in een tabel.</a:t>
+                <a:t>Koppelt 0 of 1 records.</a:t>
               </a:r>
             </a:p>
           </p:txBody>
@@ -17237,9 +17237,9 @@
         <p:grpSpPr>
           <a:xfrm>
             <a:off x="838201" y="2880908"/>
-            <a:ext cx="6407759" cy="400110"/>
+            <a:ext cx="5120483" cy="400110"/>
             <a:chOff x="838201" y="2895535"/>
-            <a:chExt cx="6407759" cy="400110"/>
+            <a:chExt cx="5120483" cy="400110"/>
           </a:xfrm>
         </p:grpSpPr>
         <p:grpSp>
@@ -17459,7 +17459,7 @@
           <p:spPr>
             <a:xfrm>
               <a:off x="3000054" y="2895535"/>
-              <a:ext cx="4245906" cy="400110"/>
+              <a:ext cx="2958630" cy="400110"/>
             </a:xfrm>
             <a:prstGeom prst="rect">
               <a:avLst/>
@@ -17474,7 +17474,7 @@
             <a:p>
               <a:r>
                 <a:rPr lang="nl-NL" sz="2000" noProof="0" dirty="0"/>
-                <a:t>Koppelt 0 of meer records in een tabel.</a:t>
+                <a:t>Koppelt 0 of meer records.</a:t>
               </a:r>
             </a:p>
           </p:txBody>
@@ -17495,9 +17495,9 @@
         <p:grpSpPr>
           <a:xfrm>
             <a:off x="838200" y="4619218"/>
-            <a:ext cx="6407760" cy="400110"/>
+            <a:ext cx="5120484" cy="400110"/>
             <a:chOff x="838200" y="4587532"/>
-            <a:chExt cx="6407760" cy="400110"/>
+            <a:chExt cx="5120484" cy="400110"/>
           </a:xfrm>
         </p:grpSpPr>
         <p:grpSp>
@@ -17684,7 +17684,7 @@
           <p:spPr>
             <a:xfrm>
               <a:off x="3000054" y="4587532"/>
-              <a:ext cx="4245906" cy="400110"/>
+              <a:ext cx="2958630" cy="400110"/>
             </a:xfrm>
             <a:prstGeom prst="rect">
               <a:avLst/>
@@ -17699,7 +17699,7 @@
             <a:p>
               <a:r>
                 <a:rPr lang="nl-NL" sz="2000" noProof="0" dirty="0"/>
-                <a:t>Koppelt 1 of meer records in een tabel.</a:t>
+                <a:t>Koppelt 1 of meer records.</a:t>
               </a:r>
             </a:p>
           </p:txBody>
@@ -17789,7 +17789,7 @@
         </p:spPr>
         <p:txBody>
           <a:bodyPr>
-            <a:normAutofit fontScale="92500" lnSpcReduction="10000"/>
+            <a:normAutofit/>
           </a:bodyPr>
           <a:lstStyle/>
           <a:p>
@@ -17798,7 +17798,7 @@
             </a:pPr>
             <a:r>
               <a:rPr lang="nl-NL" sz="2000" noProof="0" dirty="0"/>
-              <a:t>Een sportclub vraagt je om de database voor hun ledenadministratie op te zetten.</a:t>
+              <a:t>Een sportclub vraagt je om hun database te ontwerpen.</a:t>
             </a:r>
           </a:p>
           <a:p>
@@ -17822,8 +17822,8 @@
               <a:buChar char="-"/>
             </a:pPr>
             <a:r>
-              <a:rPr lang="nl-NL" sz="2000" noProof="0" dirty="0"/>
-              <a:t>De leden betalen contributie, waarvan de hoogte jaarlijks wordt vastgesteld.</a:t>
+              <a:rPr lang="nl-NL" sz="2000" dirty="0"/>
+              <a:t>Leden spelen in een categorie; beginner, ervaren en expert.</a:t>
             </a:r>
           </a:p>
           <a:p>
@@ -17833,7 +17833,7 @@
             </a:pPr>
             <a:r>
               <a:rPr lang="nl-NL" sz="2000" noProof="0" dirty="0"/>
-              <a:t>De status van de betalingen wordt bijgehouden inclusief herinneringen.</a:t>
+              <a:t>De club organiseert toernooien waarop leden zich kunnen inschrijven.</a:t>
             </a:r>
           </a:p>
           <a:p>
@@ -17843,7 +17843,7 @@
             </a:pPr>
             <a:r>
               <a:rPr lang="nl-NL" sz="2000" noProof="0" dirty="0"/>
-              <a:t>De club organiseert 2 toernooien per jaar waarop leden intekenen.</a:t>
+              <a:t>Voor elke toernooi inschrijving betaalt het lid inschrijfgeld.</a:t>
             </a:r>
           </a:p>
           <a:p>
@@ -17852,8 +17852,8 @@
               <a:buChar char="-"/>
             </a:pPr>
             <a:r>
-              <a:rPr lang="nl-NL" sz="2000" noProof="0" dirty="0"/>
-              <a:t>De uitslag van het toernooi wordt voor iedere speler vastgelegd.</a:t>
+              <a:rPr lang="nl-NL" sz="2000" dirty="0"/>
+              <a:t>Naast toernooien betalen de leden ook een jaarlijks contributie.</a:t>
             </a:r>
           </a:p>
           <a:p>
@@ -17862,28 +17862,8 @@
               <a:buChar char="-"/>
             </a:pPr>
             <a:r>
-              <a:rPr lang="nl-NL" sz="2000" noProof="0" dirty="0"/>
-              <a:t>Elk toernooi heeft een vast bedrag als inschrijfgeld.</a:t>
-            </a:r>
-          </a:p>
-          <a:p>
-            <a:pPr>
-              <a:buFontTx/>
-              <a:buChar char="-"/>
-            </a:pPr>
-            <a:r>
-              <a:rPr lang="nl-NL" sz="2000" noProof="0" dirty="0"/>
-              <a:t>Het inschrijfgeld wordt op dezelfde wijze betaald als de contributie.</a:t>
-            </a:r>
-          </a:p>
-          <a:p>
-            <a:pPr>
-              <a:buFontTx/>
-              <a:buChar char="-"/>
-            </a:pPr>
-            <a:r>
-              <a:rPr lang="nl-NL" sz="2000" noProof="0" dirty="0"/>
-              <a:t>Leden spelen in één van de categorieën; beginner, ervaren en expert.</a:t>
+              <a:rPr lang="nl-NL" sz="2000" dirty="0"/>
+              <a:t>De status van betalingen wordt vastgelegd; open, herinnering 1 - 3, betaald.</a:t>
             </a:r>
           </a:p>
           <a:p>
@@ -17999,8 +17979,8 @@
         </p:nvSpPr>
         <p:spPr>
           <a:xfrm>
-            <a:off x="838200" y="1825625"/>
-            <a:ext cx="4887352" cy="4351338"/>
+            <a:off x="838199" y="1825625"/>
+            <a:ext cx="3658173" cy="4351338"/>
           </a:xfrm>
         </p:spPr>
         <p:txBody>
@@ -18030,7 +18010,7 @@
             </a:pPr>
             <a:r>
               <a:rPr lang="nl-NL" sz="2000" noProof="0" dirty="0"/>
-              <a:t>Leden.</a:t>
+              <a:t>Leden</a:t>
             </a:r>
           </a:p>
           <a:p>
@@ -18039,8 +18019,8 @@
               <a:buChar char="-"/>
             </a:pPr>
             <a:r>
-              <a:rPr lang="nl-NL" sz="2000" noProof="0" dirty="0"/>
-              <a:t>Contributie.</a:t>
+              <a:rPr lang="nl-NL" sz="2000" dirty="0"/>
+              <a:t>Speler categorie</a:t>
             </a:r>
           </a:p>
           <a:p>
@@ -18050,7 +18030,7 @@
             </a:pPr>
             <a:r>
               <a:rPr lang="nl-NL" sz="2000" noProof="0" dirty="0"/>
-              <a:t>Toernooien.</a:t>
+              <a:t>Toernooien</a:t>
             </a:r>
           </a:p>
           <a:p>
@@ -18059,8 +18039,8 @@
               <a:buChar char="-"/>
             </a:pPr>
             <a:r>
-              <a:rPr lang="nl-NL" sz="2000" noProof="0" dirty="0"/>
-              <a:t>Speler categorie.</a:t>
+              <a:rPr lang="nl-NL" sz="2000" dirty="0"/>
+              <a:t>Toernooi inschrijvingen</a:t>
             </a:r>
           </a:p>
           <a:p>
@@ -18070,7 +18050,7 @@
             </a:pPr>
             <a:r>
               <a:rPr lang="nl-NL" sz="2000" noProof="0" dirty="0"/>
-              <a:t>Betalingen.</a:t>
+              <a:t>Betaalstatus: Inschrijving</a:t>
             </a:r>
           </a:p>
           <a:p>
@@ -18079,14 +18059,208 @@
               <a:buChar char="-"/>
             </a:pPr>
             <a:r>
+              <a:rPr lang="nl-NL" sz="2000" dirty="0"/>
+              <a:t>Contributies</a:t>
+            </a:r>
+          </a:p>
+          <a:p>
+            <a:pPr>
+              <a:buFontTx/>
+              <a:buChar char="-"/>
+            </a:pPr>
+            <a:r>
               <a:rPr lang="nl-NL" sz="2000" noProof="0" dirty="0"/>
-              <a:t>Status betaling.</a:t>
-            </a:r>
-          </a:p>
-          <a:p>
-            <a:pPr marL="457200" indent="-457200">
-              <a:buAutoNum type="arabicPeriod"/>
-            </a:pPr>
+              <a:t>Betaalstatus: </a:t>
+            </a:r>
+            <a:r>
+              <a:rPr lang="nl-NL" sz="2000" dirty="0"/>
+              <a:t>Contributie</a:t>
+            </a:r>
+            <a:endParaRPr lang="nl-NL" sz="2000" noProof="0" dirty="0"/>
+          </a:p>
+        </p:txBody>
+      </p:sp>
+    </p:spTree>
+    <p:extLst>
+      <p:ext uri="{BB962C8B-B14F-4D97-AF65-F5344CB8AC3E}">
+        <p14:creationId xmlns:p14="http://schemas.microsoft.com/office/powerpoint/2010/main" val="1597186539"/>
+      </p:ext>
+    </p:extLst>
+  </p:cSld>
+  <p:clrMapOvr>
+    <a:masterClrMapping/>
+  </p:clrMapOvr>
+</p:sld>
+</file>
+
+<file path=ppt/slides/slide27.xml><?xml version="1.0" encoding="utf-8"?>
+<p:sld xmlns:a="http://schemas.openxmlformats.org/drawingml/2006/main" xmlns:r="http://schemas.openxmlformats.org/officeDocument/2006/relationships" xmlns:p="http://schemas.openxmlformats.org/presentationml/2006/main">
+  <p:cSld>
+    <p:spTree>
+      <p:nvGrpSpPr>
+        <p:cNvPr id="1" name="">
+          <a:extLst>
+            <a:ext uri="{FF2B5EF4-FFF2-40B4-BE49-F238E27FC236}">
+              <a16:creationId xmlns:a16="http://schemas.microsoft.com/office/drawing/2014/main" id="{9B44B139-4C31-6C5A-A13E-D42F10877D1B}"/>
+            </a:ext>
+          </a:extLst>
+        </p:cNvPr>
+        <p:cNvGrpSpPr/>
+        <p:nvPr/>
+      </p:nvGrpSpPr>
+      <p:grpSpPr>
+        <a:xfrm>
+          <a:off x="0" y="0"/>
+          <a:ext cx="0" cy="0"/>
+          <a:chOff x="0" y="0"/>
+          <a:chExt cx="0" cy="0"/>
+        </a:xfrm>
+      </p:grpSpPr>
+      <p:sp>
+        <p:nvSpPr>
+          <p:cNvPr id="2" name="Title 1">
+            <a:extLst>
+              <a:ext uri="{FF2B5EF4-FFF2-40B4-BE49-F238E27FC236}">
+                <a16:creationId xmlns:a16="http://schemas.microsoft.com/office/drawing/2014/main" id="{575C888E-4C1E-FC04-CB9E-0A98BEB328F8}"/>
+              </a:ext>
+            </a:extLst>
+          </p:cNvPr>
+          <p:cNvSpPr>
+            <a:spLocks noGrp="1"/>
+          </p:cNvSpPr>
+          <p:nvPr>
+            <p:ph type="title"/>
+          </p:nvPr>
+        </p:nvSpPr>
+        <p:spPr/>
+        <p:txBody>
+          <a:bodyPr>
+            <a:normAutofit/>
+          </a:bodyPr>
+          <a:lstStyle/>
+          <a:p>
+            <a:r>
+              <a:rPr lang="nl-NL" sz="3600" noProof="0" dirty="0"/>
+              <a:t>Oefeningen 2</a:t>
+            </a:r>
+          </a:p>
+        </p:txBody>
+      </p:sp>
+      <p:sp>
+        <p:nvSpPr>
+          <p:cNvPr id="3" name="Content Placeholder 2">
+            <a:extLst>
+              <a:ext uri="{FF2B5EF4-FFF2-40B4-BE49-F238E27FC236}">
+                <a16:creationId xmlns:a16="http://schemas.microsoft.com/office/drawing/2014/main" id="{26B960F8-DD7E-03E7-D6EA-51D3F9AC5F51}"/>
+              </a:ext>
+            </a:extLst>
+          </p:cNvPr>
+          <p:cNvSpPr>
+            <a:spLocks noGrp="1"/>
+          </p:cNvSpPr>
+          <p:nvPr>
+            <p:ph idx="1"/>
+          </p:nvPr>
+        </p:nvSpPr>
+        <p:spPr>
+          <a:xfrm>
+            <a:off x="838199" y="1825625"/>
+            <a:ext cx="3658173" cy="4351338"/>
+          </a:xfrm>
+        </p:spPr>
+        <p:txBody>
+          <a:bodyPr>
+            <a:normAutofit/>
+          </a:bodyPr>
+          <a:lstStyle/>
+          <a:p>
+            <a:pPr marL="0" indent="0">
+              <a:buNone/>
+            </a:pPr>
+            <a:r>
+              <a:rPr lang="nl-NL" sz="2000" noProof="0" dirty="0"/>
+              <a:t>Entiteiten:</a:t>
+            </a:r>
+          </a:p>
+          <a:p>
+            <a:pPr marL="0" indent="0">
+              <a:buNone/>
+            </a:pPr>
+            <a:endParaRPr lang="nl-NL" sz="2000" noProof="0" dirty="0"/>
+          </a:p>
+          <a:p>
+            <a:pPr>
+              <a:buFontTx/>
+              <a:buChar char="-"/>
+            </a:pPr>
+            <a:r>
+              <a:rPr lang="nl-NL" sz="2000" noProof="0" dirty="0"/>
+              <a:t>Leden</a:t>
+            </a:r>
+          </a:p>
+          <a:p>
+            <a:pPr>
+              <a:buFontTx/>
+              <a:buChar char="-"/>
+            </a:pPr>
+            <a:r>
+              <a:rPr lang="nl-NL" sz="2000" dirty="0"/>
+              <a:t>Speler categorie</a:t>
+            </a:r>
+          </a:p>
+          <a:p>
+            <a:pPr>
+              <a:buFontTx/>
+              <a:buChar char="-"/>
+            </a:pPr>
+            <a:r>
+              <a:rPr lang="nl-NL" sz="2000" noProof="0" dirty="0"/>
+              <a:t>Toernooien</a:t>
+            </a:r>
+          </a:p>
+          <a:p>
+            <a:pPr>
+              <a:buFontTx/>
+              <a:buChar char="-"/>
+            </a:pPr>
+            <a:r>
+              <a:rPr lang="nl-NL" sz="2000" dirty="0"/>
+              <a:t>Toernooi inschrijvingen</a:t>
+            </a:r>
+          </a:p>
+          <a:p>
+            <a:pPr>
+              <a:buFontTx/>
+              <a:buChar char="-"/>
+            </a:pPr>
+            <a:r>
+              <a:rPr lang="nl-NL" sz="2000" noProof="0" dirty="0"/>
+              <a:t>Betaalstatus: Inschrijving</a:t>
+            </a:r>
+          </a:p>
+          <a:p>
+            <a:pPr>
+              <a:buFontTx/>
+              <a:buChar char="-"/>
+            </a:pPr>
+            <a:r>
+              <a:rPr lang="nl-NL" sz="2000" dirty="0"/>
+              <a:t>Contributies</a:t>
+            </a:r>
+          </a:p>
+          <a:p>
+            <a:pPr>
+              <a:buFontTx/>
+              <a:buChar char="-"/>
+            </a:pPr>
+            <a:r>
+              <a:rPr lang="nl-NL" sz="2000" noProof="0" dirty="0"/>
+              <a:t>Betaalstatus: </a:t>
+            </a:r>
+            <a:r>
+              <a:rPr lang="nl-NL" sz="2000" dirty="0"/>
+              <a:t>Contributie</a:t>
+            </a:r>
             <a:endParaRPr lang="nl-NL" sz="2000" noProof="0" dirty="0"/>
           </a:p>
         </p:txBody>
@@ -18096,7 +18270,7 @@
           <p:cNvPr id="4" name="Content Placeholder 2">
             <a:extLst>
               <a:ext uri="{FF2B5EF4-FFF2-40B4-BE49-F238E27FC236}">
-                <a16:creationId xmlns:a16="http://schemas.microsoft.com/office/drawing/2014/main" id="{80C09D4A-C8D5-B213-ABBF-1F5566D650BD}"/>
+                <a16:creationId xmlns:a16="http://schemas.microsoft.com/office/drawing/2014/main" id="{6C2D687D-468A-B1C4-F94C-2F63C893877C}"/>
               </a:ext>
             </a:extLst>
           </p:cNvPr>
@@ -18107,8 +18281,8 @@
         </p:nvSpPr>
         <p:spPr>
           <a:xfrm>
-            <a:off x="7138182" y="1825625"/>
-            <a:ext cx="4887352" cy="4351338"/>
+            <a:off x="5725550" y="1825625"/>
+            <a:ext cx="5907265" cy="4351338"/>
           </a:xfrm>
           <a:prstGeom prst="rect">
             <a:avLst/>
@@ -18305,16 +18479,8 @@
               <a:buChar char="-"/>
             </a:pPr>
             <a:r>
-              <a:rPr lang="nl-NL" sz="2000" noProof="0" dirty="0"/>
-              <a:t>Leden    =&gt;    Toernooi (</a:t>
-            </a:r>
-            <a:r>
-              <a:rPr lang="nl-NL" sz="2000" noProof="0" dirty="0" err="1"/>
-              <a:t>m:m</a:t>
-            </a:r>
-            <a:r>
-              <a:rPr lang="nl-NL" sz="2000" noProof="0" dirty="0"/>
-              <a:t>).</a:t>
+              <a:rPr lang="nl-NL" sz="2000" dirty="0"/>
+              <a:t>Leden    =&gt;    Speler categorie 		           n:1</a:t>
             </a:r>
           </a:p>
           <a:p>
@@ -18324,7 +18490,7 @@
             </a:pPr>
             <a:r>
               <a:rPr lang="nl-NL" sz="2000" noProof="0" dirty="0"/>
-              <a:t>Leden    =&gt;    Speler categorie (1:m).</a:t>
+              <a:t>Leden    =&gt;    Toernooi inschrijving	           1:n</a:t>
             </a:r>
           </a:p>
           <a:p>
@@ -18333,15 +18499,9 @@
               <a:buChar char="-"/>
             </a:pPr>
             <a:r>
-              <a:rPr lang="nl-NL" sz="2000" noProof="0" dirty="0"/>
-              <a:t>Leden    =&gt;    Betalingen (1:m).</a:t>
-            </a:r>
-          </a:p>
-          <a:p>
-            <a:pPr marL="0" indent="0">
-              <a:buNone/>
-            </a:pPr>
-            <a:endParaRPr lang="nl-NL" sz="2000" noProof="0" dirty="0"/>
+              <a:rPr lang="nl-NL" sz="2000" dirty="0"/>
+              <a:t>Leden    =&gt;     Betaalstatus: Inschrijving	           1:n</a:t>
+            </a:r>
           </a:p>
           <a:p>
             <a:pPr>
@@ -18349,9 +18509,15 @@
               <a:buChar char="-"/>
             </a:pPr>
             <a:r>
-              <a:rPr lang="nl-NL" sz="2000" noProof="0" dirty="0"/>
-              <a:t>Betaling    =&gt;    Contributie / Toernooi (1:1).</a:t>
-            </a:r>
+              <a:rPr lang="nl-NL" sz="2000" dirty="0"/>
+              <a:t>Leden    =&gt;     Betaalstatus: Contributie	           1:n</a:t>
+            </a:r>
+          </a:p>
+          <a:p>
+            <a:pPr marL="0" indent="0">
+              <a:buNone/>
+            </a:pPr>
+            <a:endParaRPr lang="nl-NL" sz="2000" dirty="0"/>
           </a:p>
           <a:p>
             <a:pPr>
@@ -18359,8 +18525,25 @@
               <a:buChar char="-"/>
             </a:pPr>
             <a:r>
-              <a:rPr lang="nl-NL" sz="2000" noProof="0" dirty="0"/>
-              <a:t>Betaling    =&gt;    Status betaling (1:m).</a:t>
+              <a:rPr lang="nl-NL" sz="2000" dirty="0"/>
+              <a:t>Toernooien    =&gt;    Toernooi inschrijving	           1:n</a:t>
+            </a:r>
+          </a:p>
+          <a:p>
+            <a:pPr>
+              <a:buFontTx/>
+              <a:buChar char="-"/>
+            </a:pPr>
+            <a:endParaRPr lang="nl-NL" sz="2000" dirty="0"/>
+          </a:p>
+          <a:p>
+            <a:pPr>
+              <a:buFontTx/>
+              <a:buChar char="-"/>
+            </a:pPr>
+            <a:r>
+              <a:rPr lang="nl-NL" sz="2000" dirty="0"/>
+              <a:t>Contributie    =&gt;    Betaalstatus: Contributie         1:n</a:t>
             </a:r>
           </a:p>
         </p:txBody>
@@ -18370,7 +18553,7 @@
           <p:cNvPr id="6" name="Straight Connector 5">
             <a:extLst>
               <a:ext uri="{FF2B5EF4-FFF2-40B4-BE49-F238E27FC236}">
-                <a16:creationId xmlns:a16="http://schemas.microsoft.com/office/drawing/2014/main" id="{18F204CE-3B8C-CC2A-7382-A1956BE576A5}"/>
+                <a16:creationId xmlns:a16="http://schemas.microsoft.com/office/drawing/2014/main" id="{FFDABF7A-40C3-79B5-07FB-8640045B592F}"/>
               </a:ext>
             </a:extLst>
           </p:cNvPr>
@@ -18381,7 +18564,7 @@
         </p:nvCxnSpPr>
         <p:spPr>
           <a:xfrm>
-            <a:off x="6096000" y="1582615"/>
+            <a:off x="5071597" y="1582615"/>
             <a:ext cx="0" cy="4396154"/>
           </a:xfrm>
           <a:prstGeom prst="line">
@@ -18406,7 +18589,7 @@
     </p:spTree>
     <p:extLst>
       <p:ext uri="{BB962C8B-B14F-4D97-AF65-F5344CB8AC3E}">
-        <p14:creationId xmlns:p14="http://schemas.microsoft.com/office/powerpoint/2010/main" val="1597186539"/>
+        <p14:creationId xmlns:p14="http://schemas.microsoft.com/office/powerpoint/2010/main" val="2713263604"/>
       </p:ext>
     </p:extLst>
   </p:cSld>
@@ -18416,7 +18599,7 @@
 </p:sld>
 </file>
 
-<file path=ppt/slides/slide27.xml><?xml version="1.0" encoding="utf-8"?>
+<file path=ppt/slides/slide28.xml><?xml version="1.0" encoding="utf-8"?>
 <p:sld xmlns:a="http://schemas.openxmlformats.org/drawingml/2006/main" xmlns:r="http://schemas.openxmlformats.org/officeDocument/2006/relationships" xmlns:p="http://schemas.openxmlformats.org/presentationml/2006/main">
   <p:cSld>
     <p:spTree>
@@ -18439,42 +18622,12 @@
           <a:chExt cx="0" cy="0"/>
         </a:xfrm>
       </p:grpSpPr>
-      <p:sp>
-        <p:nvSpPr>
-          <p:cNvPr id="2" name="Title 1">
+      <p:pic>
+        <p:nvPicPr>
+          <p:cNvPr id="4" name="Picture 3">
             <a:extLst>
               <a:ext uri="{FF2B5EF4-FFF2-40B4-BE49-F238E27FC236}">
-                <a16:creationId xmlns:a16="http://schemas.microsoft.com/office/drawing/2014/main" id="{5C6951A1-9F56-B7F0-07B4-6E7AD3C441D7}"/>
-              </a:ext>
-            </a:extLst>
-          </p:cNvPr>
-          <p:cNvSpPr>
-            <a:spLocks noGrp="1"/>
-          </p:cNvSpPr>
-          <p:nvPr>
-            <p:ph type="title"/>
-          </p:nvPr>
-        </p:nvSpPr>
-        <p:spPr/>
-        <p:txBody>
-          <a:bodyPr>
-            <a:normAutofit/>
-          </a:bodyPr>
-          <a:lstStyle/>
-          <a:p>
-            <a:r>
-              <a:rPr lang="nl-NL" sz="3600" noProof="0" dirty="0"/>
-              <a:t>Oefeningen 2</a:t>
-            </a:r>
-          </a:p>
-        </p:txBody>
-      </p:sp>
-      <p:pic>
-        <p:nvPicPr>
-          <p:cNvPr id="5" name="Picture 4" descr="A screenshot of a computer&#10;&#10;Description automatically generated">
-            <a:extLst>
-              <a:ext uri="{FF2B5EF4-FFF2-40B4-BE49-F238E27FC236}">
-                <a16:creationId xmlns:a16="http://schemas.microsoft.com/office/drawing/2014/main" id="{0217F1B4-5109-3E07-23A3-DB0BD190F9B7}"/>
+                <a16:creationId xmlns:a16="http://schemas.microsoft.com/office/drawing/2014/main" id="{006637E1-829C-BBCC-29AA-E5ABF7D80498}"/>
               </a:ext>
             </a:extLst>
           </p:cNvPr>
@@ -18484,21 +18637,15 @@
           <p:nvPr/>
         </p:nvPicPr>
         <p:blipFill>
-          <a:blip r:embed="rId2">
-            <a:extLst>
-              <a:ext uri="{28A0092B-C50C-407E-A947-70E740481C1C}">
-                <a14:useLocalDpi xmlns:a14="http://schemas.microsoft.com/office/drawing/2010/main" val="0"/>
-              </a:ext>
-            </a:extLst>
-          </a:blip>
+          <a:blip r:embed="rId2"/>
           <a:stretch>
             <a:fillRect/>
           </a:stretch>
         </p:blipFill>
         <p:spPr>
           <a:xfrm>
-            <a:off x="838200" y="1526946"/>
-            <a:ext cx="9930809" cy="4705371"/>
+            <a:off x="2057050" y="990388"/>
+            <a:ext cx="8077900" cy="4877223"/>
           </a:xfrm>
           <a:prstGeom prst="rect">
             <a:avLst/>
@@ -18518,7 +18665,7 @@
 </p:sld>
 </file>
 
-<file path=ppt/slides/slide28.xml><?xml version="1.0" encoding="utf-8"?>
+<file path=ppt/slides/slide29.xml><?xml version="1.0" encoding="utf-8"?>
 <p:sld xmlns:a="http://schemas.openxmlformats.org/drawingml/2006/main" xmlns:r="http://schemas.openxmlformats.org/officeDocument/2006/relationships" xmlns:p="http://schemas.openxmlformats.org/presentationml/2006/main">
   <p:cSld>
     <p:spTree>
@@ -18603,7 +18750,92 @@
 </p:sld>
 </file>
 
-<file path=ppt/slides/slide29.xml><?xml version="1.0" encoding="utf-8"?>
+<file path=ppt/slides/slide3.xml><?xml version="1.0" encoding="utf-8"?>
+<p:sld xmlns:a="http://schemas.openxmlformats.org/drawingml/2006/main" xmlns:r="http://schemas.openxmlformats.org/officeDocument/2006/relationships" xmlns:p="http://schemas.openxmlformats.org/presentationml/2006/main">
+  <p:cSld>
+    <p:spTree>
+      <p:nvGrpSpPr>
+        <p:cNvPr id="1" name=""/>
+        <p:cNvGrpSpPr/>
+        <p:nvPr/>
+      </p:nvGrpSpPr>
+      <p:grpSpPr>
+        <a:xfrm>
+          <a:off x="0" y="0"/>
+          <a:ext cx="0" cy="0"/>
+          <a:chOff x="0" y="0"/>
+          <a:chExt cx="0" cy="0"/>
+        </a:xfrm>
+      </p:grpSpPr>
+      <p:sp>
+        <p:nvSpPr>
+          <p:cNvPr id="4" name="Title 3">
+            <a:extLst>
+              <a:ext uri="{FF2B5EF4-FFF2-40B4-BE49-F238E27FC236}">
+                <a16:creationId xmlns:a16="http://schemas.microsoft.com/office/drawing/2014/main" id="{B021A23A-264E-4F48-8D91-52361A48531C}"/>
+              </a:ext>
+            </a:extLst>
+          </p:cNvPr>
+          <p:cNvSpPr>
+            <a:spLocks noGrp="1"/>
+          </p:cNvSpPr>
+          <p:nvPr>
+            <p:ph type="title"/>
+          </p:nvPr>
+        </p:nvSpPr>
+        <p:spPr/>
+        <p:txBody>
+          <a:bodyPr>
+            <a:normAutofit/>
+          </a:bodyPr>
+          <a:lstStyle/>
+          <a:p>
+            <a:r>
+              <a:rPr lang="nl-NL" sz="4400" noProof="0" dirty="0"/>
+              <a:t>Structuur en normalisatie</a:t>
+            </a:r>
+          </a:p>
+        </p:txBody>
+      </p:sp>
+      <p:sp>
+        <p:nvSpPr>
+          <p:cNvPr id="5" name="Text Placeholder 4">
+            <a:extLst>
+              <a:ext uri="{FF2B5EF4-FFF2-40B4-BE49-F238E27FC236}">
+                <a16:creationId xmlns:a16="http://schemas.microsoft.com/office/drawing/2014/main" id="{8B343CC5-EAA5-4394-8782-3BBA201EEC8C}"/>
+              </a:ext>
+            </a:extLst>
+          </p:cNvPr>
+          <p:cNvSpPr>
+            <a:spLocks noGrp="1"/>
+          </p:cNvSpPr>
+          <p:nvPr>
+            <p:ph type="body" idx="1"/>
+          </p:nvPr>
+        </p:nvSpPr>
+        <p:spPr/>
+        <p:txBody>
+          <a:bodyPr/>
+          <a:lstStyle/>
+          <a:p>
+            <a:endParaRPr lang="nl-NL" noProof="0" dirty="0"/>
+          </a:p>
+        </p:txBody>
+      </p:sp>
+    </p:spTree>
+    <p:extLst>
+      <p:ext uri="{BB962C8B-B14F-4D97-AF65-F5344CB8AC3E}">
+        <p14:creationId xmlns:p14="http://schemas.microsoft.com/office/powerpoint/2010/main" val="2754617916"/>
+      </p:ext>
+    </p:extLst>
+  </p:cSld>
+  <p:clrMapOvr>
+    <a:masterClrMapping/>
+  </p:clrMapOvr>
+</p:sld>
+</file>
+
+<file path=ppt/slides/slide30.xml><?xml version="1.0" encoding="utf-8"?>
 <p:sld xmlns:a="http://schemas.openxmlformats.org/drawingml/2006/main" xmlns:r="http://schemas.openxmlformats.org/officeDocument/2006/relationships" xmlns:p="http://schemas.openxmlformats.org/presentationml/2006/main">
   <p:cSld>
     <p:spTree>
@@ -19103,92 +19335,7 @@
 </p:sld>
 </file>
 
-<file path=ppt/slides/slide3.xml><?xml version="1.0" encoding="utf-8"?>
-<p:sld xmlns:a="http://schemas.openxmlformats.org/drawingml/2006/main" xmlns:r="http://schemas.openxmlformats.org/officeDocument/2006/relationships" xmlns:p="http://schemas.openxmlformats.org/presentationml/2006/main">
-  <p:cSld>
-    <p:spTree>
-      <p:nvGrpSpPr>
-        <p:cNvPr id="1" name=""/>
-        <p:cNvGrpSpPr/>
-        <p:nvPr/>
-      </p:nvGrpSpPr>
-      <p:grpSpPr>
-        <a:xfrm>
-          <a:off x="0" y="0"/>
-          <a:ext cx="0" cy="0"/>
-          <a:chOff x="0" y="0"/>
-          <a:chExt cx="0" cy="0"/>
-        </a:xfrm>
-      </p:grpSpPr>
-      <p:sp>
-        <p:nvSpPr>
-          <p:cNvPr id="4" name="Title 3">
-            <a:extLst>
-              <a:ext uri="{FF2B5EF4-FFF2-40B4-BE49-F238E27FC236}">
-                <a16:creationId xmlns:a16="http://schemas.microsoft.com/office/drawing/2014/main" id="{B021A23A-264E-4F48-8D91-52361A48531C}"/>
-              </a:ext>
-            </a:extLst>
-          </p:cNvPr>
-          <p:cNvSpPr>
-            <a:spLocks noGrp="1"/>
-          </p:cNvSpPr>
-          <p:nvPr>
-            <p:ph type="title"/>
-          </p:nvPr>
-        </p:nvSpPr>
-        <p:spPr/>
-        <p:txBody>
-          <a:bodyPr>
-            <a:normAutofit/>
-          </a:bodyPr>
-          <a:lstStyle/>
-          <a:p>
-            <a:r>
-              <a:rPr lang="nl-NL" sz="4400" noProof="0" dirty="0"/>
-              <a:t>Structuur en normalisatie</a:t>
-            </a:r>
-          </a:p>
-        </p:txBody>
-      </p:sp>
-      <p:sp>
-        <p:nvSpPr>
-          <p:cNvPr id="5" name="Text Placeholder 4">
-            <a:extLst>
-              <a:ext uri="{FF2B5EF4-FFF2-40B4-BE49-F238E27FC236}">
-                <a16:creationId xmlns:a16="http://schemas.microsoft.com/office/drawing/2014/main" id="{8B343CC5-EAA5-4394-8782-3BBA201EEC8C}"/>
-              </a:ext>
-            </a:extLst>
-          </p:cNvPr>
-          <p:cNvSpPr>
-            <a:spLocks noGrp="1"/>
-          </p:cNvSpPr>
-          <p:nvPr>
-            <p:ph type="body" idx="1"/>
-          </p:nvPr>
-        </p:nvSpPr>
-        <p:spPr/>
-        <p:txBody>
-          <a:bodyPr/>
-          <a:lstStyle/>
-          <a:p>
-            <a:endParaRPr lang="nl-NL" noProof="0" dirty="0"/>
-          </a:p>
-        </p:txBody>
-      </p:sp>
-    </p:spTree>
-    <p:extLst>
-      <p:ext uri="{BB962C8B-B14F-4D97-AF65-F5344CB8AC3E}">
-        <p14:creationId xmlns:p14="http://schemas.microsoft.com/office/powerpoint/2010/main" val="2754617916"/>
-      </p:ext>
-    </p:extLst>
-  </p:cSld>
-  <p:clrMapOvr>
-    <a:masterClrMapping/>
-  </p:clrMapOvr>
-</p:sld>
-</file>
-
-<file path=ppt/slides/slide30.xml><?xml version="1.0" encoding="utf-8"?>
+<file path=ppt/slides/slide31.xml><?xml version="1.0" encoding="utf-8"?>
 <p:sld xmlns:a="http://schemas.openxmlformats.org/drawingml/2006/main" xmlns:r="http://schemas.openxmlformats.org/officeDocument/2006/relationships" xmlns:p="http://schemas.openxmlformats.org/presentationml/2006/main">
   <p:cSld>
     <p:spTree>
@@ -19553,7 +19700,7 @@
 </p:sld>
 </file>
 
-<file path=ppt/slides/slide31.xml><?xml version="1.0" encoding="utf-8"?>
+<file path=ppt/slides/slide32.xml><?xml version="1.0" encoding="utf-8"?>
 <p:sld xmlns:a="http://schemas.openxmlformats.org/drawingml/2006/main" xmlns:r="http://schemas.openxmlformats.org/officeDocument/2006/relationships" xmlns:p="http://schemas.openxmlformats.org/presentationml/2006/main">
   <p:cSld>
     <p:spTree>
@@ -20226,7 +20373,7 @@
 </p:sld>
 </file>
 
-<file path=ppt/slides/slide32.xml><?xml version="1.0" encoding="utf-8"?>
+<file path=ppt/slides/slide33.xml><?xml version="1.0" encoding="utf-8"?>
 <p:sld xmlns:a="http://schemas.openxmlformats.org/drawingml/2006/main" xmlns:r="http://schemas.openxmlformats.org/officeDocument/2006/relationships" xmlns:p="http://schemas.openxmlformats.org/presentationml/2006/main">
   <p:cSld>
     <p:spTree>
@@ -20785,7 +20932,7 @@
 </p:sld>
 </file>
 
-<file path=ppt/slides/slide33.xml><?xml version="1.0" encoding="utf-8"?>
+<file path=ppt/slides/slide34.xml><?xml version="1.0" encoding="utf-8"?>
 <p:sld xmlns:a="http://schemas.openxmlformats.org/drawingml/2006/main" xmlns:r="http://schemas.openxmlformats.org/officeDocument/2006/relationships" xmlns:p="http://schemas.openxmlformats.org/presentationml/2006/main">
   <p:cSld>
     <p:spTree>
@@ -20833,7 +20980,7 @@
           <a:p>
             <a:r>
               <a:rPr lang="nl-NL" sz="3600" noProof="0" dirty="0"/>
-              <a:t>Gekoppelde sleutel</a:t>
+              <a:t>Koppel sleutel</a:t>
             </a:r>
           </a:p>
         </p:txBody>
@@ -21403,7 +21550,7 @@
 </p:sld>
 </file>
 
-<file path=ppt/slides/slide34.xml><?xml version="1.0" encoding="utf-8"?>
+<file path=ppt/slides/slide35.xml><?xml version="1.0" encoding="utf-8"?>
 <p:sld xmlns:a="http://schemas.openxmlformats.org/drawingml/2006/main" xmlns:r="http://schemas.openxmlformats.org/officeDocument/2006/relationships" xmlns:p="http://schemas.openxmlformats.org/presentationml/2006/main">
   <p:cSld>
     <p:spTree>
@@ -22150,7 +22297,7 @@
 </p:sld>
 </file>
 
-<file path=ppt/slides/slide35.xml><?xml version="1.0" encoding="utf-8"?>
+<file path=ppt/slides/slide36.xml><?xml version="1.0" encoding="utf-8"?>
 <p:sld xmlns:a="http://schemas.openxmlformats.org/drawingml/2006/main" xmlns:r="http://schemas.openxmlformats.org/officeDocument/2006/relationships" xmlns:p="http://schemas.openxmlformats.org/presentationml/2006/main">
   <p:cSld>
     <p:spTree>
@@ -22658,7 +22805,7 @@
 </p:sld>
 </file>
 
-<file path=ppt/slides/slide36.xml><?xml version="1.0" encoding="utf-8"?>
+<file path=ppt/slides/slide37.xml><?xml version="1.0" encoding="utf-8"?>
 <p:sld xmlns:a="http://schemas.openxmlformats.org/drawingml/2006/main" xmlns:r="http://schemas.openxmlformats.org/officeDocument/2006/relationships" xmlns:p="http://schemas.openxmlformats.org/presentationml/2006/main">
   <p:cSld>
     <p:spTree>
@@ -23199,7 +23346,7 @@
 </p:sld>
 </file>
 
-<file path=ppt/slides/slide37.xml><?xml version="1.0" encoding="utf-8"?>
+<file path=ppt/slides/slide38.xml><?xml version="1.0" encoding="utf-8"?>
 <p:sld xmlns:a="http://schemas.openxmlformats.org/drawingml/2006/main" xmlns:r="http://schemas.openxmlformats.org/officeDocument/2006/relationships" xmlns:p="http://schemas.openxmlformats.org/presentationml/2006/main">
   <p:cSld>
     <p:spTree>
@@ -23806,7 +23953,7 @@
 </p:sld>
 </file>
 
-<file path=ppt/slides/slide38.xml><?xml version="1.0" encoding="utf-8"?>
+<file path=ppt/slides/slide39.xml><?xml version="1.0" encoding="utf-8"?>
 <p:sld xmlns:a="http://schemas.openxmlformats.org/drawingml/2006/main" xmlns:r="http://schemas.openxmlformats.org/officeDocument/2006/relationships" xmlns:p="http://schemas.openxmlformats.org/presentationml/2006/main">
   <p:cSld>
     <p:spTree>
@@ -24572,7 +24719,550 @@
 </p:sld>
 </file>
 
-<file path=ppt/slides/slide39.xml><?xml version="1.0" encoding="utf-8"?>
+<file path=ppt/slides/slide4.xml><?xml version="1.0" encoding="utf-8"?>
+<p:sld xmlns:a="http://schemas.openxmlformats.org/drawingml/2006/main" xmlns:r="http://schemas.openxmlformats.org/officeDocument/2006/relationships" xmlns:p="http://schemas.openxmlformats.org/presentationml/2006/main">
+  <p:cSld>
+    <p:spTree>
+      <p:nvGrpSpPr>
+        <p:cNvPr id="1" name=""/>
+        <p:cNvGrpSpPr/>
+        <p:nvPr/>
+      </p:nvGrpSpPr>
+      <p:grpSpPr>
+        <a:xfrm>
+          <a:off x="0" y="0"/>
+          <a:ext cx="0" cy="0"/>
+          <a:chOff x="0" y="0"/>
+          <a:chExt cx="0" cy="0"/>
+        </a:xfrm>
+      </p:grpSpPr>
+      <p:sp>
+        <p:nvSpPr>
+          <p:cNvPr id="2" name="Title 1">
+            <a:extLst>
+              <a:ext uri="{FF2B5EF4-FFF2-40B4-BE49-F238E27FC236}">
+                <a16:creationId xmlns:a16="http://schemas.microsoft.com/office/drawing/2014/main" id="{9BDFD261-0D2C-41B9-9E28-43DF575D40E0}"/>
+              </a:ext>
+            </a:extLst>
+          </p:cNvPr>
+          <p:cNvSpPr>
+            <a:spLocks noGrp="1"/>
+          </p:cNvSpPr>
+          <p:nvPr>
+            <p:ph type="title"/>
+          </p:nvPr>
+        </p:nvSpPr>
+        <p:spPr/>
+        <p:txBody>
+          <a:bodyPr>
+            <a:normAutofit/>
+          </a:bodyPr>
+          <a:lstStyle/>
+          <a:p>
+            <a:r>
+              <a:rPr lang="nl-NL" sz="3600" noProof="0" dirty="0"/>
+              <a:t>Entiteiten in tabellen</a:t>
+            </a:r>
+          </a:p>
+        </p:txBody>
+      </p:sp>
+      <p:sp>
+        <p:nvSpPr>
+          <p:cNvPr id="3" name="Content Placeholder 2">
+            <a:extLst>
+              <a:ext uri="{FF2B5EF4-FFF2-40B4-BE49-F238E27FC236}">
+                <a16:creationId xmlns:a16="http://schemas.microsoft.com/office/drawing/2014/main" id="{7844B503-C44F-453E-9465-D42E4557DE0C}"/>
+              </a:ext>
+            </a:extLst>
+          </p:cNvPr>
+          <p:cNvSpPr>
+            <a:spLocks noGrp="1"/>
+          </p:cNvSpPr>
+          <p:nvPr>
+            <p:ph idx="1"/>
+          </p:nvPr>
+        </p:nvSpPr>
+        <p:spPr>
+          <a:xfrm>
+            <a:off x="838199" y="1825625"/>
+            <a:ext cx="10442825" cy="4351338"/>
+          </a:xfrm>
+        </p:spPr>
+        <p:txBody>
+          <a:bodyPr>
+            <a:normAutofit/>
+          </a:bodyPr>
+          <a:lstStyle/>
+          <a:p>
+            <a:pPr marL="0" indent="0">
+              <a:buNone/>
+            </a:pPr>
+            <a:r>
+              <a:rPr lang="nl-NL" sz="2000" noProof="0" dirty="0"/>
+              <a:t>Entiteiten en hun attributen slaan we op in tabellen:</a:t>
+            </a:r>
+          </a:p>
+          <a:p>
+            <a:pPr marL="0" indent="0">
+              <a:buNone/>
+            </a:pPr>
+            <a:endParaRPr lang="nl-NL" sz="2000" noProof="0" dirty="0"/>
+          </a:p>
+          <a:p>
+            <a:pPr marL="0" indent="0">
+              <a:buNone/>
+            </a:pPr>
+            <a:endParaRPr lang="nl-NL" sz="2000" noProof="0" dirty="0"/>
+          </a:p>
+        </p:txBody>
+      </p:sp>
+      <p:graphicFrame>
+        <p:nvGraphicFramePr>
+          <p:cNvPr id="4" name="Table 5">
+            <a:extLst>
+              <a:ext uri="{FF2B5EF4-FFF2-40B4-BE49-F238E27FC236}">
+                <a16:creationId xmlns:a16="http://schemas.microsoft.com/office/drawing/2014/main" id="{62CA46F3-D9D4-4F4A-856A-A943EE0F0F0C}"/>
+              </a:ext>
+            </a:extLst>
+          </p:cNvPr>
+          <p:cNvGraphicFramePr>
+            <a:graphicFrameLocks noGrp="1"/>
+          </p:cNvGraphicFramePr>
+          <p:nvPr>
+            <p:extLst>
+              <p:ext uri="{D42A27DB-BD31-4B8C-83A1-F6EECF244321}">
+                <p14:modId xmlns:p14="http://schemas.microsoft.com/office/powerpoint/2010/main" val="798112305"/>
+              </p:ext>
+            </p:extLst>
+          </p:nvPr>
+        </p:nvGraphicFramePr>
+        <p:xfrm>
+          <a:off x="989028" y="2928721"/>
+          <a:ext cx="1820160" cy="1849120"/>
+        </p:xfrm>
+        <a:graphic>
+          <a:graphicData uri="http://schemas.openxmlformats.org/drawingml/2006/table">
+            <a:tbl>
+              <a:tblPr firstRow="1" bandRow="1">
+                <a:tableStyleId>{5C22544A-7EE6-4342-B048-85BDC9FD1C3A}</a:tableStyleId>
+              </a:tblPr>
+              <a:tblGrid>
+                <a:gridCol w="1820160">
+                  <a:extLst>
+                    <a:ext uri="{9D8B030D-6E8A-4147-A177-3AD203B41FA5}">
+                      <a16:colId xmlns:a16="http://schemas.microsoft.com/office/drawing/2014/main" val="2508677333"/>
+                    </a:ext>
+                  </a:extLst>
+                </a:gridCol>
+              </a:tblGrid>
+              <a:tr h="0">
+                <a:tc>
+                  <a:txBody>
+                    <a:bodyPr/>
+                    <a:lstStyle/>
+                    <a:p>
+                      <a:r>
+                        <a:rPr lang="nl-NL" noProof="0" dirty="0"/>
+                        <a:t>Klanten</a:t>
+                      </a:r>
+                    </a:p>
+                  </a:txBody>
+                  <a:tcPr/>
+                </a:tc>
+                <a:extLst>
+                  <a:ext uri="{0D108BD9-81ED-4DB2-BD59-A6C34878D82A}">
+                    <a16:rowId xmlns:a16="http://schemas.microsoft.com/office/drawing/2014/main" val="858791041"/>
+                  </a:ext>
+                </a:extLst>
+              </a:tr>
+              <a:tr h="370840">
+                <a:tc>
+                  <a:txBody>
+                    <a:bodyPr/>
+                    <a:lstStyle/>
+                    <a:p>
+                      <a:r>
+                        <a:rPr lang="nl-NL" b="0" noProof="0" dirty="0" err="1"/>
+                        <a:t>KlantID</a:t>
+                      </a:r>
+                      <a:endParaRPr lang="nl-NL" b="0" noProof="0" dirty="0"/>
+                    </a:p>
+                  </a:txBody>
+                  <a:tcPr/>
+                </a:tc>
+                <a:extLst>
+                  <a:ext uri="{0D108BD9-81ED-4DB2-BD59-A6C34878D82A}">
+                    <a16:rowId xmlns:a16="http://schemas.microsoft.com/office/drawing/2014/main" val="1538811982"/>
+                  </a:ext>
+                </a:extLst>
+              </a:tr>
+              <a:tr h="370840">
+                <a:tc>
+                  <a:txBody>
+                    <a:bodyPr/>
+                    <a:lstStyle/>
+                    <a:p>
+                      <a:r>
+                        <a:rPr lang="nl-NL" noProof="0" dirty="0"/>
+                        <a:t>Voornaam</a:t>
+                      </a:r>
+                    </a:p>
+                  </a:txBody>
+                  <a:tcPr/>
+                </a:tc>
+                <a:extLst>
+                  <a:ext uri="{0D108BD9-81ED-4DB2-BD59-A6C34878D82A}">
+                    <a16:rowId xmlns:a16="http://schemas.microsoft.com/office/drawing/2014/main" val="3674785774"/>
+                  </a:ext>
+                </a:extLst>
+              </a:tr>
+              <a:tr h="370840">
+                <a:tc>
+                  <a:txBody>
+                    <a:bodyPr/>
+                    <a:lstStyle/>
+                    <a:p>
+                      <a:r>
+                        <a:rPr lang="nl-NL" noProof="0" dirty="0"/>
+                        <a:t>Achternaam</a:t>
+                      </a:r>
+                    </a:p>
+                  </a:txBody>
+                  <a:tcPr/>
+                </a:tc>
+                <a:extLst>
+                  <a:ext uri="{0D108BD9-81ED-4DB2-BD59-A6C34878D82A}">
+                    <a16:rowId xmlns:a16="http://schemas.microsoft.com/office/drawing/2014/main" val="2335262126"/>
+                  </a:ext>
+                </a:extLst>
+              </a:tr>
+              <a:tr h="370840">
+                <a:tc>
+                  <a:txBody>
+                    <a:bodyPr/>
+                    <a:lstStyle/>
+                    <a:p>
+                      <a:r>
+                        <a:rPr lang="nl-NL" noProof="0" dirty="0"/>
+                        <a:t>…</a:t>
+                      </a:r>
+                    </a:p>
+                  </a:txBody>
+                  <a:tcPr/>
+                </a:tc>
+                <a:extLst>
+                  <a:ext uri="{0D108BD9-81ED-4DB2-BD59-A6C34878D82A}">
+                    <a16:rowId xmlns:a16="http://schemas.microsoft.com/office/drawing/2014/main" val="2163937255"/>
+                  </a:ext>
+                </a:extLst>
+              </a:tr>
+            </a:tbl>
+          </a:graphicData>
+        </a:graphic>
+      </p:graphicFrame>
+      <p:graphicFrame>
+        <p:nvGraphicFramePr>
+          <p:cNvPr id="5" name="Table 5">
+            <a:extLst>
+              <a:ext uri="{FF2B5EF4-FFF2-40B4-BE49-F238E27FC236}">
+                <a16:creationId xmlns:a16="http://schemas.microsoft.com/office/drawing/2014/main" id="{2F81CE1D-F9ED-02C0-0A6D-49B2EC941B4F}"/>
+              </a:ext>
+            </a:extLst>
+          </p:cNvPr>
+          <p:cNvGraphicFramePr>
+            <a:graphicFrameLocks noGrp="1"/>
+          </p:cNvGraphicFramePr>
+          <p:nvPr>
+            <p:extLst>
+              <p:ext uri="{D42A27DB-BD31-4B8C-83A1-F6EECF244321}">
+                <p14:modId xmlns:p14="http://schemas.microsoft.com/office/powerpoint/2010/main" val="1399094275"/>
+              </p:ext>
+            </p:extLst>
+          </p:nvPr>
+        </p:nvGraphicFramePr>
+        <p:xfrm>
+          <a:off x="4275840" y="2928721"/>
+          <a:ext cx="1820160" cy="1849120"/>
+        </p:xfrm>
+        <a:graphic>
+          <a:graphicData uri="http://schemas.openxmlformats.org/drawingml/2006/table">
+            <a:tbl>
+              <a:tblPr firstRow="1" bandRow="1">
+                <a:tableStyleId>{5C22544A-7EE6-4342-B048-85BDC9FD1C3A}</a:tableStyleId>
+              </a:tblPr>
+              <a:tblGrid>
+                <a:gridCol w="1820160">
+                  <a:extLst>
+                    <a:ext uri="{9D8B030D-6E8A-4147-A177-3AD203B41FA5}">
+                      <a16:colId xmlns:a16="http://schemas.microsoft.com/office/drawing/2014/main" val="2508677333"/>
+                    </a:ext>
+                  </a:extLst>
+                </a:gridCol>
+              </a:tblGrid>
+              <a:tr h="0">
+                <a:tc>
+                  <a:txBody>
+                    <a:bodyPr/>
+                    <a:lstStyle/>
+                    <a:p>
+                      <a:r>
+                        <a:rPr lang="nl-NL" noProof="0" dirty="0"/>
+                        <a:t>Transacties</a:t>
+                      </a:r>
+                    </a:p>
+                  </a:txBody>
+                  <a:tcPr/>
+                </a:tc>
+                <a:extLst>
+                  <a:ext uri="{0D108BD9-81ED-4DB2-BD59-A6C34878D82A}">
+                    <a16:rowId xmlns:a16="http://schemas.microsoft.com/office/drawing/2014/main" val="858791041"/>
+                  </a:ext>
+                </a:extLst>
+              </a:tr>
+              <a:tr h="370840">
+                <a:tc>
+                  <a:txBody>
+                    <a:bodyPr/>
+                    <a:lstStyle/>
+                    <a:p>
+                      <a:r>
+                        <a:rPr lang="nl-NL" b="0" noProof="0" dirty="0" err="1"/>
+                        <a:t>KlantID</a:t>
+                      </a:r>
+                      <a:endParaRPr lang="nl-NL" b="0" noProof="0" dirty="0"/>
+                    </a:p>
+                  </a:txBody>
+                  <a:tcPr/>
+                </a:tc>
+                <a:extLst>
+                  <a:ext uri="{0D108BD9-81ED-4DB2-BD59-A6C34878D82A}">
+                    <a16:rowId xmlns:a16="http://schemas.microsoft.com/office/drawing/2014/main" val="1538811982"/>
+                  </a:ext>
+                </a:extLst>
+              </a:tr>
+              <a:tr h="370840">
+                <a:tc>
+                  <a:txBody>
+                    <a:bodyPr/>
+                    <a:lstStyle/>
+                    <a:p>
+                      <a:r>
+                        <a:rPr lang="nl-NL" b="0" noProof="0" dirty="0" err="1"/>
+                        <a:t>ProductID</a:t>
+                      </a:r>
+                      <a:endParaRPr lang="nl-NL" b="0" noProof="0" dirty="0"/>
+                    </a:p>
+                  </a:txBody>
+                  <a:tcPr/>
+                </a:tc>
+                <a:extLst>
+                  <a:ext uri="{0D108BD9-81ED-4DB2-BD59-A6C34878D82A}">
+                    <a16:rowId xmlns:a16="http://schemas.microsoft.com/office/drawing/2014/main" val="3674785774"/>
+                  </a:ext>
+                </a:extLst>
+              </a:tr>
+              <a:tr h="370840">
+                <a:tc>
+                  <a:txBody>
+                    <a:bodyPr/>
+                    <a:lstStyle/>
+                    <a:p>
+                      <a:r>
+                        <a:rPr lang="nl-NL" noProof="0" dirty="0"/>
+                        <a:t>Aantal</a:t>
+                      </a:r>
+                    </a:p>
+                  </a:txBody>
+                  <a:tcPr/>
+                </a:tc>
+                <a:extLst>
+                  <a:ext uri="{0D108BD9-81ED-4DB2-BD59-A6C34878D82A}">
+                    <a16:rowId xmlns:a16="http://schemas.microsoft.com/office/drawing/2014/main" val="2335262126"/>
+                  </a:ext>
+                </a:extLst>
+              </a:tr>
+              <a:tr h="370840">
+                <a:tc>
+                  <a:txBody>
+                    <a:bodyPr/>
+                    <a:lstStyle/>
+                    <a:p>
+                      <a:r>
+                        <a:rPr lang="nl-NL" noProof="0" dirty="0"/>
+                        <a:t>…</a:t>
+                      </a:r>
+                    </a:p>
+                  </a:txBody>
+                  <a:tcPr/>
+                </a:tc>
+                <a:extLst>
+                  <a:ext uri="{0D108BD9-81ED-4DB2-BD59-A6C34878D82A}">
+                    <a16:rowId xmlns:a16="http://schemas.microsoft.com/office/drawing/2014/main" val="2163937255"/>
+                  </a:ext>
+                </a:extLst>
+              </a:tr>
+            </a:tbl>
+          </a:graphicData>
+        </a:graphic>
+      </p:graphicFrame>
+      <p:graphicFrame>
+        <p:nvGraphicFramePr>
+          <p:cNvPr id="8" name="Table 5">
+            <a:extLst>
+              <a:ext uri="{FF2B5EF4-FFF2-40B4-BE49-F238E27FC236}">
+                <a16:creationId xmlns:a16="http://schemas.microsoft.com/office/drawing/2014/main" id="{F4917DC8-4826-215A-40A2-62AE8EF1EFDB}"/>
+              </a:ext>
+            </a:extLst>
+          </p:cNvPr>
+          <p:cNvGraphicFramePr>
+            <a:graphicFrameLocks noGrp="1"/>
+          </p:cNvGraphicFramePr>
+          <p:nvPr>
+            <p:extLst>
+              <p:ext uri="{D42A27DB-BD31-4B8C-83A1-F6EECF244321}">
+                <p14:modId xmlns:p14="http://schemas.microsoft.com/office/powerpoint/2010/main" val="2944981733"/>
+              </p:ext>
+            </p:extLst>
+          </p:nvPr>
+        </p:nvGraphicFramePr>
+        <p:xfrm>
+          <a:off x="7562652" y="2928721"/>
+          <a:ext cx="1820160" cy="1849120"/>
+        </p:xfrm>
+        <a:graphic>
+          <a:graphicData uri="http://schemas.openxmlformats.org/drawingml/2006/table">
+            <a:tbl>
+              <a:tblPr firstRow="1" bandRow="1">
+                <a:tableStyleId>{5C22544A-7EE6-4342-B048-85BDC9FD1C3A}</a:tableStyleId>
+              </a:tblPr>
+              <a:tblGrid>
+                <a:gridCol w="1820160">
+                  <a:extLst>
+                    <a:ext uri="{9D8B030D-6E8A-4147-A177-3AD203B41FA5}">
+                      <a16:colId xmlns:a16="http://schemas.microsoft.com/office/drawing/2014/main" val="2508677333"/>
+                    </a:ext>
+                  </a:extLst>
+                </a:gridCol>
+              </a:tblGrid>
+              <a:tr h="0">
+                <a:tc>
+                  <a:txBody>
+                    <a:bodyPr/>
+                    <a:lstStyle/>
+                    <a:p>
+                      <a:r>
+                        <a:rPr lang="nl-NL" noProof="0" dirty="0"/>
+                        <a:t>Producten</a:t>
+                      </a:r>
+                    </a:p>
+                  </a:txBody>
+                  <a:tcPr/>
+                </a:tc>
+                <a:extLst>
+                  <a:ext uri="{0D108BD9-81ED-4DB2-BD59-A6C34878D82A}">
+                    <a16:rowId xmlns:a16="http://schemas.microsoft.com/office/drawing/2014/main" val="858791041"/>
+                  </a:ext>
+                </a:extLst>
+              </a:tr>
+              <a:tr h="370840">
+                <a:tc>
+                  <a:txBody>
+                    <a:bodyPr/>
+                    <a:lstStyle/>
+                    <a:p>
+                      <a:r>
+                        <a:rPr lang="nl-NL" b="0" noProof="0" dirty="0" err="1"/>
+                        <a:t>ProductID</a:t>
+                      </a:r>
+                      <a:endParaRPr lang="nl-NL" b="0" noProof="0" dirty="0"/>
+                    </a:p>
+                  </a:txBody>
+                  <a:tcPr/>
+                </a:tc>
+                <a:extLst>
+                  <a:ext uri="{0D108BD9-81ED-4DB2-BD59-A6C34878D82A}">
+                    <a16:rowId xmlns:a16="http://schemas.microsoft.com/office/drawing/2014/main" val="1538811982"/>
+                  </a:ext>
+                </a:extLst>
+              </a:tr>
+              <a:tr h="370840">
+                <a:tc>
+                  <a:txBody>
+                    <a:bodyPr/>
+                    <a:lstStyle/>
+                    <a:p>
+                      <a:r>
+                        <a:rPr lang="nl-NL" noProof="0" dirty="0"/>
+                        <a:t>Naam</a:t>
+                      </a:r>
+                    </a:p>
+                  </a:txBody>
+                  <a:tcPr/>
+                </a:tc>
+                <a:extLst>
+                  <a:ext uri="{0D108BD9-81ED-4DB2-BD59-A6C34878D82A}">
+                    <a16:rowId xmlns:a16="http://schemas.microsoft.com/office/drawing/2014/main" val="3674785774"/>
+                  </a:ext>
+                </a:extLst>
+              </a:tr>
+              <a:tr h="370840">
+                <a:tc>
+                  <a:txBody>
+                    <a:bodyPr/>
+                    <a:lstStyle/>
+                    <a:p>
+                      <a:r>
+                        <a:rPr lang="nl-NL" noProof="0" dirty="0"/>
+                        <a:t>Omschrijving</a:t>
+                      </a:r>
+                    </a:p>
+                  </a:txBody>
+                  <a:tcPr/>
+                </a:tc>
+                <a:extLst>
+                  <a:ext uri="{0D108BD9-81ED-4DB2-BD59-A6C34878D82A}">
+                    <a16:rowId xmlns:a16="http://schemas.microsoft.com/office/drawing/2014/main" val="2335262126"/>
+                  </a:ext>
+                </a:extLst>
+              </a:tr>
+              <a:tr h="370840">
+                <a:tc>
+                  <a:txBody>
+                    <a:bodyPr/>
+                    <a:lstStyle/>
+                    <a:p>
+                      <a:r>
+                        <a:rPr lang="nl-NL" noProof="0" dirty="0"/>
+                        <a:t>…</a:t>
+                      </a:r>
+                    </a:p>
+                  </a:txBody>
+                  <a:tcPr/>
+                </a:tc>
+                <a:extLst>
+                  <a:ext uri="{0D108BD9-81ED-4DB2-BD59-A6C34878D82A}">
+                    <a16:rowId xmlns:a16="http://schemas.microsoft.com/office/drawing/2014/main" val="2163937255"/>
+                  </a:ext>
+                </a:extLst>
+              </a:tr>
+            </a:tbl>
+          </a:graphicData>
+        </a:graphic>
+      </p:graphicFrame>
+    </p:spTree>
+    <p:extLst>
+      <p:ext uri="{BB962C8B-B14F-4D97-AF65-F5344CB8AC3E}">
+        <p14:creationId xmlns:p14="http://schemas.microsoft.com/office/powerpoint/2010/main" val="2320990652"/>
+      </p:ext>
+    </p:extLst>
+  </p:cSld>
+  <p:clrMapOvr>
+    <a:masterClrMapping/>
+  </p:clrMapOvr>
+</p:sld>
+</file>
+
+<file path=ppt/slides/slide40.xml><?xml version="1.0" encoding="utf-8"?>
 <p:sld xmlns:a="http://schemas.openxmlformats.org/drawingml/2006/main" xmlns:r="http://schemas.openxmlformats.org/officeDocument/2006/relationships" xmlns:p="http://schemas.openxmlformats.org/presentationml/2006/main">
   <p:cSld>
     <p:spTree>
@@ -24988,550 +25678,7 @@
 </p:sld>
 </file>
 
-<file path=ppt/slides/slide4.xml><?xml version="1.0" encoding="utf-8"?>
-<p:sld xmlns:a="http://schemas.openxmlformats.org/drawingml/2006/main" xmlns:r="http://schemas.openxmlformats.org/officeDocument/2006/relationships" xmlns:p="http://schemas.openxmlformats.org/presentationml/2006/main">
-  <p:cSld>
-    <p:spTree>
-      <p:nvGrpSpPr>
-        <p:cNvPr id="1" name=""/>
-        <p:cNvGrpSpPr/>
-        <p:nvPr/>
-      </p:nvGrpSpPr>
-      <p:grpSpPr>
-        <a:xfrm>
-          <a:off x="0" y="0"/>
-          <a:ext cx="0" cy="0"/>
-          <a:chOff x="0" y="0"/>
-          <a:chExt cx="0" cy="0"/>
-        </a:xfrm>
-      </p:grpSpPr>
-      <p:sp>
-        <p:nvSpPr>
-          <p:cNvPr id="2" name="Title 1">
-            <a:extLst>
-              <a:ext uri="{FF2B5EF4-FFF2-40B4-BE49-F238E27FC236}">
-                <a16:creationId xmlns:a16="http://schemas.microsoft.com/office/drawing/2014/main" id="{9BDFD261-0D2C-41B9-9E28-43DF575D40E0}"/>
-              </a:ext>
-            </a:extLst>
-          </p:cNvPr>
-          <p:cNvSpPr>
-            <a:spLocks noGrp="1"/>
-          </p:cNvSpPr>
-          <p:nvPr>
-            <p:ph type="title"/>
-          </p:nvPr>
-        </p:nvSpPr>
-        <p:spPr/>
-        <p:txBody>
-          <a:bodyPr>
-            <a:normAutofit/>
-          </a:bodyPr>
-          <a:lstStyle/>
-          <a:p>
-            <a:r>
-              <a:rPr lang="nl-NL" sz="3600" noProof="0" dirty="0"/>
-              <a:t>Entiteiten in tabellen</a:t>
-            </a:r>
-          </a:p>
-        </p:txBody>
-      </p:sp>
-      <p:sp>
-        <p:nvSpPr>
-          <p:cNvPr id="3" name="Content Placeholder 2">
-            <a:extLst>
-              <a:ext uri="{FF2B5EF4-FFF2-40B4-BE49-F238E27FC236}">
-                <a16:creationId xmlns:a16="http://schemas.microsoft.com/office/drawing/2014/main" id="{7844B503-C44F-453E-9465-D42E4557DE0C}"/>
-              </a:ext>
-            </a:extLst>
-          </p:cNvPr>
-          <p:cNvSpPr>
-            <a:spLocks noGrp="1"/>
-          </p:cNvSpPr>
-          <p:nvPr>
-            <p:ph idx="1"/>
-          </p:nvPr>
-        </p:nvSpPr>
-        <p:spPr>
-          <a:xfrm>
-            <a:off x="838199" y="1825625"/>
-            <a:ext cx="10442825" cy="4351338"/>
-          </a:xfrm>
-        </p:spPr>
-        <p:txBody>
-          <a:bodyPr>
-            <a:normAutofit/>
-          </a:bodyPr>
-          <a:lstStyle/>
-          <a:p>
-            <a:pPr marL="0" indent="0">
-              <a:buNone/>
-            </a:pPr>
-            <a:r>
-              <a:rPr lang="nl-NL" sz="2000" noProof="0" dirty="0"/>
-              <a:t>Entiteiten en hun attributen slaan we op in tabellen:</a:t>
-            </a:r>
-          </a:p>
-          <a:p>
-            <a:pPr marL="0" indent="0">
-              <a:buNone/>
-            </a:pPr>
-            <a:endParaRPr lang="nl-NL" sz="2000" noProof="0" dirty="0"/>
-          </a:p>
-          <a:p>
-            <a:pPr marL="0" indent="0">
-              <a:buNone/>
-            </a:pPr>
-            <a:endParaRPr lang="nl-NL" sz="2000" noProof="0" dirty="0"/>
-          </a:p>
-        </p:txBody>
-      </p:sp>
-      <p:graphicFrame>
-        <p:nvGraphicFramePr>
-          <p:cNvPr id="4" name="Table 5">
-            <a:extLst>
-              <a:ext uri="{FF2B5EF4-FFF2-40B4-BE49-F238E27FC236}">
-                <a16:creationId xmlns:a16="http://schemas.microsoft.com/office/drawing/2014/main" id="{62CA46F3-D9D4-4F4A-856A-A943EE0F0F0C}"/>
-              </a:ext>
-            </a:extLst>
-          </p:cNvPr>
-          <p:cNvGraphicFramePr>
-            <a:graphicFrameLocks noGrp="1"/>
-          </p:cNvGraphicFramePr>
-          <p:nvPr>
-            <p:extLst>
-              <p:ext uri="{D42A27DB-BD31-4B8C-83A1-F6EECF244321}">
-                <p14:modId xmlns:p14="http://schemas.microsoft.com/office/powerpoint/2010/main" val="798112305"/>
-              </p:ext>
-            </p:extLst>
-          </p:nvPr>
-        </p:nvGraphicFramePr>
-        <p:xfrm>
-          <a:off x="989028" y="2928721"/>
-          <a:ext cx="1820160" cy="1849120"/>
-        </p:xfrm>
-        <a:graphic>
-          <a:graphicData uri="http://schemas.openxmlformats.org/drawingml/2006/table">
-            <a:tbl>
-              <a:tblPr firstRow="1" bandRow="1">
-                <a:tableStyleId>{5C22544A-7EE6-4342-B048-85BDC9FD1C3A}</a:tableStyleId>
-              </a:tblPr>
-              <a:tblGrid>
-                <a:gridCol w="1820160">
-                  <a:extLst>
-                    <a:ext uri="{9D8B030D-6E8A-4147-A177-3AD203B41FA5}">
-                      <a16:colId xmlns:a16="http://schemas.microsoft.com/office/drawing/2014/main" val="2508677333"/>
-                    </a:ext>
-                  </a:extLst>
-                </a:gridCol>
-              </a:tblGrid>
-              <a:tr h="0">
-                <a:tc>
-                  <a:txBody>
-                    <a:bodyPr/>
-                    <a:lstStyle/>
-                    <a:p>
-                      <a:r>
-                        <a:rPr lang="nl-NL" noProof="0" dirty="0"/>
-                        <a:t>Klanten</a:t>
-                      </a:r>
-                    </a:p>
-                  </a:txBody>
-                  <a:tcPr/>
-                </a:tc>
-                <a:extLst>
-                  <a:ext uri="{0D108BD9-81ED-4DB2-BD59-A6C34878D82A}">
-                    <a16:rowId xmlns:a16="http://schemas.microsoft.com/office/drawing/2014/main" val="858791041"/>
-                  </a:ext>
-                </a:extLst>
-              </a:tr>
-              <a:tr h="370840">
-                <a:tc>
-                  <a:txBody>
-                    <a:bodyPr/>
-                    <a:lstStyle/>
-                    <a:p>
-                      <a:r>
-                        <a:rPr lang="nl-NL" b="0" noProof="0" dirty="0" err="1"/>
-                        <a:t>KlantID</a:t>
-                      </a:r>
-                      <a:endParaRPr lang="nl-NL" b="0" noProof="0" dirty="0"/>
-                    </a:p>
-                  </a:txBody>
-                  <a:tcPr/>
-                </a:tc>
-                <a:extLst>
-                  <a:ext uri="{0D108BD9-81ED-4DB2-BD59-A6C34878D82A}">
-                    <a16:rowId xmlns:a16="http://schemas.microsoft.com/office/drawing/2014/main" val="1538811982"/>
-                  </a:ext>
-                </a:extLst>
-              </a:tr>
-              <a:tr h="370840">
-                <a:tc>
-                  <a:txBody>
-                    <a:bodyPr/>
-                    <a:lstStyle/>
-                    <a:p>
-                      <a:r>
-                        <a:rPr lang="nl-NL" noProof="0" dirty="0"/>
-                        <a:t>Voornaam</a:t>
-                      </a:r>
-                    </a:p>
-                  </a:txBody>
-                  <a:tcPr/>
-                </a:tc>
-                <a:extLst>
-                  <a:ext uri="{0D108BD9-81ED-4DB2-BD59-A6C34878D82A}">
-                    <a16:rowId xmlns:a16="http://schemas.microsoft.com/office/drawing/2014/main" val="3674785774"/>
-                  </a:ext>
-                </a:extLst>
-              </a:tr>
-              <a:tr h="370840">
-                <a:tc>
-                  <a:txBody>
-                    <a:bodyPr/>
-                    <a:lstStyle/>
-                    <a:p>
-                      <a:r>
-                        <a:rPr lang="nl-NL" noProof="0" dirty="0"/>
-                        <a:t>Achternaam</a:t>
-                      </a:r>
-                    </a:p>
-                  </a:txBody>
-                  <a:tcPr/>
-                </a:tc>
-                <a:extLst>
-                  <a:ext uri="{0D108BD9-81ED-4DB2-BD59-A6C34878D82A}">
-                    <a16:rowId xmlns:a16="http://schemas.microsoft.com/office/drawing/2014/main" val="2335262126"/>
-                  </a:ext>
-                </a:extLst>
-              </a:tr>
-              <a:tr h="370840">
-                <a:tc>
-                  <a:txBody>
-                    <a:bodyPr/>
-                    <a:lstStyle/>
-                    <a:p>
-                      <a:r>
-                        <a:rPr lang="nl-NL" noProof="0" dirty="0"/>
-                        <a:t>…</a:t>
-                      </a:r>
-                    </a:p>
-                  </a:txBody>
-                  <a:tcPr/>
-                </a:tc>
-                <a:extLst>
-                  <a:ext uri="{0D108BD9-81ED-4DB2-BD59-A6C34878D82A}">
-                    <a16:rowId xmlns:a16="http://schemas.microsoft.com/office/drawing/2014/main" val="2163937255"/>
-                  </a:ext>
-                </a:extLst>
-              </a:tr>
-            </a:tbl>
-          </a:graphicData>
-        </a:graphic>
-      </p:graphicFrame>
-      <p:graphicFrame>
-        <p:nvGraphicFramePr>
-          <p:cNvPr id="5" name="Table 5">
-            <a:extLst>
-              <a:ext uri="{FF2B5EF4-FFF2-40B4-BE49-F238E27FC236}">
-                <a16:creationId xmlns:a16="http://schemas.microsoft.com/office/drawing/2014/main" id="{2F81CE1D-F9ED-02C0-0A6D-49B2EC941B4F}"/>
-              </a:ext>
-            </a:extLst>
-          </p:cNvPr>
-          <p:cNvGraphicFramePr>
-            <a:graphicFrameLocks noGrp="1"/>
-          </p:cNvGraphicFramePr>
-          <p:nvPr>
-            <p:extLst>
-              <p:ext uri="{D42A27DB-BD31-4B8C-83A1-F6EECF244321}">
-                <p14:modId xmlns:p14="http://schemas.microsoft.com/office/powerpoint/2010/main" val="1399094275"/>
-              </p:ext>
-            </p:extLst>
-          </p:nvPr>
-        </p:nvGraphicFramePr>
-        <p:xfrm>
-          <a:off x="4275840" y="2928721"/>
-          <a:ext cx="1820160" cy="1849120"/>
-        </p:xfrm>
-        <a:graphic>
-          <a:graphicData uri="http://schemas.openxmlformats.org/drawingml/2006/table">
-            <a:tbl>
-              <a:tblPr firstRow="1" bandRow="1">
-                <a:tableStyleId>{5C22544A-7EE6-4342-B048-85BDC9FD1C3A}</a:tableStyleId>
-              </a:tblPr>
-              <a:tblGrid>
-                <a:gridCol w="1820160">
-                  <a:extLst>
-                    <a:ext uri="{9D8B030D-6E8A-4147-A177-3AD203B41FA5}">
-                      <a16:colId xmlns:a16="http://schemas.microsoft.com/office/drawing/2014/main" val="2508677333"/>
-                    </a:ext>
-                  </a:extLst>
-                </a:gridCol>
-              </a:tblGrid>
-              <a:tr h="0">
-                <a:tc>
-                  <a:txBody>
-                    <a:bodyPr/>
-                    <a:lstStyle/>
-                    <a:p>
-                      <a:r>
-                        <a:rPr lang="nl-NL" noProof="0" dirty="0"/>
-                        <a:t>Transacties</a:t>
-                      </a:r>
-                    </a:p>
-                  </a:txBody>
-                  <a:tcPr/>
-                </a:tc>
-                <a:extLst>
-                  <a:ext uri="{0D108BD9-81ED-4DB2-BD59-A6C34878D82A}">
-                    <a16:rowId xmlns:a16="http://schemas.microsoft.com/office/drawing/2014/main" val="858791041"/>
-                  </a:ext>
-                </a:extLst>
-              </a:tr>
-              <a:tr h="370840">
-                <a:tc>
-                  <a:txBody>
-                    <a:bodyPr/>
-                    <a:lstStyle/>
-                    <a:p>
-                      <a:r>
-                        <a:rPr lang="nl-NL" b="0" noProof="0" dirty="0" err="1"/>
-                        <a:t>KlantID</a:t>
-                      </a:r>
-                      <a:endParaRPr lang="nl-NL" b="0" noProof="0" dirty="0"/>
-                    </a:p>
-                  </a:txBody>
-                  <a:tcPr/>
-                </a:tc>
-                <a:extLst>
-                  <a:ext uri="{0D108BD9-81ED-4DB2-BD59-A6C34878D82A}">
-                    <a16:rowId xmlns:a16="http://schemas.microsoft.com/office/drawing/2014/main" val="1538811982"/>
-                  </a:ext>
-                </a:extLst>
-              </a:tr>
-              <a:tr h="370840">
-                <a:tc>
-                  <a:txBody>
-                    <a:bodyPr/>
-                    <a:lstStyle/>
-                    <a:p>
-                      <a:r>
-                        <a:rPr lang="nl-NL" b="0" noProof="0" dirty="0" err="1"/>
-                        <a:t>ProductID</a:t>
-                      </a:r>
-                      <a:endParaRPr lang="nl-NL" b="0" noProof="0" dirty="0"/>
-                    </a:p>
-                  </a:txBody>
-                  <a:tcPr/>
-                </a:tc>
-                <a:extLst>
-                  <a:ext uri="{0D108BD9-81ED-4DB2-BD59-A6C34878D82A}">
-                    <a16:rowId xmlns:a16="http://schemas.microsoft.com/office/drawing/2014/main" val="3674785774"/>
-                  </a:ext>
-                </a:extLst>
-              </a:tr>
-              <a:tr h="370840">
-                <a:tc>
-                  <a:txBody>
-                    <a:bodyPr/>
-                    <a:lstStyle/>
-                    <a:p>
-                      <a:r>
-                        <a:rPr lang="nl-NL" noProof="0" dirty="0"/>
-                        <a:t>Aantal</a:t>
-                      </a:r>
-                    </a:p>
-                  </a:txBody>
-                  <a:tcPr/>
-                </a:tc>
-                <a:extLst>
-                  <a:ext uri="{0D108BD9-81ED-4DB2-BD59-A6C34878D82A}">
-                    <a16:rowId xmlns:a16="http://schemas.microsoft.com/office/drawing/2014/main" val="2335262126"/>
-                  </a:ext>
-                </a:extLst>
-              </a:tr>
-              <a:tr h="370840">
-                <a:tc>
-                  <a:txBody>
-                    <a:bodyPr/>
-                    <a:lstStyle/>
-                    <a:p>
-                      <a:r>
-                        <a:rPr lang="nl-NL" noProof="0" dirty="0"/>
-                        <a:t>…</a:t>
-                      </a:r>
-                    </a:p>
-                  </a:txBody>
-                  <a:tcPr/>
-                </a:tc>
-                <a:extLst>
-                  <a:ext uri="{0D108BD9-81ED-4DB2-BD59-A6C34878D82A}">
-                    <a16:rowId xmlns:a16="http://schemas.microsoft.com/office/drawing/2014/main" val="2163937255"/>
-                  </a:ext>
-                </a:extLst>
-              </a:tr>
-            </a:tbl>
-          </a:graphicData>
-        </a:graphic>
-      </p:graphicFrame>
-      <p:graphicFrame>
-        <p:nvGraphicFramePr>
-          <p:cNvPr id="8" name="Table 5">
-            <a:extLst>
-              <a:ext uri="{FF2B5EF4-FFF2-40B4-BE49-F238E27FC236}">
-                <a16:creationId xmlns:a16="http://schemas.microsoft.com/office/drawing/2014/main" id="{F4917DC8-4826-215A-40A2-62AE8EF1EFDB}"/>
-              </a:ext>
-            </a:extLst>
-          </p:cNvPr>
-          <p:cNvGraphicFramePr>
-            <a:graphicFrameLocks noGrp="1"/>
-          </p:cNvGraphicFramePr>
-          <p:nvPr>
-            <p:extLst>
-              <p:ext uri="{D42A27DB-BD31-4B8C-83A1-F6EECF244321}">
-                <p14:modId xmlns:p14="http://schemas.microsoft.com/office/powerpoint/2010/main" val="2944981733"/>
-              </p:ext>
-            </p:extLst>
-          </p:nvPr>
-        </p:nvGraphicFramePr>
-        <p:xfrm>
-          <a:off x="7562652" y="2928721"/>
-          <a:ext cx="1820160" cy="1849120"/>
-        </p:xfrm>
-        <a:graphic>
-          <a:graphicData uri="http://schemas.openxmlformats.org/drawingml/2006/table">
-            <a:tbl>
-              <a:tblPr firstRow="1" bandRow="1">
-                <a:tableStyleId>{5C22544A-7EE6-4342-B048-85BDC9FD1C3A}</a:tableStyleId>
-              </a:tblPr>
-              <a:tblGrid>
-                <a:gridCol w="1820160">
-                  <a:extLst>
-                    <a:ext uri="{9D8B030D-6E8A-4147-A177-3AD203B41FA5}">
-                      <a16:colId xmlns:a16="http://schemas.microsoft.com/office/drawing/2014/main" val="2508677333"/>
-                    </a:ext>
-                  </a:extLst>
-                </a:gridCol>
-              </a:tblGrid>
-              <a:tr h="0">
-                <a:tc>
-                  <a:txBody>
-                    <a:bodyPr/>
-                    <a:lstStyle/>
-                    <a:p>
-                      <a:r>
-                        <a:rPr lang="nl-NL" noProof="0" dirty="0"/>
-                        <a:t>Producten</a:t>
-                      </a:r>
-                    </a:p>
-                  </a:txBody>
-                  <a:tcPr/>
-                </a:tc>
-                <a:extLst>
-                  <a:ext uri="{0D108BD9-81ED-4DB2-BD59-A6C34878D82A}">
-                    <a16:rowId xmlns:a16="http://schemas.microsoft.com/office/drawing/2014/main" val="858791041"/>
-                  </a:ext>
-                </a:extLst>
-              </a:tr>
-              <a:tr h="370840">
-                <a:tc>
-                  <a:txBody>
-                    <a:bodyPr/>
-                    <a:lstStyle/>
-                    <a:p>
-                      <a:r>
-                        <a:rPr lang="nl-NL" b="0" noProof="0" dirty="0" err="1"/>
-                        <a:t>ProductID</a:t>
-                      </a:r>
-                      <a:endParaRPr lang="nl-NL" b="0" noProof="0" dirty="0"/>
-                    </a:p>
-                  </a:txBody>
-                  <a:tcPr/>
-                </a:tc>
-                <a:extLst>
-                  <a:ext uri="{0D108BD9-81ED-4DB2-BD59-A6C34878D82A}">
-                    <a16:rowId xmlns:a16="http://schemas.microsoft.com/office/drawing/2014/main" val="1538811982"/>
-                  </a:ext>
-                </a:extLst>
-              </a:tr>
-              <a:tr h="370840">
-                <a:tc>
-                  <a:txBody>
-                    <a:bodyPr/>
-                    <a:lstStyle/>
-                    <a:p>
-                      <a:r>
-                        <a:rPr lang="nl-NL" noProof="0" dirty="0"/>
-                        <a:t>Naam</a:t>
-                      </a:r>
-                    </a:p>
-                  </a:txBody>
-                  <a:tcPr/>
-                </a:tc>
-                <a:extLst>
-                  <a:ext uri="{0D108BD9-81ED-4DB2-BD59-A6C34878D82A}">
-                    <a16:rowId xmlns:a16="http://schemas.microsoft.com/office/drawing/2014/main" val="3674785774"/>
-                  </a:ext>
-                </a:extLst>
-              </a:tr>
-              <a:tr h="370840">
-                <a:tc>
-                  <a:txBody>
-                    <a:bodyPr/>
-                    <a:lstStyle/>
-                    <a:p>
-                      <a:r>
-                        <a:rPr lang="nl-NL" noProof="0" dirty="0"/>
-                        <a:t>Omschrijving</a:t>
-                      </a:r>
-                    </a:p>
-                  </a:txBody>
-                  <a:tcPr/>
-                </a:tc>
-                <a:extLst>
-                  <a:ext uri="{0D108BD9-81ED-4DB2-BD59-A6C34878D82A}">
-                    <a16:rowId xmlns:a16="http://schemas.microsoft.com/office/drawing/2014/main" val="2335262126"/>
-                  </a:ext>
-                </a:extLst>
-              </a:tr>
-              <a:tr h="370840">
-                <a:tc>
-                  <a:txBody>
-                    <a:bodyPr/>
-                    <a:lstStyle/>
-                    <a:p>
-                      <a:r>
-                        <a:rPr lang="nl-NL" noProof="0" dirty="0"/>
-                        <a:t>…</a:t>
-                      </a:r>
-                    </a:p>
-                  </a:txBody>
-                  <a:tcPr/>
-                </a:tc>
-                <a:extLst>
-                  <a:ext uri="{0D108BD9-81ED-4DB2-BD59-A6C34878D82A}">
-                    <a16:rowId xmlns:a16="http://schemas.microsoft.com/office/drawing/2014/main" val="2163937255"/>
-                  </a:ext>
-                </a:extLst>
-              </a:tr>
-            </a:tbl>
-          </a:graphicData>
-        </a:graphic>
-      </p:graphicFrame>
-    </p:spTree>
-    <p:extLst>
-      <p:ext uri="{BB962C8B-B14F-4D97-AF65-F5344CB8AC3E}">
-        <p14:creationId xmlns:p14="http://schemas.microsoft.com/office/powerpoint/2010/main" val="2320990652"/>
-      </p:ext>
-    </p:extLst>
-  </p:cSld>
-  <p:clrMapOvr>
-    <a:masterClrMapping/>
-  </p:clrMapOvr>
-</p:sld>
-</file>
-
-<file path=ppt/slides/slide40.xml><?xml version="1.0" encoding="utf-8"?>
+<file path=ppt/slides/slide41.xml><?xml version="1.0" encoding="utf-8"?>
 <p:sld xmlns:a="http://schemas.openxmlformats.org/drawingml/2006/main" xmlns:r="http://schemas.openxmlformats.org/officeDocument/2006/relationships" xmlns:p="http://schemas.openxmlformats.org/presentationml/2006/main">
   <p:cSld>
     <p:spTree>
@@ -26057,7 +26204,7 @@
 </p:sld>
 </file>
 
-<file path=ppt/slides/slide41.xml><?xml version="1.0" encoding="utf-8"?>
+<file path=ppt/slides/slide42.xml><?xml version="1.0" encoding="utf-8"?>
 <p:sld xmlns:a="http://schemas.openxmlformats.org/drawingml/2006/main" xmlns:r="http://schemas.openxmlformats.org/officeDocument/2006/relationships" xmlns:p="http://schemas.openxmlformats.org/presentationml/2006/main">
   <p:cSld>
     <p:spTree>
@@ -26575,7 +26722,7 @@
 </p:sld>
 </file>
 
-<file path=ppt/slides/slide42.xml><?xml version="1.0" encoding="utf-8"?>
+<file path=ppt/slides/slide43.xml><?xml version="1.0" encoding="utf-8"?>
 <p:sld xmlns:a="http://schemas.openxmlformats.org/drawingml/2006/main" xmlns:r="http://schemas.openxmlformats.org/officeDocument/2006/relationships" xmlns:p="http://schemas.openxmlformats.org/presentationml/2006/main">
   <p:cSld>
     <p:spTree>
@@ -27080,7 +27227,7 @@
 </p:sld>
 </file>
 
-<file path=ppt/slides/slide43.xml><?xml version="1.0" encoding="utf-8"?>
+<file path=ppt/slides/slide44.xml><?xml version="1.0" encoding="utf-8"?>
 <p:sld xmlns:a="http://schemas.openxmlformats.org/drawingml/2006/main" xmlns:r="http://schemas.openxmlformats.org/officeDocument/2006/relationships" xmlns:p="http://schemas.openxmlformats.org/presentationml/2006/main">
   <p:cSld>
     <p:spTree>
@@ -27651,7 +27798,7 @@
 </p:sld>
 </file>
 
-<file path=ppt/slides/slide44.xml><?xml version="1.0" encoding="utf-8"?>
+<file path=ppt/slides/slide45.xml><?xml version="1.0" encoding="utf-8"?>
 <p:sld xmlns:a="http://schemas.openxmlformats.org/drawingml/2006/main" xmlns:r="http://schemas.openxmlformats.org/officeDocument/2006/relationships" xmlns:p="http://schemas.openxmlformats.org/presentationml/2006/main">
   <p:cSld>
     <p:spTree>
@@ -28213,7 +28360,7 @@
 </p:sld>
 </file>
 
-<file path=ppt/slides/slide45.xml><?xml version="1.0" encoding="utf-8"?>
+<file path=ppt/slides/slide46.xml><?xml version="1.0" encoding="utf-8"?>
 <p:sld xmlns:a="http://schemas.openxmlformats.org/drawingml/2006/main" xmlns:r="http://schemas.openxmlformats.org/officeDocument/2006/relationships" xmlns:p="http://schemas.openxmlformats.org/presentationml/2006/main">
   <p:cSld>
     <p:spTree>
@@ -28288,7 +28435,7 @@
             </a:pPr>
             <a:r>
               <a:rPr lang="nl-NL" sz="2000" noProof="0" dirty="0"/>
-              <a:t>In oefening 2 heb je een ERD gemaakt voor de ledenadministratie van een sportclub:</a:t>
+              <a:t>In oefening 2 heb je database ontwerp gemaakt voor een sportclub:</a:t>
             </a:r>
           </a:p>
           <a:p>
@@ -28387,7 +28534,7 @@
 </p:sld>
 </file>
 
-<file path=ppt/slides/slide46.xml><?xml version="1.0" encoding="utf-8"?>
+<file path=ppt/slides/slide47.xml><?xml version="1.0" encoding="utf-8"?>
 <p:sld xmlns:a="http://schemas.openxmlformats.org/drawingml/2006/main" xmlns:r="http://schemas.openxmlformats.org/officeDocument/2006/relationships" xmlns:p="http://schemas.openxmlformats.org/presentationml/2006/main">
   <p:cSld>
     <p:spTree>
@@ -29736,7 +29883,7 @@
 </p:sld>
 </file>
 
-<file path=ppt/slides/slide47.xml><?xml version="1.0" encoding="utf-8"?>
+<file path=ppt/slides/slide48.xml><?xml version="1.0" encoding="utf-8"?>
 <p:sld xmlns:a="http://schemas.openxmlformats.org/drawingml/2006/main" xmlns:r="http://schemas.openxmlformats.org/officeDocument/2006/relationships" xmlns:p="http://schemas.openxmlformats.org/presentationml/2006/main">
   <p:cSld>
     <p:spTree>
@@ -30468,7 +30615,7 @@
 </p:sld>
 </file>
 
-<file path=ppt/slides/slide48.xml><?xml version="1.0" encoding="utf-8"?>
+<file path=ppt/slides/slide49.xml><?xml version="1.0" encoding="utf-8"?>
 <p:sld xmlns:a="http://schemas.openxmlformats.org/drawingml/2006/main" xmlns:r="http://schemas.openxmlformats.org/officeDocument/2006/relationships" xmlns:p="http://schemas.openxmlformats.org/presentationml/2006/main">
   <p:cSld>
     <p:spTree>
@@ -30912,225 +31059,6 @@
 </p:sld>
 </file>
 
-<file path=ppt/slides/slide49.xml><?xml version="1.0" encoding="utf-8"?>
-<p:sld xmlns:a="http://schemas.openxmlformats.org/drawingml/2006/main" xmlns:r="http://schemas.openxmlformats.org/officeDocument/2006/relationships" xmlns:p="http://schemas.openxmlformats.org/presentationml/2006/main">
-  <p:cSld>
-    <p:spTree>
-      <p:nvGrpSpPr>
-        <p:cNvPr id="1" name="">
-          <a:extLst>
-            <a:ext uri="{FF2B5EF4-FFF2-40B4-BE49-F238E27FC236}">
-              <a16:creationId xmlns:a16="http://schemas.microsoft.com/office/drawing/2014/main" id="{19564467-1EE1-4316-7245-EFD687D29E19}"/>
-            </a:ext>
-          </a:extLst>
-        </p:cNvPr>
-        <p:cNvGrpSpPr/>
-        <p:nvPr/>
-      </p:nvGrpSpPr>
-      <p:grpSpPr>
-        <a:xfrm>
-          <a:off x="0" y="0"/>
-          <a:ext cx="0" cy="0"/>
-          <a:chOff x="0" y="0"/>
-          <a:chExt cx="0" cy="0"/>
-        </a:xfrm>
-      </p:grpSpPr>
-      <p:sp>
-        <p:nvSpPr>
-          <p:cNvPr id="2" name="Title 1">
-            <a:extLst>
-              <a:ext uri="{FF2B5EF4-FFF2-40B4-BE49-F238E27FC236}">
-                <a16:creationId xmlns:a16="http://schemas.microsoft.com/office/drawing/2014/main" id="{802279B3-C753-1AD7-9185-2D260280E76E}"/>
-              </a:ext>
-            </a:extLst>
-          </p:cNvPr>
-          <p:cNvSpPr>
-            <a:spLocks noGrp="1"/>
-          </p:cNvSpPr>
-          <p:nvPr>
-            <p:ph type="title"/>
-          </p:nvPr>
-        </p:nvSpPr>
-        <p:spPr/>
-        <p:txBody>
-          <a:bodyPr>
-            <a:normAutofit/>
-          </a:bodyPr>
-          <a:lstStyle/>
-          <a:p>
-            <a:r>
-              <a:rPr lang="nl-NL" sz="3600" noProof="0" dirty="0"/>
-              <a:t>Oefeningen 4</a:t>
-            </a:r>
-          </a:p>
-        </p:txBody>
-      </p:sp>
-      <p:sp>
-        <p:nvSpPr>
-          <p:cNvPr id="3" name="Content Placeholder 2">
-            <a:extLst>
-              <a:ext uri="{FF2B5EF4-FFF2-40B4-BE49-F238E27FC236}">
-                <a16:creationId xmlns:a16="http://schemas.microsoft.com/office/drawing/2014/main" id="{1EFB231B-AE1B-9FB5-5024-7906C86A4E77}"/>
-              </a:ext>
-            </a:extLst>
-          </p:cNvPr>
-          <p:cNvSpPr>
-            <a:spLocks noGrp="1"/>
-          </p:cNvSpPr>
-          <p:nvPr>
-            <p:ph idx="1"/>
-          </p:nvPr>
-        </p:nvSpPr>
-        <p:spPr/>
-        <p:txBody>
-          <a:bodyPr>
-            <a:noAutofit/>
-          </a:bodyPr>
-          <a:lstStyle/>
-          <a:p>
-            <a:pPr marL="0" indent="0">
-              <a:buNone/>
-            </a:pPr>
-            <a:r>
-              <a:rPr lang="nl-NL" sz="2000" noProof="0" dirty="0"/>
-              <a:t>Open </a:t>
-            </a:r>
-            <a:r>
-              <a:rPr lang="nl-NL" sz="2000" noProof="0" dirty="0">
-                <a:latin typeface="Courier New" panose="02070309020205020404" pitchFamily="49" charset="0"/>
-                <a:cs typeface="Courier New" panose="02070309020205020404" pitchFamily="49" charset="0"/>
-              </a:rPr>
-              <a:t>0_data/</a:t>
-            </a:r>
-            <a:r>
-              <a:rPr lang="nl-NL" sz="2000" noProof="0" dirty="0" err="1">
-                <a:latin typeface="Courier New" panose="02070309020205020404" pitchFamily="49" charset="0"/>
-                <a:cs typeface="Courier New" panose="02070309020205020404" pitchFamily="49" charset="0"/>
-              </a:rPr>
-              <a:t>sales_data</a:t>
-            </a:r>
-            <a:r>
-              <a:rPr lang="nl-NL" sz="2000" dirty="0">
-                <a:latin typeface="Courier New" panose="02070309020205020404" pitchFamily="49" charset="0"/>
-                <a:cs typeface="Courier New" panose="02070309020205020404" pitchFamily="49" charset="0"/>
-              </a:rPr>
-              <a:t>.</a:t>
-            </a:r>
-            <a:r>
-              <a:rPr lang="nl-NL" sz="2000" dirty="0" err="1">
-                <a:latin typeface="Courier New" panose="02070309020205020404" pitchFamily="49" charset="0"/>
-                <a:cs typeface="Courier New" panose="02070309020205020404" pitchFamily="49" charset="0"/>
-              </a:rPr>
-              <a:t>db</a:t>
-            </a:r>
-            <a:r>
-              <a:rPr lang="nl-NL" sz="2000" dirty="0"/>
-              <a:t> en maak de volgende views:</a:t>
-            </a:r>
-            <a:endParaRPr lang="nl-NL" sz="2000" noProof="0" dirty="0"/>
-          </a:p>
-          <a:p>
-            <a:pPr>
-              <a:buFontTx/>
-              <a:buChar char="-"/>
-            </a:pPr>
-            <a:endParaRPr lang="nl-NL" sz="2000" noProof="0" dirty="0"/>
-          </a:p>
-          <a:p>
-            <a:pPr>
-              <a:buFontTx/>
-              <a:buChar char="-"/>
-            </a:pPr>
-            <a:r>
-              <a:rPr lang="nl-NL" sz="2000" dirty="0"/>
-              <a:t>Het aantal verkochte producten en de omzet per transactie</a:t>
-            </a:r>
-            <a:r>
-              <a:rPr lang="nl-NL" sz="2000" noProof="0" dirty="0"/>
-              <a:t>.</a:t>
-            </a:r>
-          </a:p>
-          <a:p>
-            <a:pPr>
-              <a:buFontTx/>
-              <a:buChar char="-"/>
-            </a:pPr>
-            <a:endParaRPr lang="nl-NL" sz="2000" noProof="0" dirty="0"/>
-          </a:p>
-          <a:p>
-            <a:pPr>
-              <a:buFontTx/>
-              <a:buChar char="-"/>
-            </a:pPr>
-            <a:r>
-              <a:rPr lang="nl-NL" sz="2000" noProof="0" dirty="0"/>
-              <a:t>Het aantal transacties en de totale omzet per klant en per maand.</a:t>
-            </a:r>
-          </a:p>
-          <a:p>
-            <a:pPr>
-              <a:buFontTx/>
-              <a:buChar char="-"/>
-            </a:pPr>
-            <a:endParaRPr lang="nl-NL" sz="2000" dirty="0"/>
-          </a:p>
-          <a:p>
-            <a:pPr>
-              <a:buFontTx/>
-              <a:buChar char="-"/>
-            </a:pPr>
-            <a:r>
-              <a:rPr lang="nl-NL" sz="2000" dirty="0"/>
-              <a:t>De totale omzet per klant, aflopend gesorteerd op omzet.</a:t>
-            </a:r>
-          </a:p>
-          <a:p>
-            <a:pPr marL="0" indent="0">
-              <a:buNone/>
-            </a:pPr>
-            <a:endParaRPr lang="nl-NL" sz="2000" noProof="0" dirty="0"/>
-          </a:p>
-          <a:p>
-            <a:pPr marL="0" indent="0">
-              <a:buNone/>
-            </a:pPr>
-            <a:endParaRPr lang="nl-NL" sz="2000" dirty="0"/>
-          </a:p>
-          <a:p>
-            <a:pPr marL="0" indent="0">
-              <a:buNone/>
-            </a:pPr>
-            <a:r>
-              <a:rPr lang="nl-NL" sz="2000" noProof="0" dirty="0"/>
-              <a:t>Tip: Schrijf eerst de </a:t>
-            </a:r>
-            <a:r>
-              <a:rPr lang="nl-NL" sz="2000" noProof="0" dirty="0">
-                <a:latin typeface="Courier New" panose="02070309020205020404" pitchFamily="49" charset="0"/>
-                <a:cs typeface="Courier New" panose="02070309020205020404" pitchFamily="49" charset="0"/>
-              </a:rPr>
-              <a:t>SELECT</a:t>
-            </a:r>
-            <a:r>
-              <a:rPr lang="nl-NL" sz="2000" noProof="0" dirty="0"/>
-              <a:t> en maak er dan pas een view van.</a:t>
-            </a:r>
-          </a:p>
-        </p:txBody>
-      </p:sp>
-    </p:spTree>
-    <p:extLst>
-      <p:ext uri="{BB962C8B-B14F-4D97-AF65-F5344CB8AC3E}">
-        <p14:creationId xmlns:p14="http://schemas.microsoft.com/office/powerpoint/2010/main" val="3472360893"/>
-      </p:ext>
-    </p:extLst>
-  </p:cSld>
-  <p:clrMapOvr>
-    <a:masterClrMapping/>
-  </p:clrMapOvr>
-</p:sld>
-</file>
-
 <file path=ppt/slides/slide5.xml><?xml version="1.0" encoding="utf-8"?>
 <p:sld xmlns:a="http://schemas.openxmlformats.org/drawingml/2006/main" xmlns:r="http://schemas.openxmlformats.org/officeDocument/2006/relationships" xmlns:p="http://schemas.openxmlformats.org/presentationml/2006/main">
   <p:cSld>
@@ -31750,6 +31678,225 @@
         <p:cNvPr id="1" name="">
           <a:extLst>
             <a:ext uri="{FF2B5EF4-FFF2-40B4-BE49-F238E27FC236}">
+              <a16:creationId xmlns:a16="http://schemas.microsoft.com/office/drawing/2014/main" id="{19564467-1EE1-4316-7245-EFD687D29E19}"/>
+            </a:ext>
+          </a:extLst>
+        </p:cNvPr>
+        <p:cNvGrpSpPr/>
+        <p:nvPr/>
+      </p:nvGrpSpPr>
+      <p:grpSpPr>
+        <a:xfrm>
+          <a:off x="0" y="0"/>
+          <a:ext cx="0" cy="0"/>
+          <a:chOff x="0" y="0"/>
+          <a:chExt cx="0" cy="0"/>
+        </a:xfrm>
+      </p:grpSpPr>
+      <p:sp>
+        <p:nvSpPr>
+          <p:cNvPr id="2" name="Title 1">
+            <a:extLst>
+              <a:ext uri="{FF2B5EF4-FFF2-40B4-BE49-F238E27FC236}">
+                <a16:creationId xmlns:a16="http://schemas.microsoft.com/office/drawing/2014/main" id="{802279B3-C753-1AD7-9185-2D260280E76E}"/>
+              </a:ext>
+            </a:extLst>
+          </p:cNvPr>
+          <p:cNvSpPr>
+            <a:spLocks noGrp="1"/>
+          </p:cNvSpPr>
+          <p:nvPr>
+            <p:ph type="title"/>
+          </p:nvPr>
+        </p:nvSpPr>
+        <p:spPr/>
+        <p:txBody>
+          <a:bodyPr>
+            <a:normAutofit/>
+          </a:bodyPr>
+          <a:lstStyle/>
+          <a:p>
+            <a:r>
+              <a:rPr lang="nl-NL" sz="3600" noProof="0" dirty="0"/>
+              <a:t>Oefeningen 4</a:t>
+            </a:r>
+          </a:p>
+        </p:txBody>
+      </p:sp>
+      <p:sp>
+        <p:nvSpPr>
+          <p:cNvPr id="3" name="Content Placeholder 2">
+            <a:extLst>
+              <a:ext uri="{FF2B5EF4-FFF2-40B4-BE49-F238E27FC236}">
+                <a16:creationId xmlns:a16="http://schemas.microsoft.com/office/drawing/2014/main" id="{1EFB231B-AE1B-9FB5-5024-7906C86A4E77}"/>
+              </a:ext>
+            </a:extLst>
+          </p:cNvPr>
+          <p:cNvSpPr>
+            <a:spLocks noGrp="1"/>
+          </p:cNvSpPr>
+          <p:nvPr>
+            <p:ph idx="1"/>
+          </p:nvPr>
+        </p:nvSpPr>
+        <p:spPr/>
+        <p:txBody>
+          <a:bodyPr>
+            <a:noAutofit/>
+          </a:bodyPr>
+          <a:lstStyle/>
+          <a:p>
+            <a:pPr marL="0" indent="0">
+              <a:buNone/>
+            </a:pPr>
+            <a:r>
+              <a:rPr lang="nl-NL" sz="2000" noProof="0" dirty="0"/>
+              <a:t>Open </a:t>
+            </a:r>
+            <a:r>
+              <a:rPr lang="nl-NL" sz="2000" noProof="0" dirty="0">
+                <a:latin typeface="Courier New" panose="02070309020205020404" pitchFamily="49" charset="0"/>
+                <a:cs typeface="Courier New" panose="02070309020205020404" pitchFamily="49" charset="0"/>
+              </a:rPr>
+              <a:t>0_data/</a:t>
+            </a:r>
+            <a:r>
+              <a:rPr lang="nl-NL" sz="2000" noProof="0" dirty="0" err="1">
+                <a:latin typeface="Courier New" panose="02070309020205020404" pitchFamily="49" charset="0"/>
+                <a:cs typeface="Courier New" panose="02070309020205020404" pitchFamily="49" charset="0"/>
+              </a:rPr>
+              <a:t>sales_data</a:t>
+            </a:r>
+            <a:r>
+              <a:rPr lang="nl-NL" sz="2000" dirty="0">
+                <a:latin typeface="Courier New" panose="02070309020205020404" pitchFamily="49" charset="0"/>
+                <a:cs typeface="Courier New" panose="02070309020205020404" pitchFamily="49" charset="0"/>
+              </a:rPr>
+              <a:t>.</a:t>
+            </a:r>
+            <a:r>
+              <a:rPr lang="nl-NL" sz="2000" dirty="0" err="1">
+                <a:latin typeface="Courier New" panose="02070309020205020404" pitchFamily="49" charset="0"/>
+                <a:cs typeface="Courier New" panose="02070309020205020404" pitchFamily="49" charset="0"/>
+              </a:rPr>
+              <a:t>db</a:t>
+            </a:r>
+            <a:r>
+              <a:rPr lang="nl-NL" sz="2000" dirty="0"/>
+              <a:t> en maak de volgende views:</a:t>
+            </a:r>
+            <a:endParaRPr lang="nl-NL" sz="2000" noProof="0" dirty="0"/>
+          </a:p>
+          <a:p>
+            <a:pPr>
+              <a:buFontTx/>
+              <a:buChar char="-"/>
+            </a:pPr>
+            <a:endParaRPr lang="nl-NL" sz="2000" noProof="0" dirty="0"/>
+          </a:p>
+          <a:p>
+            <a:pPr>
+              <a:buFontTx/>
+              <a:buChar char="-"/>
+            </a:pPr>
+            <a:r>
+              <a:rPr lang="nl-NL" sz="2000" dirty="0"/>
+              <a:t>Het aantal verkochte producten en de omzet per transactie</a:t>
+            </a:r>
+            <a:r>
+              <a:rPr lang="nl-NL" sz="2000" noProof="0" dirty="0"/>
+              <a:t>.</a:t>
+            </a:r>
+          </a:p>
+          <a:p>
+            <a:pPr>
+              <a:buFontTx/>
+              <a:buChar char="-"/>
+            </a:pPr>
+            <a:endParaRPr lang="nl-NL" sz="2000" noProof="0" dirty="0"/>
+          </a:p>
+          <a:p>
+            <a:pPr>
+              <a:buFontTx/>
+              <a:buChar char="-"/>
+            </a:pPr>
+            <a:r>
+              <a:rPr lang="nl-NL" sz="2000" noProof="0" dirty="0"/>
+              <a:t>Het aantal transacties en de totale omzet per klant en per maand.</a:t>
+            </a:r>
+          </a:p>
+          <a:p>
+            <a:pPr>
+              <a:buFontTx/>
+              <a:buChar char="-"/>
+            </a:pPr>
+            <a:endParaRPr lang="nl-NL" sz="2000" dirty="0"/>
+          </a:p>
+          <a:p>
+            <a:pPr>
+              <a:buFontTx/>
+              <a:buChar char="-"/>
+            </a:pPr>
+            <a:r>
+              <a:rPr lang="nl-NL" sz="2000" dirty="0"/>
+              <a:t>De totale omzet per klant, aflopend gesorteerd op omzet.</a:t>
+            </a:r>
+          </a:p>
+          <a:p>
+            <a:pPr marL="0" indent="0">
+              <a:buNone/>
+            </a:pPr>
+            <a:endParaRPr lang="nl-NL" sz="2000" noProof="0" dirty="0"/>
+          </a:p>
+          <a:p>
+            <a:pPr marL="0" indent="0">
+              <a:buNone/>
+            </a:pPr>
+            <a:endParaRPr lang="nl-NL" sz="2000" dirty="0"/>
+          </a:p>
+          <a:p>
+            <a:pPr marL="0" indent="0">
+              <a:buNone/>
+            </a:pPr>
+            <a:r>
+              <a:rPr lang="nl-NL" sz="2000" noProof="0" dirty="0"/>
+              <a:t>Tip: Schrijf eerst de </a:t>
+            </a:r>
+            <a:r>
+              <a:rPr lang="nl-NL" sz="2000" noProof="0" dirty="0">
+                <a:latin typeface="Courier New" panose="02070309020205020404" pitchFamily="49" charset="0"/>
+                <a:cs typeface="Courier New" panose="02070309020205020404" pitchFamily="49" charset="0"/>
+              </a:rPr>
+              <a:t>SELECT</a:t>
+            </a:r>
+            <a:r>
+              <a:rPr lang="nl-NL" sz="2000" noProof="0" dirty="0"/>
+              <a:t> en maak er dan pas een view van.</a:t>
+            </a:r>
+          </a:p>
+        </p:txBody>
+      </p:sp>
+    </p:spTree>
+    <p:extLst>
+      <p:ext uri="{BB962C8B-B14F-4D97-AF65-F5344CB8AC3E}">
+        <p14:creationId xmlns:p14="http://schemas.microsoft.com/office/powerpoint/2010/main" val="3472360893"/>
+      </p:ext>
+    </p:extLst>
+  </p:cSld>
+  <p:clrMapOvr>
+    <a:masterClrMapping/>
+  </p:clrMapOvr>
+</p:sld>
+</file>
+
+<file path=ppt/slides/slide51.xml><?xml version="1.0" encoding="utf-8"?>
+<p:sld xmlns:a="http://schemas.openxmlformats.org/drawingml/2006/main" xmlns:r="http://schemas.openxmlformats.org/officeDocument/2006/relationships" xmlns:p="http://schemas.openxmlformats.org/presentationml/2006/main">
+  <p:cSld>
+    <p:spTree>
+      <p:nvGrpSpPr>
+        <p:cNvPr id="1" name="">
+          <a:extLst>
+            <a:ext uri="{FF2B5EF4-FFF2-40B4-BE49-F238E27FC236}">
               <a16:creationId xmlns:a16="http://schemas.microsoft.com/office/drawing/2014/main" id="{42F01F3E-CB49-03B6-A9A1-EF324F50C3A5}"/>
             </a:ext>
           </a:extLst>
@@ -31833,7 +31980,7 @@
 </p:sld>
 </file>
 
-<file path=ppt/slides/slide51.xml><?xml version="1.0" encoding="utf-8"?>
+<file path=ppt/slides/slide52.xml><?xml version="1.0" encoding="utf-8"?>
 <p:sld xmlns:a="http://schemas.openxmlformats.org/drawingml/2006/main" xmlns:r="http://schemas.openxmlformats.org/officeDocument/2006/relationships" xmlns:p="http://schemas.openxmlformats.org/presentationml/2006/main">
   <p:cSld>
     <p:spTree>
@@ -32895,7 +33042,7 @@
 </p:sld>
 </file>
 
-<file path=ppt/slides/slide52.xml><?xml version="1.0" encoding="utf-8"?>
+<file path=ppt/slides/slide53.xml><?xml version="1.0" encoding="utf-8"?>
 <p:sld xmlns:a="http://schemas.openxmlformats.org/drawingml/2006/main" xmlns:r="http://schemas.openxmlformats.org/officeDocument/2006/relationships" xmlns:p="http://schemas.openxmlformats.org/presentationml/2006/main">
   <p:cSld>
     <p:spTree>
@@ -33900,7 +34047,7 @@
 </p:sld>
 </file>
 
-<file path=ppt/slides/slide53.xml><?xml version="1.0" encoding="utf-8"?>
+<file path=ppt/slides/slide54.xml><?xml version="1.0" encoding="utf-8"?>
 <p:sld xmlns:a="http://schemas.openxmlformats.org/drawingml/2006/main" xmlns:r="http://schemas.openxmlformats.org/officeDocument/2006/relationships" xmlns:p="http://schemas.openxmlformats.org/presentationml/2006/main">
   <p:cSld>
     <p:spTree>
@@ -35706,7 +35853,7 @@
 </p:sld>
 </file>
 
-<file path=ppt/slides/slide54.xml><?xml version="1.0" encoding="utf-8"?>
+<file path=ppt/slides/slide55.xml><?xml version="1.0" encoding="utf-8"?>
 <p:sld xmlns:a="http://schemas.openxmlformats.org/drawingml/2006/main" xmlns:r="http://schemas.openxmlformats.org/officeDocument/2006/relationships" xmlns:p="http://schemas.openxmlformats.org/presentationml/2006/main">
   <p:cSld>
     <p:spTree>
@@ -37709,7 +37856,7 @@
 </p:sld>
 </file>
 
-<file path=ppt/slides/slide55.xml><?xml version="1.0" encoding="utf-8"?>
+<file path=ppt/slides/slide56.xml><?xml version="1.0" encoding="utf-8"?>
 <p:sld xmlns:a="http://schemas.openxmlformats.org/drawingml/2006/main" xmlns:r="http://schemas.openxmlformats.org/officeDocument/2006/relationships" xmlns:p="http://schemas.openxmlformats.org/presentationml/2006/main">
   <p:cSld>
     <p:spTree>
@@ -38112,7 +38259,7 @@
 </p:sld>
 </file>
 
-<file path=ppt/slides/slide56.xml><?xml version="1.0" encoding="utf-8"?>
+<file path=ppt/slides/slide57.xml><?xml version="1.0" encoding="utf-8"?>
 <p:sld xmlns:a="http://schemas.openxmlformats.org/drawingml/2006/main" xmlns:r="http://schemas.openxmlformats.org/officeDocument/2006/relationships" xmlns:p="http://schemas.openxmlformats.org/presentationml/2006/main">
   <p:cSld>
     <p:spTree>
@@ -38638,7 +38785,7 @@
 </p:sld>
 </file>
 
-<file path=ppt/slides/slide57.xml><?xml version="1.0" encoding="utf-8"?>
+<file path=ppt/slides/slide58.xml><?xml version="1.0" encoding="utf-8"?>
 <p:sld xmlns:a="http://schemas.openxmlformats.org/drawingml/2006/main" xmlns:r="http://schemas.openxmlformats.org/officeDocument/2006/relationships" xmlns:p="http://schemas.openxmlformats.org/presentationml/2006/main">
   <p:cSld>
     <p:spTree>
@@ -39269,7 +39416,7 @@
 </p:sld>
 </file>
 
-<file path=ppt/slides/slide58.xml><?xml version="1.0" encoding="utf-8"?>
+<file path=ppt/slides/slide59.xml><?xml version="1.0" encoding="utf-8"?>
 <p:sld xmlns:a="http://schemas.openxmlformats.org/drawingml/2006/main" xmlns:r="http://schemas.openxmlformats.org/officeDocument/2006/relationships" xmlns:p="http://schemas.openxmlformats.org/presentationml/2006/main">
   <p:cSld>
     <p:spTree>
@@ -39797,311 +39944,6 @@
 </p:sld>
 </file>
 
-<file path=ppt/slides/slide59.xml><?xml version="1.0" encoding="utf-8"?>
-<p:sld xmlns:a="http://schemas.openxmlformats.org/drawingml/2006/main" xmlns:r="http://schemas.openxmlformats.org/officeDocument/2006/relationships" xmlns:p="http://schemas.openxmlformats.org/presentationml/2006/main">
-  <p:cSld>
-    <p:spTree>
-      <p:nvGrpSpPr>
-        <p:cNvPr id="1" name=""/>
-        <p:cNvGrpSpPr/>
-        <p:nvPr/>
-      </p:nvGrpSpPr>
-      <p:grpSpPr>
-        <a:xfrm>
-          <a:off x="0" y="0"/>
-          <a:ext cx="0" cy="0"/>
-          <a:chOff x="0" y="0"/>
-          <a:chExt cx="0" cy="0"/>
-        </a:xfrm>
-      </p:grpSpPr>
-      <p:sp>
-        <p:nvSpPr>
-          <p:cNvPr id="2" name="Title 1">
-            <a:extLst>
-              <a:ext uri="{FF2B5EF4-FFF2-40B4-BE49-F238E27FC236}">
-                <a16:creationId xmlns:a16="http://schemas.microsoft.com/office/drawing/2014/main" id="{9BDFD261-0D2C-41B9-9E28-43DF575D40E0}"/>
-              </a:ext>
-            </a:extLst>
-          </p:cNvPr>
-          <p:cNvSpPr>
-            <a:spLocks noGrp="1"/>
-          </p:cNvSpPr>
-          <p:nvPr>
-            <p:ph type="title"/>
-          </p:nvPr>
-        </p:nvSpPr>
-        <p:spPr/>
-        <p:txBody>
-          <a:bodyPr>
-            <a:normAutofit/>
-          </a:bodyPr>
-          <a:lstStyle/>
-          <a:p>
-            <a:r>
-              <a:rPr lang="nl-NL" sz="3600" noProof="0" dirty="0"/>
-              <a:t>Oefeningen 5</a:t>
-            </a:r>
-          </a:p>
-        </p:txBody>
-      </p:sp>
-      <p:sp>
-        <p:nvSpPr>
-          <p:cNvPr id="3" name="Content Placeholder 2">
-            <a:extLst>
-              <a:ext uri="{FF2B5EF4-FFF2-40B4-BE49-F238E27FC236}">
-                <a16:creationId xmlns:a16="http://schemas.microsoft.com/office/drawing/2014/main" id="{7844B503-C44F-453E-9465-D42E4557DE0C}"/>
-              </a:ext>
-            </a:extLst>
-          </p:cNvPr>
-          <p:cNvSpPr>
-            <a:spLocks noGrp="1"/>
-          </p:cNvSpPr>
-          <p:nvPr>
-            <p:ph idx="1"/>
-          </p:nvPr>
-        </p:nvSpPr>
-        <p:spPr/>
-        <p:txBody>
-          <a:bodyPr>
-            <a:noAutofit/>
-          </a:bodyPr>
-          <a:lstStyle/>
-          <a:p>
-            <a:pPr marL="0" indent="0">
-              <a:spcBef>
-                <a:spcPts val="600"/>
-              </a:spcBef>
-              <a:buNone/>
-            </a:pPr>
-            <a:r>
-              <a:rPr lang="nl-NL" sz="2000" noProof="0" dirty="0"/>
-              <a:t>Gebruik voor deze oefening de </a:t>
-            </a:r>
-            <a:r>
-              <a:rPr lang="nl-NL" sz="2000" noProof="0" dirty="0">
-                <a:latin typeface="Courier New" panose="02070309020205020404" pitchFamily="49" charset="0"/>
-                <a:cs typeface="Courier New" panose="02070309020205020404" pitchFamily="49" charset="0"/>
-              </a:rPr>
-              <a:t>Transacties</a:t>
-            </a:r>
-            <a:r>
-              <a:rPr lang="nl-NL" sz="2000" noProof="0" dirty="0"/>
-              <a:t> tabel van </a:t>
-            </a:r>
-            <a:r>
-              <a:rPr lang="nl-NL" sz="2000" noProof="0" dirty="0">
-                <a:latin typeface="Courier New" panose="02070309020205020404" pitchFamily="49" charset="0"/>
-                <a:cs typeface="Courier New" panose="02070309020205020404" pitchFamily="49" charset="0"/>
-              </a:rPr>
-              <a:t>0_data/</a:t>
-            </a:r>
-            <a:r>
-              <a:rPr lang="nl-NL" sz="2000" noProof="0" dirty="0" err="1">
-                <a:latin typeface="Courier New" panose="02070309020205020404" pitchFamily="49" charset="0"/>
-                <a:cs typeface="Courier New" panose="02070309020205020404" pitchFamily="49" charset="0"/>
-              </a:rPr>
-              <a:t>sales_data.db</a:t>
-            </a:r>
-            <a:r>
-              <a:rPr lang="nl-NL" sz="2000" noProof="0" dirty="0"/>
-              <a:t>.</a:t>
-            </a:r>
-          </a:p>
-          <a:p>
-            <a:pPr marL="0" indent="0">
-              <a:spcBef>
-                <a:spcPts val="600"/>
-              </a:spcBef>
-              <a:buNone/>
-            </a:pPr>
-            <a:endParaRPr lang="nl-NL" sz="2000" noProof="0" dirty="0"/>
-          </a:p>
-          <a:p>
-            <a:pPr marL="457200" indent="-457200">
-              <a:spcBef>
-                <a:spcPts val="600"/>
-              </a:spcBef>
-              <a:buAutoNum type="arabicPeriod"/>
-            </a:pPr>
-            <a:r>
-              <a:rPr lang="nl-NL" sz="2000" noProof="0" dirty="0"/>
-              <a:t>Schrijf een query om een willekeurig </a:t>
-            </a:r>
-            <a:r>
-              <a:rPr lang="nl-NL" sz="2000" noProof="0" dirty="0" err="1">
-                <a:latin typeface="Courier New" panose="02070309020205020404" pitchFamily="49" charset="0"/>
-                <a:cs typeface="Courier New" panose="02070309020205020404" pitchFamily="49" charset="0"/>
-              </a:rPr>
-              <a:t>ProductId</a:t>
-            </a:r>
-            <a:r>
-              <a:rPr lang="nl-NL" sz="2000" noProof="0" dirty="0"/>
-              <a:t> te selecteren.</a:t>
-            </a:r>
-          </a:p>
-          <a:p>
-            <a:pPr marL="457200" indent="-457200">
-              <a:spcBef>
-                <a:spcPts val="600"/>
-              </a:spcBef>
-              <a:buAutoNum type="arabicPeriod"/>
-            </a:pPr>
-            <a:endParaRPr lang="nl-NL" sz="2000" noProof="0" dirty="0"/>
-          </a:p>
-          <a:p>
-            <a:pPr marL="457200" indent="-457200">
-              <a:spcBef>
-                <a:spcPts val="600"/>
-              </a:spcBef>
-              <a:buAutoNum type="arabicPeriod"/>
-            </a:pPr>
-            <a:r>
-              <a:rPr lang="nl-NL" sz="2000" noProof="0" dirty="0"/>
-              <a:t>Bekijk het executieplan voor de query.</a:t>
-            </a:r>
-          </a:p>
-          <a:p>
-            <a:pPr marL="457200" indent="-457200">
-              <a:spcBef>
-                <a:spcPts val="600"/>
-              </a:spcBef>
-              <a:buAutoNum type="arabicPeriod"/>
-            </a:pPr>
-            <a:endParaRPr lang="nl-NL" sz="2000" noProof="0" dirty="0"/>
-          </a:p>
-          <a:p>
-            <a:pPr marL="457200" indent="-457200">
-              <a:spcBef>
-                <a:spcPts val="600"/>
-              </a:spcBef>
-              <a:buAutoNum type="arabicPeriod"/>
-            </a:pPr>
-            <a:r>
-              <a:rPr lang="nl-NL" sz="2000" noProof="0" dirty="0"/>
-              <a:t>Voeg nu een index toe op de </a:t>
-            </a:r>
-            <a:r>
-              <a:rPr lang="nl-NL" sz="2000" noProof="0" dirty="0" err="1">
-                <a:latin typeface="Courier New" panose="02070309020205020404" pitchFamily="49" charset="0"/>
-                <a:cs typeface="Courier New" panose="02070309020205020404" pitchFamily="49" charset="0"/>
-              </a:rPr>
-              <a:t>ProductId</a:t>
-            </a:r>
-            <a:r>
-              <a:rPr lang="nl-NL" sz="2000" noProof="0" dirty="0"/>
-              <a:t> kolom.</a:t>
-            </a:r>
-          </a:p>
-          <a:p>
-            <a:pPr marL="457200" indent="-457200">
-              <a:spcBef>
-                <a:spcPts val="600"/>
-              </a:spcBef>
-              <a:buAutoNum type="arabicPeriod"/>
-            </a:pPr>
-            <a:endParaRPr lang="nl-NL" sz="2000" noProof="0" dirty="0"/>
-          </a:p>
-          <a:p>
-            <a:pPr marL="457200" indent="-457200">
-              <a:spcBef>
-                <a:spcPts val="600"/>
-              </a:spcBef>
-              <a:buAutoNum type="arabicPeriod"/>
-            </a:pPr>
-            <a:r>
-              <a:rPr lang="nl-NL" sz="2000" noProof="0" dirty="0"/>
-              <a:t>Bekijk opnieuw het executieplan; wordt de index gebruikt?</a:t>
-            </a:r>
-          </a:p>
-          <a:p>
-            <a:pPr marL="457200" indent="-457200">
-              <a:spcBef>
-                <a:spcPts val="600"/>
-              </a:spcBef>
-              <a:buAutoNum type="arabicPeriod"/>
-            </a:pPr>
-            <a:endParaRPr lang="nl-NL" sz="2000" noProof="0" dirty="0"/>
-          </a:p>
-          <a:p>
-            <a:pPr marL="457200" indent="-457200">
-              <a:spcBef>
-                <a:spcPts val="600"/>
-              </a:spcBef>
-              <a:buAutoNum type="arabicPeriod"/>
-            </a:pPr>
-            <a:r>
-              <a:rPr lang="nl-NL" sz="2000" noProof="0" dirty="0"/>
-              <a:t>Wordt de index ook gebruikt met </a:t>
-            </a:r>
-            <a:r>
-              <a:rPr lang="nl-NL" sz="2000" noProof="0" dirty="0">
-                <a:solidFill>
-                  <a:schemeClr val="accent5">
-                    <a:lumMod val="75000"/>
-                  </a:schemeClr>
-                </a:solidFill>
-                <a:latin typeface="Courier New" panose="02070309020205020404" pitchFamily="49" charset="0"/>
-                <a:cs typeface="Courier New" panose="02070309020205020404" pitchFamily="49" charset="0"/>
-              </a:rPr>
-              <a:t>LIKE</a:t>
-            </a:r>
-            <a:r>
-              <a:rPr lang="nl-NL" sz="2000" noProof="0" dirty="0"/>
-              <a:t>? En met </a:t>
-            </a:r>
-            <a:r>
-              <a:rPr lang="nl-NL" sz="2000" noProof="0" dirty="0">
-                <a:solidFill>
-                  <a:schemeClr val="accent5">
-                    <a:lumMod val="75000"/>
-                  </a:schemeClr>
-                </a:solidFill>
-                <a:latin typeface="Courier New" panose="02070309020205020404" pitchFamily="49" charset="0"/>
-                <a:cs typeface="Courier New" panose="02070309020205020404" pitchFamily="49" charset="0"/>
-              </a:rPr>
-              <a:t>LOWER</a:t>
-            </a:r>
-            <a:r>
-              <a:rPr lang="nl-NL" sz="2000" noProof="0" dirty="0">
-                <a:latin typeface="Courier New" panose="02070309020205020404" pitchFamily="49" charset="0"/>
-                <a:cs typeface="Courier New" panose="02070309020205020404" pitchFamily="49" charset="0"/>
-              </a:rPr>
-              <a:t>(</a:t>
-            </a:r>
-            <a:r>
-              <a:rPr lang="nl-NL" sz="2000" noProof="0" dirty="0" err="1">
-                <a:latin typeface="Courier New" panose="02070309020205020404" pitchFamily="49" charset="0"/>
-                <a:cs typeface="Courier New" panose="02070309020205020404" pitchFamily="49" charset="0"/>
-              </a:rPr>
-              <a:t>ProductId</a:t>
-            </a:r>
-            <a:r>
-              <a:rPr lang="nl-NL" sz="2000" noProof="0" dirty="0">
-                <a:latin typeface="Courier New" panose="02070309020205020404" pitchFamily="49" charset="0"/>
-                <a:cs typeface="Courier New" panose="02070309020205020404" pitchFamily="49" charset="0"/>
-              </a:rPr>
-              <a:t>)</a:t>
-            </a:r>
-            <a:r>
-              <a:rPr lang="nl-NL" sz="2000" noProof="0" dirty="0"/>
-              <a:t>?</a:t>
-            </a:r>
-          </a:p>
-        </p:txBody>
-      </p:sp>
-    </p:spTree>
-    <p:extLst>
-      <p:ext uri="{BB962C8B-B14F-4D97-AF65-F5344CB8AC3E}">
-        <p14:creationId xmlns:p14="http://schemas.microsoft.com/office/powerpoint/2010/main" val="2338708325"/>
-      </p:ext>
-    </p:extLst>
-  </p:cSld>
-  <p:clrMapOvr>
-    <a:masterClrMapping/>
-  </p:clrMapOvr>
-</p:sld>
-</file>
-
 <file path=ppt/slides/slide6.xml><?xml version="1.0" encoding="utf-8"?>
 <p:sld xmlns:a="http://schemas.openxmlformats.org/drawingml/2006/main" xmlns:r="http://schemas.openxmlformats.org/officeDocument/2006/relationships" xmlns:p="http://schemas.openxmlformats.org/presentationml/2006/main">
   <p:cSld>
@@ -40338,7 +40180,7 @@
 </file>
 
 <file path=ppt/slides/slide60.xml><?xml version="1.0" encoding="utf-8"?>
-<p:sld xmlns:a="http://schemas.openxmlformats.org/drawingml/2006/main" xmlns:r="http://schemas.openxmlformats.org/officeDocument/2006/relationships" xmlns:p="http://schemas.openxmlformats.org/presentationml/2006/main" show="0">
+<p:sld xmlns:a="http://schemas.openxmlformats.org/drawingml/2006/main" xmlns:r="http://schemas.openxmlformats.org/officeDocument/2006/relationships" xmlns:p="http://schemas.openxmlformats.org/presentationml/2006/main">
   <p:cSld>
     <p:spTree>
       <p:nvGrpSpPr>
@@ -40379,7 +40221,7 @@
           <a:p>
             <a:r>
               <a:rPr lang="nl-NL" sz="3600" noProof="0" dirty="0"/>
-              <a:t>Huiswerk</a:t>
+              <a:t>Oefeningen 5</a:t>
             </a:r>
           </a:p>
         </p:txBody>
@@ -40400,423 +40242,239 @@
             <p:ph idx="1"/>
           </p:nvPr>
         </p:nvSpPr>
-        <p:spPr>
-          <a:xfrm>
-            <a:off x="838200" y="1825625"/>
-            <a:ext cx="5069440" cy="4351338"/>
-          </a:xfrm>
-        </p:spPr>
+        <p:spPr/>
         <p:txBody>
           <a:bodyPr>
-            <a:normAutofit/>
+            <a:noAutofit/>
           </a:bodyPr>
           <a:lstStyle/>
           <a:p>
             <a:pPr marL="0" indent="0">
+              <a:spcBef>
+                <a:spcPts val="600"/>
+              </a:spcBef>
               <a:buNone/>
             </a:pPr>
             <a:r>
               <a:rPr lang="nl-NL" sz="2000" noProof="0" dirty="0"/>
-              <a:t>De sales database was niet erg goed gemodelleerd....</a:t>
-            </a:r>
-          </a:p>
-          <a:p>
-            <a:pPr marL="0" indent="0">
-              <a:buNone/>
-            </a:pPr>
-            <a:endParaRPr lang="nl-NL" sz="2000" noProof="0" dirty="0"/>
-          </a:p>
-          <a:p>
-            <a:pPr marL="0" indent="0">
-              <a:buNone/>
-            </a:pPr>
-            <a:r>
-              <a:rPr lang="nl-NL" sz="2000" dirty="0"/>
-              <a:t>Kun jij de opzet van </a:t>
-            </a:r>
-            <a:r>
-              <a:rPr lang="nl-NL" sz="2000" dirty="0">
+              <a:t>Gebruik voor deze oefening de </a:t>
+            </a:r>
+            <a:r>
+              <a:rPr lang="nl-NL" sz="2000" noProof="0" dirty="0">
                 <a:latin typeface="Courier New" panose="02070309020205020404" pitchFamily="49" charset="0"/>
                 <a:cs typeface="Courier New" panose="02070309020205020404" pitchFamily="49" charset="0"/>
               </a:rPr>
               <a:t>Transacties</a:t>
             </a:r>
             <a:r>
-              <a:rPr lang="nl-NL" sz="2000" dirty="0"/>
-              <a:t> en </a:t>
-            </a:r>
-            <a:r>
-              <a:rPr lang="nl-NL" sz="2000" dirty="0">
+              <a:rPr lang="nl-NL" sz="2000" noProof="0" dirty="0"/>
+              <a:t> tabel van </a:t>
+            </a:r>
+            <a:r>
+              <a:rPr lang="nl-NL" sz="2000" noProof="0" dirty="0">
                 <a:latin typeface="Courier New" panose="02070309020205020404" pitchFamily="49" charset="0"/>
                 <a:cs typeface="Courier New" panose="02070309020205020404" pitchFamily="49" charset="0"/>
               </a:rPr>
-              <a:t>Producten</a:t>
-            </a:r>
-            <a:r>
-              <a:rPr lang="nl-NL" sz="2000" dirty="0"/>
-              <a:t> verbeteren?</a:t>
-            </a:r>
-            <a:endParaRPr lang="nl-NL" sz="2000" dirty="0">
-              <a:latin typeface="Courier New" panose="02070309020205020404" pitchFamily="49" charset="0"/>
-              <a:cs typeface="Courier New" panose="02070309020205020404" pitchFamily="49" charset="0"/>
-            </a:endParaRPr>
+              <a:t>0_data/</a:t>
+            </a:r>
+            <a:r>
+              <a:rPr lang="nl-NL" sz="2000" noProof="0" dirty="0" err="1">
+                <a:latin typeface="Courier New" panose="02070309020205020404" pitchFamily="49" charset="0"/>
+                <a:cs typeface="Courier New" panose="02070309020205020404" pitchFamily="49" charset="0"/>
+              </a:rPr>
+              <a:t>sales_data.db</a:t>
+            </a:r>
+            <a:r>
+              <a:rPr lang="nl-NL" sz="2000" noProof="0" dirty="0"/>
+              <a:t>.</a:t>
+            </a:r>
           </a:p>
           <a:p>
             <a:pPr marL="0" indent="0">
+              <a:spcBef>
+                <a:spcPts val="600"/>
+              </a:spcBef>
               <a:buNone/>
             </a:pPr>
             <a:endParaRPr lang="nl-NL" sz="2000" noProof="0" dirty="0"/>
           </a:p>
           <a:p>
-            <a:pPr>
-              <a:buFontTx/>
-              <a:buChar char="-"/>
+            <a:pPr marL="457200" indent="-457200">
+              <a:spcBef>
+                <a:spcPts val="600"/>
+              </a:spcBef>
+              <a:buAutoNum type="arabicPeriod"/>
             </a:pPr>
             <a:r>
               <a:rPr lang="nl-NL" sz="2000" noProof="0" dirty="0"/>
-              <a:t>Maak een ERD waarin je de entiteiten en hun relaties weergeeft.</a:t>
-            </a:r>
-          </a:p>
-          <a:p>
-            <a:pPr marL="0" indent="0">
-              <a:buNone/>
+              <a:t>Schrijf een query om een willekeurig </a:t>
+            </a:r>
+            <a:r>
+              <a:rPr lang="nl-NL" sz="2000" noProof="0" dirty="0" err="1">
+                <a:latin typeface="Courier New" panose="02070309020205020404" pitchFamily="49" charset="0"/>
+                <a:cs typeface="Courier New" panose="02070309020205020404" pitchFamily="49" charset="0"/>
+              </a:rPr>
+              <a:t>ProductId</a:t>
+            </a:r>
+            <a:r>
+              <a:rPr lang="nl-NL" sz="2000" noProof="0" dirty="0"/>
+              <a:t> te selecteren.</a:t>
+            </a:r>
+          </a:p>
+          <a:p>
+            <a:pPr marL="457200" indent="-457200">
+              <a:spcBef>
+                <a:spcPts val="600"/>
+              </a:spcBef>
+              <a:buAutoNum type="arabicPeriod"/>
             </a:pPr>
             <a:endParaRPr lang="nl-NL" sz="2000" noProof="0" dirty="0"/>
           </a:p>
           <a:p>
-            <a:pPr>
-              <a:buFontTx/>
-              <a:buChar char="-"/>
+            <a:pPr marL="457200" indent="-457200">
+              <a:spcBef>
+                <a:spcPts val="600"/>
+              </a:spcBef>
+              <a:buAutoNum type="arabicPeriod"/>
             </a:pPr>
             <a:r>
               <a:rPr lang="nl-NL" sz="2000" noProof="0" dirty="0"/>
-              <a:t>Maak een SQL script om de tabellen aan te maken.</a:t>
+              <a:t>Bekijk het executieplan voor de query.</a:t>
+            </a:r>
+          </a:p>
+          <a:p>
+            <a:pPr marL="457200" indent="-457200">
+              <a:spcBef>
+                <a:spcPts val="600"/>
+              </a:spcBef>
+              <a:buAutoNum type="arabicPeriod"/>
+            </a:pPr>
+            <a:endParaRPr lang="nl-NL" sz="2000" noProof="0" dirty="0"/>
+          </a:p>
+          <a:p>
+            <a:pPr marL="457200" indent="-457200">
+              <a:spcBef>
+                <a:spcPts val="600"/>
+              </a:spcBef>
+              <a:buAutoNum type="arabicPeriod"/>
+            </a:pPr>
+            <a:r>
+              <a:rPr lang="nl-NL" sz="2000" noProof="0" dirty="0"/>
+              <a:t>Voeg nu een index toe op de </a:t>
+            </a:r>
+            <a:r>
+              <a:rPr lang="nl-NL" sz="2000" noProof="0" dirty="0" err="1">
+                <a:latin typeface="Courier New" panose="02070309020205020404" pitchFamily="49" charset="0"/>
+                <a:cs typeface="Courier New" panose="02070309020205020404" pitchFamily="49" charset="0"/>
+              </a:rPr>
+              <a:t>ProductId</a:t>
+            </a:r>
+            <a:r>
+              <a:rPr lang="nl-NL" sz="2000" noProof="0" dirty="0"/>
+              <a:t> kolom.</a:t>
+            </a:r>
+          </a:p>
+          <a:p>
+            <a:pPr marL="457200" indent="-457200">
+              <a:spcBef>
+                <a:spcPts val="600"/>
+              </a:spcBef>
+              <a:buAutoNum type="arabicPeriod"/>
+            </a:pPr>
+            <a:endParaRPr lang="nl-NL" sz="2000" noProof="0" dirty="0"/>
+          </a:p>
+          <a:p>
+            <a:pPr marL="457200" indent="-457200">
+              <a:spcBef>
+                <a:spcPts val="600"/>
+              </a:spcBef>
+              <a:buAutoNum type="arabicPeriod"/>
+            </a:pPr>
+            <a:r>
+              <a:rPr lang="nl-NL" sz="2000" noProof="0" dirty="0"/>
+              <a:t>Bekijk opnieuw het executieplan; wordt de index gebruikt?</a:t>
+            </a:r>
+          </a:p>
+          <a:p>
+            <a:pPr marL="457200" indent="-457200">
+              <a:spcBef>
+                <a:spcPts val="600"/>
+              </a:spcBef>
+              <a:buAutoNum type="arabicPeriod"/>
+            </a:pPr>
+            <a:endParaRPr lang="nl-NL" sz="2000" noProof="0" dirty="0"/>
+          </a:p>
+          <a:p>
+            <a:pPr marL="457200" indent="-457200">
+              <a:spcBef>
+                <a:spcPts val="600"/>
+              </a:spcBef>
+              <a:buAutoNum type="arabicPeriod"/>
+            </a:pPr>
+            <a:r>
+              <a:rPr lang="nl-NL" sz="2000" noProof="0" dirty="0"/>
+              <a:t>Wordt de index ook gebruikt met </a:t>
+            </a:r>
+            <a:r>
+              <a:rPr lang="nl-NL" sz="2000" noProof="0" dirty="0">
+                <a:solidFill>
+                  <a:schemeClr val="accent5">
+                    <a:lumMod val="75000"/>
+                  </a:schemeClr>
+                </a:solidFill>
+                <a:latin typeface="Courier New" panose="02070309020205020404" pitchFamily="49" charset="0"/>
+                <a:cs typeface="Courier New" panose="02070309020205020404" pitchFamily="49" charset="0"/>
+              </a:rPr>
+              <a:t>LIKE</a:t>
+            </a:r>
+            <a:r>
+              <a:rPr lang="nl-NL" sz="2000" noProof="0" dirty="0"/>
+              <a:t>? En met </a:t>
+            </a:r>
+            <a:r>
+              <a:rPr lang="nl-NL" sz="2000" noProof="0" dirty="0">
+                <a:solidFill>
+                  <a:schemeClr val="accent5">
+                    <a:lumMod val="75000"/>
+                  </a:schemeClr>
+                </a:solidFill>
+                <a:latin typeface="Courier New" panose="02070309020205020404" pitchFamily="49" charset="0"/>
+                <a:cs typeface="Courier New" panose="02070309020205020404" pitchFamily="49" charset="0"/>
+              </a:rPr>
+              <a:t>LOWER</a:t>
+            </a:r>
+            <a:r>
+              <a:rPr lang="nl-NL" sz="2000" noProof="0" dirty="0">
+                <a:latin typeface="Courier New" panose="02070309020205020404" pitchFamily="49" charset="0"/>
+                <a:cs typeface="Courier New" panose="02070309020205020404" pitchFamily="49" charset="0"/>
+              </a:rPr>
+              <a:t>(</a:t>
+            </a:r>
+            <a:r>
+              <a:rPr lang="nl-NL" sz="2000" noProof="0" dirty="0" err="1">
+                <a:latin typeface="Courier New" panose="02070309020205020404" pitchFamily="49" charset="0"/>
+                <a:cs typeface="Courier New" panose="02070309020205020404" pitchFamily="49" charset="0"/>
+              </a:rPr>
+              <a:t>ProductId</a:t>
+            </a:r>
+            <a:r>
+              <a:rPr lang="nl-NL" sz="2000" noProof="0" dirty="0">
+                <a:latin typeface="Courier New" panose="02070309020205020404" pitchFamily="49" charset="0"/>
+                <a:cs typeface="Courier New" panose="02070309020205020404" pitchFamily="49" charset="0"/>
+              </a:rPr>
+              <a:t>)</a:t>
+            </a:r>
+            <a:r>
+              <a:rPr lang="nl-NL" sz="2000" noProof="0" dirty="0"/>
+              <a:t>?</a:t>
             </a:r>
           </a:p>
         </p:txBody>
       </p:sp>
-      <p:sp>
-        <p:nvSpPr>
-          <p:cNvPr id="5" name="Content Placeholder 2">
-            <a:extLst>
-              <a:ext uri="{FF2B5EF4-FFF2-40B4-BE49-F238E27FC236}">
-                <a16:creationId xmlns:a16="http://schemas.microsoft.com/office/drawing/2014/main" id="{43FB1EF2-5E0A-4A37-8F20-78CE7AFACEC9}"/>
-              </a:ext>
-            </a:extLst>
-          </p:cNvPr>
-          <p:cNvSpPr txBox="1">
-            <a:spLocks/>
-          </p:cNvSpPr>
-          <p:nvPr/>
-        </p:nvSpPr>
-        <p:spPr>
-          <a:xfrm>
-            <a:off x="6284360" y="1825625"/>
-            <a:ext cx="5069440" cy="4351338"/>
-          </a:xfrm>
-          <a:prstGeom prst="rect">
-            <a:avLst/>
-          </a:prstGeom>
-        </p:spPr>
-        <p:txBody>
-          <a:bodyPr vert="horz" lIns="91440" tIns="45720" rIns="91440" bIns="45720" rtlCol="0">
-            <a:normAutofit/>
-          </a:bodyPr>
-          <a:lstStyle>
-            <a:lvl1pPr marL="228600" indent="-228600" algn="l" defTabSz="914400" rtl="0" eaLnBrk="1" latinLnBrk="0" hangingPunct="1">
-              <a:lnSpc>
-                <a:spcPct val="90000"/>
-              </a:lnSpc>
-              <a:spcBef>
-                <a:spcPts val="1000"/>
-              </a:spcBef>
-              <a:buFont typeface="Arial" panose="020B0604020202020204" pitchFamily="34" charset="0"/>
-              <a:buChar char="•"/>
-              <a:defRPr sz="2800" kern="1200">
-                <a:solidFill>
-                  <a:schemeClr val="tx1"/>
-                </a:solidFill>
-                <a:latin typeface="+mn-lt"/>
-                <a:ea typeface="+mn-ea"/>
-                <a:cs typeface="+mn-cs"/>
-              </a:defRPr>
-            </a:lvl1pPr>
-            <a:lvl2pPr marL="685800" indent="-228600" algn="l" defTabSz="914400" rtl="0" eaLnBrk="1" latinLnBrk="0" hangingPunct="1">
-              <a:lnSpc>
-                <a:spcPct val="90000"/>
-              </a:lnSpc>
-              <a:spcBef>
-                <a:spcPts val="500"/>
-              </a:spcBef>
-              <a:buFont typeface="Arial" panose="020B0604020202020204" pitchFamily="34" charset="0"/>
-              <a:buChar char="•"/>
-              <a:defRPr sz="2400" kern="1200">
-                <a:solidFill>
-                  <a:schemeClr val="tx1"/>
-                </a:solidFill>
-                <a:latin typeface="+mn-lt"/>
-                <a:ea typeface="+mn-ea"/>
-                <a:cs typeface="+mn-cs"/>
-              </a:defRPr>
-            </a:lvl2pPr>
-            <a:lvl3pPr marL="1143000" indent="-228600" algn="l" defTabSz="914400" rtl="0" eaLnBrk="1" latinLnBrk="0" hangingPunct="1">
-              <a:lnSpc>
-                <a:spcPct val="90000"/>
-              </a:lnSpc>
-              <a:spcBef>
-                <a:spcPts val="500"/>
-              </a:spcBef>
-              <a:buFont typeface="Arial" panose="020B0604020202020204" pitchFamily="34" charset="0"/>
-              <a:buChar char="•"/>
-              <a:defRPr sz="2000" kern="1200">
-                <a:solidFill>
-                  <a:schemeClr val="tx1"/>
-                </a:solidFill>
-                <a:latin typeface="+mn-lt"/>
-                <a:ea typeface="+mn-ea"/>
-                <a:cs typeface="+mn-cs"/>
-              </a:defRPr>
-            </a:lvl3pPr>
-            <a:lvl4pPr marL="1600200" indent="-228600" algn="l" defTabSz="914400" rtl="0" eaLnBrk="1" latinLnBrk="0" hangingPunct="1">
-              <a:lnSpc>
-                <a:spcPct val="90000"/>
-              </a:lnSpc>
-              <a:spcBef>
-                <a:spcPts val="500"/>
-              </a:spcBef>
-              <a:buFont typeface="Arial" panose="020B0604020202020204" pitchFamily="34" charset="0"/>
-              <a:buChar char="•"/>
-              <a:defRPr sz="1800" kern="1200">
-                <a:solidFill>
-                  <a:schemeClr val="tx1"/>
-                </a:solidFill>
-                <a:latin typeface="+mn-lt"/>
-                <a:ea typeface="+mn-ea"/>
-                <a:cs typeface="+mn-cs"/>
-              </a:defRPr>
-            </a:lvl4pPr>
-            <a:lvl5pPr marL="2057400" indent="-228600" algn="l" defTabSz="914400" rtl="0" eaLnBrk="1" latinLnBrk="0" hangingPunct="1">
-              <a:lnSpc>
-                <a:spcPct val="90000"/>
-              </a:lnSpc>
-              <a:spcBef>
-                <a:spcPts val="500"/>
-              </a:spcBef>
-              <a:buFont typeface="Arial" panose="020B0604020202020204" pitchFamily="34" charset="0"/>
-              <a:buChar char="•"/>
-              <a:defRPr sz="1800" kern="1200">
-                <a:solidFill>
-                  <a:schemeClr val="tx1"/>
-                </a:solidFill>
-                <a:latin typeface="+mn-lt"/>
-                <a:ea typeface="+mn-ea"/>
-                <a:cs typeface="+mn-cs"/>
-              </a:defRPr>
-            </a:lvl5pPr>
-            <a:lvl6pPr marL="2514600" indent="-228600" algn="l" defTabSz="914400" rtl="0" eaLnBrk="1" latinLnBrk="0" hangingPunct="1">
-              <a:lnSpc>
-                <a:spcPct val="90000"/>
-              </a:lnSpc>
-              <a:spcBef>
-                <a:spcPts val="500"/>
-              </a:spcBef>
-              <a:buFont typeface="Arial" panose="020B0604020202020204" pitchFamily="34" charset="0"/>
-              <a:buChar char="•"/>
-              <a:defRPr sz="1800" kern="1200">
-                <a:solidFill>
-                  <a:schemeClr val="tx1"/>
-                </a:solidFill>
-                <a:latin typeface="+mn-lt"/>
-                <a:ea typeface="+mn-ea"/>
-                <a:cs typeface="+mn-cs"/>
-              </a:defRPr>
-            </a:lvl6pPr>
-            <a:lvl7pPr marL="2971800" indent="-228600" algn="l" defTabSz="914400" rtl="0" eaLnBrk="1" latinLnBrk="0" hangingPunct="1">
-              <a:lnSpc>
-                <a:spcPct val="90000"/>
-              </a:lnSpc>
-              <a:spcBef>
-                <a:spcPts val="500"/>
-              </a:spcBef>
-              <a:buFont typeface="Arial" panose="020B0604020202020204" pitchFamily="34" charset="0"/>
-              <a:buChar char="•"/>
-              <a:defRPr sz="1800" kern="1200">
-                <a:solidFill>
-                  <a:schemeClr val="tx1"/>
-                </a:solidFill>
-                <a:latin typeface="+mn-lt"/>
-                <a:ea typeface="+mn-ea"/>
-                <a:cs typeface="+mn-cs"/>
-              </a:defRPr>
-            </a:lvl7pPr>
-            <a:lvl8pPr marL="3429000" indent="-228600" algn="l" defTabSz="914400" rtl="0" eaLnBrk="1" latinLnBrk="0" hangingPunct="1">
-              <a:lnSpc>
-                <a:spcPct val="90000"/>
-              </a:lnSpc>
-              <a:spcBef>
-                <a:spcPts val="500"/>
-              </a:spcBef>
-              <a:buFont typeface="Arial" panose="020B0604020202020204" pitchFamily="34" charset="0"/>
-              <a:buChar char="•"/>
-              <a:defRPr sz="1800" kern="1200">
-                <a:solidFill>
-                  <a:schemeClr val="tx1"/>
-                </a:solidFill>
-                <a:latin typeface="+mn-lt"/>
-                <a:ea typeface="+mn-ea"/>
-                <a:cs typeface="+mn-cs"/>
-              </a:defRPr>
-            </a:lvl8pPr>
-            <a:lvl9pPr marL="3886200" indent="-228600" algn="l" defTabSz="914400" rtl="0" eaLnBrk="1" latinLnBrk="0" hangingPunct="1">
-              <a:lnSpc>
-                <a:spcPct val="90000"/>
-              </a:lnSpc>
-              <a:spcBef>
-                <a:spcPts val="500"/>
-              </a:spcBef>
-              <a:buFont typeface="Arial" panose="020B0604020202020204" pitchFamily="34" charset="0"/>
-              <a:buChar char="•"/>
-              <a:defRPr sz="1800" kern="1200">
-                <a:solidFill>
-                  <a:schemeClr val="tx1"/>
-                </a:solidFill>
-                <a:latin typeface="+mn-lt"/>
-                <a:ea typeface="+mn-ea"/>
-                <a:cs typeface="+mn-cs"/>
-              </a:defRPr>
-            </a:lvl9pPr>
-          </a:lstStyle>
-          <a:p>
-            <a:pPr>
-              <a:buFontTx/>
-              <a:buChar char="-"/>
-            </a:pPr>
-            <a:r>
-              <a:rPr lang="nl-NL" sz="2000" noProof="0" dirty="0"/>
-              <a:t>Hoe zou je de transacties netjes genormaliseerd opslaan (3NF)?</a:t>
-            </a:r>
-          </a:p>
-          <a:p>
-            <a:pPr>
-              <a:buFontTx/>
-              <a:buChar char="-"/>
-            </a:pPr>
-            <a:endParaRPr lang="nl-NL" sz="2000" dirty="0"/>
-          </a:p>
-          <a:p>
-            <a:pPr>
-              <a:buFontTx/>
-              <a:buChar char="-"/>
-            </a:pPr>
-            <a:r>
-              <a:rPr lang="nl-NL" sz="2000" noProof="0" dirty="0"/>
-              <a:t>Hoe ga je om met prijswijzigingen of tijdelijke kortingsacties?</a:t>
-            </a:r>
-          </a:p>
-          <a:p>
-            <a:pPr>
-              <a:buFontTx/>
-              <a:buChar char="-"/>
-            </a:pPr>
-            <a:endParaRPr lang="nl-NL" sz="2000" noProof="0" dirty="0"/>
-          </a:p>
-          <a:p>
-            <a:pPr>
-              <a:buFontTx/>
-              <a:buChar char="-"/>
-            </a:pPr>
-            <a:r>
-              <a:rPr lang="nl-NL" sz="2000" noProof="0" dirty="0"/>
-              <a:t>Hoe </a:t>
-            </a:r>
-            <a:r>
-              <a:rPr lang="nl-NL" sz="2000" dirty="0"/>
-              <a:t>zou je</a:t>
-            </a:r>
-            <a:r>
-              <a:rPr lang="nl-NL" sz="2000" noProof="0" dirty="0"/>
-              <a:t> producten met heel veel verschillende </a:t>
-            </a:r>
-            <a:r>
-              <a:rPr lang="nl-NL" sz="2000" noProof="0"/>
-              <a:t>eigenschappen opslaan?</a:t>
-            </a:r>
-            <a:endParaRPr lang="nl-NL" sz="2000" noProof="0" dirty="0"/>
-          </a:p>
-          <a:p>
-            <a:pPr marL="0" indent="0">
-              <a:buNone/>
-            </a:pPr>
-            <a:endParaRPr lang="nl-NL" sz="2000" noProof="0" dirty="0"/>
-          </a:p>
-          <a:p>
-            <a:pPr>
-              <a:buFontTx/>
-              <a:buChar char="-"/>
-            </a:pPr>
-            <a:r>
-              <a:rPr lang="nl-NL" sz="2000" noProof="0" dirty="0"/>
-              <a:t>Hoe </a:t>
-            </a:r>
-            <a:r>
-              <a:rPr lang="nl-NL" sz="2000" dirty="0"/>
-              <a:t>ga je om met hiërarchische </a:t>
-            </a:r>
-            <a:r>
-              <a:rPr lang="nl-NL" sz="2000" noProof="0" dirty="0"/>
-              <a:t>product categorieën (levensmiddelen &gt; vers &gt; </a:t>
-            </a:r>
-            <a:r>
-              <a:rPr lang="nl-NL" sz="2000" dirty="0"/>
-              <a:t>f</a:t>
-            </a:r>
-            <a:r>
-              <a:rPr lang="nl-NL" sz="2000" noProof="0" dirty="0"/>
-              <a:t>ruit)?</a:t>
-            </a:r>
-          </a:p>
-        </p:txBody>
-      </p:sp>
-      <p:cxnSp>
-        <p:nvCxnSpPr>
-          <p:cNvPr id="7" name="Straight Connector 6">
-            <a:extLst>
-              <a:ext uri="{FF2B5EF4-FFF2-40B4-BE49-F238E27FC236}">
-                <a16:creationId xmlns:a16="http://schemas.microsoft.com/office/drawing/2014/main" id="{E4E5960F-5A4D-4A60-91C5-9D07E2269090}"/>
-              </a:ext>
-            </a:extLst>
-          </p:cNvPr>
-          <p:cNvCxnSpPr/>
-          <p:nvPr/>
-        </p:nvCxnSpPr>
-        <p:spPr>
-          <a:xfrm>
-            <a:off x="6096000" y="1825625"/>
-            <a:ext cx="0" cy="4351338"/>
-          </a:xfrm>
-          <a:prstGeom prst="line">
-            <a:avLst/>
-          </a:prstGeom>
-        </p:spPr>
-        <p:style>
-          <a:lnRef idx="3">
-            <a:schemeClr val="dk1"/>
-          </a:lnRef>
-          <a:fillRef idx="0">
-            <a:schemeClr val="dk1"/>
-          </a:fillRef>
-          <a:effectRef idx="2">
-            <a:schemeClr val="dk1"/>
-          </a:effectRef>
-          <a:fontRef idx="minor">
-            <a:schemeClr val="tx1"/>
-          </a:fontRef>
-        </p:style>
-      </p:cxnSp>
     </p:spTree>
     <p:extLst>
       <p:ext uri="{BB962C8B-B14F-4D97-AF65-F5344CB8AC3E}">
-        <p14:creationId xmlns:p14="http://schemas.microsoft.com/office/powerpoint/2010/main" val="1333858174"/>
+        <p14:creationId xmlns:p14="http://schemas.microsoft.com/office/powerpoint/2010/main" val="2338708325"/>
       </p:ext>
     </p:extLst>
   </p:cSld>

</xml_diff>

<commit_message>
Finalize SQL P2 database design
</commit_message>
<xml_diff>
--- a/sql_course_2p/2_database_design/2_database_design.pptx
+++ b/sql_course_2p/2_database_design/2_database_design.pptx
@@ -256,7 +256,7 @@
           <a:p>
             <a:fld id="{61CE90D0-176A-4BE5-B54F-392F0A16E3B3}" type="datetimeFigureOut">
               <a:rPr lang="en-NL" smtClean="0"/>
-              <a:t>13/10/2026</a:t>
+              <a:t>19/10/2026</a:t>
             </a:fld>
             <a:endParaRPr lang="en-NL"/>
           </a:p>
@@ -568,32 +568,7 @@
           <a:bodyPr/>
           <a:lstStyle/>
           <a:p>
-            <a:r>
-              <a:rPr lang="nl-NL" dirty="0"/>
-              <a:t>Maar: wat als het gaat om bijvoorbeeld aanhef? Vast aantal categorieën =&gt; dan is het een op veel...</a:t>
-            </a:r>
-          </a:p>
-          <a:p>
-            <a:r>
-              <a:rPr lang="nl-NL" dirty="0"/>
-              <a:t>Onderscheid dimensie (</a:t>
-            </a:r>
-            <a:r>
-              <a:rPr lang="nl-NL" dirty="0" err="1"/>
-              <a:t>dimension</a:t>
-            </a:r>
-            <a:r>
-              <a:rPr lang="nl-NL" dirty="0"/>
-              <a:t>) versus feit (</a:t>
-            </a:r>
-            <a:r>
-              <a:rPr lang="nl-NL" dirty="0" err="1"/>
-              <a:t>fact</a:t>
-            </a:r>
-            <a:r>
-              <a:rPr lang="nl-NL" dirty="0"/>
-              <a:t>) bespreken.</a:t>
-            </a:r>
+            <a:endParaRPr lang="nl-NL" dirty="0"/>
           </a:p>
         </p:txBody>
       </p:sp>
@@ -1039,11 +1014,7 @@
           <a:p>
             <a:r>
               <a:rPr lang="en-US" dirty="0"/>
-              <a:t>Demo: 1</a:t>
-            </a:r>
-            <a:r>
-              <a:rPr lang="en-US"/>
-              <a:t>_foreign_keys.sql</a:t>
+              <a:t>Demo: 1_foreign_keys.sql</a:t>
             </a:r>
             <a:endParaRPr lang="en-NL" dirty="0"/>
           </a:p>
@@ -3872,7 +3843,7 @@
           <a:p>
             <a:fld id="{7B15CBDA-B49C-4B0F-9869-5B15867EA611}" type="datetimeFigureOut">
               <a:rPr lang="en-NL" smtClean="0"/>
-              <a:t>13/10/2026</a:t>
+              <a:t>19/10/2026</a:t>
             </a:fld>
             <a:endParaRPr lang="en-NL"/>
           </a:p>
@@ -4072,7 +4043,7 @@
           <a:p>
             <a:fld id="{7B15CBDA-B49C-4B0F-9869-5B15867EA611}" type="datetimeFigureOut">
               <a:rPr lang="en-NL" smtClean="0"/>
-              <a:t>13/10/2026</a:t>
+              <a:t>19/10/2026</a:t>
             </a:fld>
             <a:endParaRPr lang="en-NL"/>
           </a:p>
@@ -4282,7 +4253,7 @@
           <a:p>
             <a:fld id="{7B15CBDA-B49C-4B0F-9869-5B15867EA611}" type="datetimeFigureOut">
               <a:rPr lang="en-NL" smtClean="0"/>
-              <a:t>13/10/2026</a:t>
+              <a:t>19/10/2026</a:t>
             </a:fld>
             <a:endParaRPr lang="en-NL"/>
           </a:p>
@@ -4482,7 +4453,7 @@
           <a:p>
             <a:fld id="{7B15CBDA-B49C-4B0F-9869-5B15867EA611}" type="datetimeFigureOut">
               <a:rPr lang="en-NL" smtClean="0"/>
-              <a:t>13/10/2026</a:t>
+              <a:t>19/10/2026</a:t>
             </a:fld>
             <a:endParaRPr lang="en-NL"/>
           </a:p>
@@ -4758,7 +4729,7 @@
           <a:p>
             <a:fld id="{7B15CBDA-B49C-4B0F-9869-5B15867EA611}" type="datetimeFigureOut">
               <a:rPr lang="en-NL" smtClean="0"/>
-              <a:t>13/10/2026</a:t>
+              <a:t>19/10/2026</a:t>
             </a:fld>
             <a:endParaRPr lang="en-NL"/>
           </a:p>
@@ -5026,7 +4997,7 @@
           <a:p>
             <a:fld id="{7B15CBDA-B49C-4B0F-9869-5B15867EA611}" type="datetimeFigureOut">
               <a:rPr lang="en-NL" smtClean="0"/>
-              <a:t>13/10/2026</a:t>
+              <a:t>19/10/2026</a:t>
             </a:fld>
             <a:endParaRPr lang="en-NL"/>
           </a:p>
@@ -5441,7 +5412,7 @@
           <a:p>
             <a:fld id="{7B15CBDA-B49C-4B0F-9869-5B15867EA611}" type="datetimeFigureOut">
               <a:rPr lang="en-NL" smtClean="0"/>
-              <a:t>13/10/2026</a:t>
+              <a:t>19/10/2026</a:t>
             </a:fld>
             <a:endParaRPr lang="en-NL"/>
           </a:p>
@@ -5583,7 +5554,7 @@
           <a:p>
             <a:fld id="{7B15CBDA-B49C-4B0F-9869-5B15867EA611}" type="datetimeFigureOut">
               <a:rPr lang="en-NL" smtClean="0"/>
-              <a:t>13/10/2026</a:t>
+              <a:t>19/10/2026</a:t>
             </a:fld>
             <a:endParaRPr lang="en-NL"/>
           </a:p>
@@ -5696,7 +5667,7 @@
           <a:p>
             <a:fld id="{7B15CBDA-B49C-4B0F-9869-5B15867EA611}" type="datetimeFigureOut">
               <a:rPr lang="en-NL" smtClean="0"/>
-              <a:t>13/10/2026</a:t>
+              <a:t>19/10/2026</a:t>
             </a:fld>
             <a:endParaRPr lang="en-NL"/>
           </a:p>
@@ -6009,7 +5980,7 @@
           <a:p>
             <a:fld id="{7B15CBDA-B49C-4B0F-9869-5B15867EA611}" type="datetimeFigureOut">
               <a:rPr lang="en-NL" smtClean="0"/>
-              <a:t>13/10/2026</a:t>
+              <a:t>19/10/2026</a:t>
             </a:fld>
             <a:endParaRPr lang="en-NL"/>
           </a:p>
@@ -6298,7 +6269,7 @@
           <a:p>
             <a:fld id="{7B15CBDA-B49C-4B0F-9869-5B15867EA611}" type="datetimeFigureOut">
               <a:rPr lang="en-NL" smtClean="0"/>
-              <a:t>13/10/2026</a:t>
+              <a:t>19/10/2026</a:t>
             </a:fld>
             <a:endParaRPr lang="en-NL"/>
           </a:p>
@@ -6541,7 +6512,7 @@
           <a:p>
             <a:fld id="{7B15CBDA-B49C-4B0F-9869-5B15867EA611}" type="datetimeFigureOut">
               <a:rPr lang="en-NL" smtClean="0"/>
-              <a:t>13/10/2026</a:t>
+              <a:t>19/10/2026</a:t>
             </a:fld>
             <a:endParaRPr lang="en-NL"/>
           </a:p>
@@ -7009,7 +6980,7 @@
           <a:p>
             <a:r>
               <a:rPr lang="nl-NL" noProof="0" dirty="0"/>
-              <a:t>2025</a:t>
+              <a:t>2026</a:t>
             </a:r>
           </a:p>
         </p:txBody>
@@ -7930,7 +7901,7 @@
         <p:spPr>
           <a:xfrm>
             <a:off x="4534344" y="3481621"/>
-            <a:ext cx="1888659" cy="338554"/>
+            <a:ext cx="1481688" cy="338554"/>
           </a:xfrm>
           <a:prstGeom prst="rect">
             <a:avLst/>
@@ -7945,7 +7916,7 @@
           <a:p>
             <a:r>
               <a:rPr lang="nl-NL" sz="1600" noProof="0" dirty="0" err="1"/>
-              <a:t>TransactieProducten</a:t>
+              <a:t>TransactieRegel</a:t>
             </a:r>
             <a:endParaRPr lang="nl-NL" sz="1600" noProof="0" dirty="0"/>
           </a:p>
@@ -16018,7 +15989,7 @@
             <a:pPr lvl="1"/>
             <a:r>
               <a:rPr lang="nl-NL" sz="2000" noProof="0" dirty="0"/>
-              <a:t>Welke kolom(men) vormen de sleutel van deze tabel?</a:t>
+              <a:t>Welke kolommen vormen de sleutel van deze tabel?</a:t>
             </a:r>
           </a:p>
           <a:p>
@@ -16249,7 +16220,7 @@
             <a:pPr lvl="1"/>
             <a:r>
               <a:rPr lang="nl-NL" sz="2000" noProof="0" dirty="0"/>
-              <a:t>Sleutel kolom(men):		</a:t>
+              <a:t>Sleutel kolommen:		</a:t>
             </a:r>
             <a:r>
               <a:rPr lang="nl-NL" sz="2000" noProof="0" dirty="0" err="1">
@@ -16283,7 +16254,7 @@
                 <a:latin typeface="Courier New" panose="02070309020205020404" pitchFamily="49" charset="0"/>
                 <a:cs typeface="Courier New" panose="02070309020205020404" pitchFamily="49" charset="0"/>
               </a:rPr>
-              <a:t>					</a:t>
+              <a:t>				</a:t>
             </a:r>
             <a:r>
               <a:rPr lang="nl-NL" sz="2000" dirty="0" err="1">
@@ -16323,14 +16294,14 @@
             <a:pPr lvl="1"/>
             <a:r>
               <a:rPr lang="nl-NL" sz="2000" noProof="0" dirty="0"/>
-              <a:t>Voldoet aan 1NF:			Ja, unieke rijen met enkele waardes.</a:t>
+              <a:t>Voldoet aan 1NF:		Ja, unieke rijen met enkele waardes.</a:t>
             </a:r>
           </a:p>
           <a:p>
             <a:pPr lvl="1"/>
             <a:r>
               <a:rPr lang="nl-NL" sz="2000" noProof="0" dirty="0"/>
-              <a:t>Voldoet aan 2NF:			Nee, </a:t>
+              <a:t>Voldoet aan 2NF:		Nee, </a:t>
             </a:r>
             <a:r>
               <a:rPr lang="nl-NL" sz="2000" noProof="0" dirty="0" err="1">
@@ -16364,7 +16335,7 @@
             <a:pPr lvl="1"/>
             <a:r>
               <a:rPr lang="nl-NL" sz="2000" noProof="0" dirty="0"/>
-              <a:t>Niet 3NF kolom:			</a:t>
+              <a:t>Niet 3NF kolom:		</a:t>
             </a:r>
             <a:r>
               <a:rPr lang="nl-NL" sz="2000" noProof="0" dirty="0">
@@ -17993,7 +17964,7 @@
               <a:buNone/>
             </a:pPr>
             <a:r>
-              <a:rPr lang="nl-NL" sz="2000" noProof="0" dirty="0"/>
+              <a:rPr lang="nl-NL" sz="2000" b="1" noProof="0" dirty="0"/>
               <a:t>Entiteiten:</a:t>
             </a:r>
           </a:p>
@@ -18060,7 +18031,7 @@
             </a:pPr>
             <a:r>
               <a:rPr lang="nl-NL" sz="2000" dirty="0"/>
-              <a:t>Contributies</a:t>
+              <a:t>Contributie</a:t>
             </a:r>
           </a:p>
           <a:p>
@@ -18178,7 +18149,7 @@
               <a:buNone/>
             </a:pPr>
             <a:r>
-              <a:rPr lang="nl-NL" sz="2000" noProof="0" dirty="0"/>
+              <a:rPr lang="nl-NL" sz="2000" b="1" noProof="0" dirty="0"/>
               <a:t>Entiteiten:</a:t>
             </a:r>
           </a:p>
@@ -18245,7 +18216,7 @@
             </a:pPr>
             <a:r>
               <a:rPr lang="nl-NL" sz="2000" dirty="0"/>
-              <a:t>Contributies</a:t>
+              <a:t>Contributie</a:t>
             </a:r>
           </a:p>
           <a:p>
@@ -18462,7 +18433,7 @@
               <a:buNone/>
             </a:pPr>
             <a:r>
-              <a:rPr lang="nl-NL" sz="2000" noProof="0" dirty="0"/>
+              <a:rPr lang="nl-NL" sz="2000" b="1" noProof="0" dirty="0"/>
               <a:t>Relaties:</a:t>
             </a:r>
           </a:p>
@@ -18624,10 +18595,10 @@
       </p:grpSpPr>
       <p:pic>
         <p:nvPicPr>
-          <p:cNvPr id="4" name="Picture 3">
+          <p:cNvPr id="3" name="Picture 2">
             <a:extLst>
               <a:ext uri="{FF2B5EF4-FFF2-40B4-BE49-F238E27FC236}">
-                <a16:creationId xmlns:a16="http://schemas.microsoft.com/office/drawing/2014/main" id="{006637E1-829C-BBCC-29AA-E5ABF7D80498}"/>
+                <a16:creationId xmlns:a16="http://schemas.microsoft.com/office/drawing/2014/main" id="{04AFBC5B-5616-8037-8D68-C8DC799A59DA}"/>
               </a:ext>
             </a:extLst>
           </p:cNvPr>
@@ -18644,8 +18615,8 @@
         </p:blipFill>
         <p:spPr>
           <a:xfrm>
-            <a:off x="2057050" y="990388"/>
-            <a:ext cx="8077900" cy="4877223"/>
+            <a:off x="1302604" y="495046"/>
+            <a:ext cx="9586791" cy="5867908"/>
           </a:xfrm>
           <a:prstGeom prst="rect">
             <a:avLst/>
@@ -22284,6 +22255,42 @@
           </a:fontRef>
         </p:style>
       </p:cxnSp>
+      <p:sp>
+        <p:nvSpPr>
+          <p:cNvPr id="7" name="TextBox 6">
+            <a:extLst>
+              <a:ext uri="{FF2B5EF4-FFF2-40B4-BE49-F238E27FC236}">
+                <a16:creationId xmlns:a16="http://schemas.microsoft.com/office/drawing/2014/main" id="{C84D2571-ABA5-5200-B904-E1F7D662D97D}"/>
+              </a:ext>
+            </a:extLst>
+          </p:cNvPr>
+          <p:cNvSpPr txBox="1"/>
+          <p:nvPr/>
+        </p:nvSpPr>
+        <p:spPr>
+          <a:xfrm>
+            <a:off x="734505" y="6214383"/>
+            <a:ext cx="5361495" cy="261610"/>
+          </a:xfrm>
+          <a:prstGeom prst="rect">
+            <a:avLst/>
+          </a:prstGeom>
+          <a:noFill/>
+        </p:spPr>
+        <p:txBody>
+          <a:bodyPr wrap="square">
+            <a:spAutoFit/>
+          </a:bodyPr>
+          <a:lstStyle/>
+          <a:p>
+            <a:r>
+              <a:rPr lang="en-US" sz="1100" dirty="0"/>
+              <a:t>D: 1_foreign_keys.sql</a:t>
+            </a:r>
+            <a:endParaRPr lang="en-NL" sz="1100" dirty="0"/>
+          </a:p>
+        </p:txBody>
+      </p:sp>
     </p:spTree>
     <p:extLst>
       <p:ext uri="{BB962C8B-B14F-4D97-AF65-F5344CB8AC3E}">
@@ -27693,21 +27700,11 @@
               <a:buChar char="-"/>
             </a:pPr>
             <a:r>
-              <a:rPr lang="nl-NL" sz="2000" noProof="0" dirty="0"/>
-              <a:t>Beperkingen op standaard waardes.</a:t>
-            </a:r>
-          </a:p>
-          <a:p>
-            <a:pPr>
-              <a:buFontTx/>
-              <a:buChar char="-"/>
-            </a:pPr>
-            <a:r>
-              <a:rPr lang="nl-NL" sz="2000" noProof="0" dirty="0"/>
+              <a:rPr lang="nl-NL" sz="2000" dirty="0"/>
               <a:t>Geen </a:t>
             </a:r>
             <a:r>
-              <a:rPr lang="nl-NL" sz="2000" noProof="0" dirty="0">
+              <a:rPr lang="nl-NL" sz="2000" dirty="0">
                 <a:solidFill>
                   <a:schemeClr val="accent5">
                     <a:lumMod val="75000"/>
@@ -27719,8 +27716,18 @@
               <a:t>PRIMARY KEY / UNIQUE</a:t>
             </a:r>
             <a:r>
+              <a:rPr lang="nl-NL" sz="2000" dirty="0"/>
+              <a:t>.</a:t>
+            </a:r>
+          </a:p>
+          <a:p>
+            <a:pPr>
+              <a:buFontTx/>
+              <a:buChar char="-"/>
+            </a:pPr>
+            <a:r>
               <a:rPr lang="nl-NL" sz="2000" noProof="0" dirty="0"/>
-              <a:t>.</a:t>
+              <a:t>Beperkingen op standaard waardes.</a:t>
             </a:r>
           </a:p>
           <a:p>
@@ -27733,7 +27740,7 @@
             <a:pPr marL="0" indent="0">
               <a:buNone/>
             </a:pPr>
-            <a:endParaRPr lang="nl-NL" sz="1600" noProof="0" dirty="0"/>
+            <a:endParaRPr lang="nl-NL" sz="2000" noProof="0" dirty="0"/>
           </a:p>
           <a:p>
             <a:pPr marL="0" indent="0">
@@ -28271,7 +28278,23 @@
             </a:pPr>
             <a:r>
               <a:rPr lang="nl-NL" sz="2000" noProof="0" dirty="0"/>
-              <a:t>Geen FOREIGN KEY.</a:t>
+              <a:t>Geen </a:t>
+            </a:r>
+            <a:r>
+              <a:rPr lang="nl-NL" sz="2000" noProof="0" dirty="0">
+                <a:solidFill>
+                  <a:schemeClr val="accent5">
+                    <a:lumMod val="75000"/>
+                  </a:schemeClr>
+                </a:solidFill>
+                <a:latin typeface="Courier New" panose="02070309020205020404" pitchFamily="49" charset="0"/>
+                <a:cs typeface="Courier New" panose="02070309020205020404" pitchFamily="49" charset="0"/>
+              </a:rPr>
+              <a:t>FOREIGN KEY</a:t>
+            </a:r>
+            <a:r>
+              <a:rPr lang="nl-NL" sz="2000" noProof="0" dirty="0"/>
+              <a:t>.</a:t>
             </a:r>
           </a:p>
           <a:p>
@@ -28625,7 +28648,7 @@
             </a:pPr>
             <a:r>
               <a:rPr lang="nl-NL" sz="2000" noProof="0" dirty="0"/>
-              <a:t>Een view is een query die wordt opgeslagen in de database.</a:t>
+              <a:t>View is een opgeslagen query in de database.</a:t>
             </a:r>
           </a:p>
           <a:p>
@@ -28683,6 +28706,22 @@
               <a:rPr lang="nl-NL" sz="2000" noProof="0" dirty="0"/>
               <a:t> queries werkt een view als een tabel.</a:t>
             </a:r>
+          </a:p>
+          <a:p>
+            <a:pPr marL="0" indent="0">
+              <a:buNone/>
+            </a:pPr>
+            <a:endParaRPr lang="nl-NL" sz="2000" dirty="0"/>
+          </a:p>
+          <a:p>
+            <a:pPr marL="0" indent="0">
+              <a:buNone/>
+            </a:pPr>
+            <a:r>
+              <a:rPr lang="nl-NL" sz="2000" dirty="0"/>
+              <a:t>Je kunt data niet wijzigen in een view!</a:t>
+            </a:r>
+            <a:endParaRPr lang="nl-NL" sz="2000" noProof="0" dirty="0"/>
           </a:p>
         </p:txBody>
       </p:sp>
@@ -30059,7 +30098,26 @@
                 <a:latin typeface="Courier New" panose="02070309020205020404" pitchFamily="49" charset="0"/>
                 <a:cs typeface="Courier New" panose="02070309020205020404" pitchFamily="49" charset="0"/>
               </a:rPr>
-              <a:t>),</a:t>
+              <a:t>) </a:t>
+            </a:r>
+            <a:r>
+              <a:rPr lang="nl-NL" sz="2000" noProof="0" dirty="0">
+                <a:solidFill>
+                  <a:schemeClr val="accent5">
+                    <a:lumMod val="75000"/>
+                  </a:schemeClr>
+                </a:solidFill>
+                <a:latin typeface="Courier New" panose="02070309020205020404" pitchFamily="49" charset="0"/>
+                <a:cs typeface="Courier New" panose="02070309020205020404" pitchFamily="49" charset="0"/>
+              </a:rPr>
+              <a:t>AS</a:t>
+            </a:r>
+            <a:r>
+              <a:rPr lang="nl-NL" sz="2000" noProof="0" dirty="0">
+                <a:latin typeface="Courier New" panose="02070309020205020404" pitchFamily="49" charset="0"/>
+                <a:cs typeface="Courier New" panose="02070309020205020404" pitchFamily="49" charset="0"/>
+              </a:rPr>
+              <a:t> Datum,</a:t>
             </a:r>
           </a:p>
           <a:p>
@@ -30220,28 +30278,14 @@
                 <a:latin typeface="Courier New" panose="02070309020205020404" pitchFamily="49" charset="0"/>
                 <a:cs typeface="Courier New" panose="02070309020205020404" pitchFamily="49" charset="0"/>
               </a:rPr>
-              <a:t>GROUP BY DATE</a:t>
+              <a:t>GROUP BY </a:t>
             </a:r>
             <a:r>
               <a:rPr lang="nl-NL" sz="2000" noProof="0" dirty="0">
                 <a:latin typeface="Courier New" panose="02070309020205020404" pitchFamily="49" charset="0"/>
                 <a:cs typeface="Courier New" panose="02070309020205020404" pitchFamily="49" charset="0"/>
               </a:rPr>
-              <a:t>(</a:t>
-            </a:r>
-            <a:r>
-              <a:rPr lang="nl-NL" sz="2000" noProof="0" dirty="0" err="1">
-                <a:latin typeface="Courier New" panose="02070309020205020404" pitchFamily="49" charset="0"/>
-                <a:cs typeface="Courier New" panose="02070309020205020404" pitchFamily="49" charset="0"/>
-              </a:rPr>
-              <a:t>DatumTijd</a:t>
-            </a:r>
-            <a:r>
-              <a:rPr lang="nl-NL" sz="2000" noProof="0" dirty="0">
-                <a:latin typeface="Courier New" panose="02070309020205020404" pitchFamily="49" charset="0"/>
-                <a:cs typeface="Courier New" panose="02070309020205020404" pitchFamily="49" charset="0"/>
-              </a:rPr>
-              <a:t>)</a:t>
+              <a:t>Datum</a:t>
             </a:r>
           </a:p>
           <a:p>
@@ -30465,8 +30509,14 @@
             </a:pPr>
             <a:r>
               <a:rPr lang="nl-NL" sz="2000" noProof="0" dirty="0"/>
-              <a:t>Maak een view aan met </a:t>
-            </a:r>
+              <a:t>Maak een view aan met</a:t>
+            </a:r>
+          </a:p>
+          <a:p>
+            <a:pPr marL="0" indent="0">
+              <a:buFont typeface="Arial" panose="020B0604020202020204" pitchFamily="34" charset="0"/>
+              <a:buNone/>
+            </a:pPr>
             <a:r>
               <a:rPr lang="nl-NL" sz="2000" noProof="0" dirty="0">
                 <a:solidFill>
@@ -30951,8 +31001,8 @@
               <a:buNone/>
             </a:pPr>
             <a:r>
-              <a:rPr lang="nl-NL" sz="2000" b="1" noProof="0" dirty="0" err="1"/>
-              <a:t>Table</a:t>
+              <a:rPr lang="nl-NL" sz="2000" b="1" noProof="0" dirty="0"/>
+              <a:t>Tabel</a:t>
             </a:r>
             <a:endParaRPr lang="nl-NL" sz="2000" noProof="0" dirty="0"/>
           </a:p>
@@ -31864,6 +31914,11 @@
             </a:r>
             <a:r>
               <a:rPr lang="nl-NL" sz="2000" noProof="0" dirty="0">
+                <a:solidFill>
+                  <a:schemeClr val="accent5">
+                    <a:lumMod val="75000"/>
+                  </a:schemeClr>
+                </a:solidFill>
                 <a:latin typeface="Courier New" panose="02070309020205020404" pitchFamily="49" charset="0"/>
                 <a:cs typeface="Courier New" panose="02070309020205020404" pitchFamily="49" charset="0"/>
               </a:rPr>
@@ -31871,7 +31926,7 @@
             </a:r>
             <a:r>
               <a:rPr lang="nl-NL" sz="2000" noProof="0" dirty="0"/>
-              <a:t> en maak er dan pas een view van.</a:t>
+              <a:t> query en maak er daarna een view van.</a:t>
             </a:r>
           </a:p>
         </p:txBody>
@@ -32230,7 +32285,7 @@
             </a:pPr>
             <a:r>
               <a:rPr lang="nl-NL" sz="2000" noProof="0" dirty="0"/>
-              <a:t>Een index kan een query flink versnellen, omdat niet de hele tabel ingelezen wordt.</a:t>
+              <a:t>Een index kan een query flink versnellen, omdat niet de hele tabel doorzocht wordt.</a:t>
             </a:r>
           </a:p>
           <a:p>
@@ -32292,29 +32347,8 @@
             </a:pPr>
             <a:r>
               <a:rPr lang="nl-NL" sz="2000" noProof="0" dirty="0"/>
-              <a:t>Let </a:t>
-            </a:r>
-            <a:r>
-              <a:rPr lang="nl-NL" sz="2000" noProof="0"/>
-              <a:t>op:</a:t>
-            </a:r>
-          </a:p>
-          <a:p>
-            <a:pPr marL="0" indent="0">
-              <a:buFont typeface="Arial" panose="020B0604020202020204" pitchFamily="34" charset="0"/>
-              <a:buNone/>
-            </a:pPr>
-            <a:r>
-              <a:rPr lang="nl-NL" sz="2000" noProof="0" dirty="0"/>
               <a:t>Query bepaalt of index gebruikt wordt of niet!</a:t>
             </a:r>
-          </a:p>
-          <a:p>
-            <a:pPr marL="0" indent="0">
-              <a:buFont typeface="Arial" panose="020B0604020202020204" pitchFamily="34" charset="0"/>
-              <a:buNone/>
-            </a:pPr>
-            <a:endParaRPr lang="nl-NL" sz="2000" noProof="0" dirty="0"/>
           </a:p>
         </p:txBody>
       </p:sp>
@@ -33090,7 +33124,7 @@
           <a:p>
             <a:r>
               <a:rPr lang="nl-NL" sz="3600" noProof="0" dirty="0"/>
-              <a:t>Hoe werkt een index?</a:t>
+              <a:t>Query zonder index</a:t>
             </a:r>
           </a:p>
         </p:txBody>
@@ -33803,7 +33837,18 @@
             </a:pPr>
             <a:r>
               <a:rPr lang="nl-NL" sz="2000" noProof="0" dirty="0"/>
-              <a:t>Scan alle waardes en verzamel rijen met waarde 30.</a:t>
+              <a:t>Scan alle rijen en verzamel rijen met </a:t>
+            </a:r>
+            <a:r>
+              <a:rPr lang="nl-NL" sz="2000" noProof="0" dirty="0">
+                <a:latin typeface="Courier New" panose="02070309020205020404" pitchFamily="49" charset="0"/>
+                <a:cs typeface="Courier New" panose="02070309020205020404" pitchFamily="49" charset="0"/>
+              </a:rPr>
+              <a:t>Leeftijd = 30</a:t>
+            </a:r>
+            <a:r>
+              <a:rPr lang="nl-NL" sz="2000" noProof="0" dirty="0"/>
+              <a:t>.</a:t>
             </a:r>
           </a:p>
           <a:p>
@@ -33975,8 +34020,8 @@
         </p:nvSpPr>
         <p:spPr>
           <a:xfrm>
-            <a:off x="2543856" y="1690688"/>
-            <a:ext cx="882678" cy="369332"/>
+            <a:off x="2538599" y="1690688"/>
+            <a:ext cx="887935" cy="369332"/>
           </a:xfrm>
           <a:prstGeom prst="rect">
             <a:avLst/>
@@ -33989,11 +34034,11 @@
           </a:bodyPr>
           <a:lstStyle/>
           <a:p>
-            <a:r>
-              <a:rPr lang="en-US" dirty="0" err="1"/>
-              <a:t>waarde</a:t>
-            </a:r>
-            <a:endParaRPr lang="en-US" dirty="0"/>
+            <a:pPr algn="r"/>
+            <a:r>
+              <a:rPr lang="en-US" dirty="0"/>
+              <a:t>Leeftijd</a:t>
+            </a:r>
           </a:p>
         </p:txBody>
       </p:sp>
@@ -34094,9 +34139,10 @@
           <a:lstStyle/>
           <a:p>
             <a:r>
-              <a:rPr lang="nl-NL" sz="3600" noProof="0" dirty="0"/>
-              <a:t>Hoe werkt een index?</a:t>
-            </a:r>
+              <a:rPr lang="nl-NL" sz="3600" dirty="0"/>
+              <a:t>Query met index</a:t>
+            </a:r>
+            <a:endParaRPr lang="nl-NL" sz="3600" noProof="0" dirty="0"/>
           </a:p>
         </p:txBody>
       </p:sp>
@@ -35260,7 +35306,7 @@
         </p:spPr>
         <p:txBody>
           <a:bodyPr vert="horz" lIns="91440" tIns="45720" rIns="91440" bIns="45720" rtlCol="0">
-            <a:normAutofit lnSpcReduction="10000"/>
+            <a:normAutofit/>
           </a:bodyPr>
           <a:lstStyle>
             <a:lvl1pPr marL="228600" indent="-228600" algn="l" defTabSz="914400" rtl="0" eaLnBrk="1" latinLnBrk="0" hangingPunct="1">
@@ -35447,7 +35493,20 @@
               <a:rPr lang="nl-NL" sz="2000" noProof="0" dirty="0">
                 <a:cs typeface="Courier New" panose="02070309020205020404" pitchFamily="49" charset="0"/>
               </a:rPr>
-              <a:t>Groepeer en sorteer alle unieke waardes.</a:t>
+              <a:t>Index bevat rijen gegroepeerd op </a:t>
+            </a:r>
+            <a:r>
+              <a:rPr lang="nl-NL" sz="2000" noProof="0" dirty="0">
+                <a:latin typeface="Courier New" panose="02070309020205020404" pitchFamily="49" charset="0"/>
+                <a:cs typeface="Courier New" panose="02070309020205020404" pitchFamily="49" charset="0"/>
+              </a:rPr>
+              <a:t>Leeftijd</a:t>
+            </a:r>
+            <a:r>
+              <a:rPr lang="nl-NL" sz="2000" noProof="0" dirty="0">
+                <a:cs typeface="Courier New" panose="02070309020205020404" pitchFamily="49" charset="0"/>
+              </a:rPr>
+              <a:t>.</a:t>
             </a:r>
           </a:p>
           <a:p>
@@ -35459,30 +35518,33 @@
               <a:rPr lang="nl-NL" sz="2000" noProof="0" dirty="0">
                 <a:cs typeface="Courier New" panose="02070309020205020404" pitchFamily="49" charset="0"/>
               </a:rPr>
-              <a:t>Verzamel alleen de rijen uit de correcte groep.</a:t>
-            </a:r>
-          </a:p>
-          <a:p>
-            <a:pPr marL="0" indent="0">
-              <a:buFont typeface="Arial" panose="020B0604020202020204" pitchFamily="34" charset="0"/>
-              <a:buNone/>
-            </a:pPr>
-            <a:endParaRPr lang="nl-NL" sz="2000" noProof="0" dirty="0">
-              <a:cs typeface="Courier New" panose="02070309020205020404" pitchFamily="49" charset="0"/>
-            </a:endParaRPr>
-          </a:p>
-          <a:p>
-            <a:pPr marL="0" indent="0">
-              <a:buFont typeface="Arial" panose="020B0604020202020204" pitchFamily="34" charset="0"/>
-              <a:buNone/>
-            </a:pPr>
+              <a:t>Zoek de groep met </a:t>
+            </a:r>
+            <a:r>
+              <a:rPr lang="nl-NL" sz="2000" noProof="0" dirty="0">
+                <a:latin typeface="Courier New" panose="02070309020205020404" pitchFamily="49" charset="0"/>
+                <a:cs typeface="Courier New" panose="02070309020205020404" pitchFamily="49" charset="0"/>
+              </a:rPr>
+              <a:t>Leeftijd = 30</a:t>
+            </a:r>
             <a:r>
               <a:rPr lang="nl-NL" sz="2000" noProof="0" dirty="0">
                 <a:cs typeface="Courier New" panose="02070309020205020404" pitchFamily="49" charset="0"/>
               </a:rPr>
-              <a:t>Veel minder data in te lezen!</a:t>
-            </a:r>
-            <a:endParaRPr lang="nl-NL" sz="2000" noProof="0" dirty="0"/>
+              <a:t>.</a:t>
+            </a:r>
+          </a:p>
+          <a:p>
+            <a:pPr>
+              <a:buFontTx/>
+              <a:buChar char="-"/>
+            </a:pPr>
+            <a:r>
+              <a:rPr lang="nl-NL" sz="2000" noProof="0" dirty="0">
+                <a:cs typeface="Courier New" panose="02070309020205020404" pitchFamily="49" charset="0"/>
+              </a:rPr>
+              <a:t>Retourneer de rijen uit deze groep.</a:t>
+            </a:r>
           </a:p>
         </p:txBody>
       </p:sp>
@@ -35593,8 +35655,8 @@
         </p:nvSpPr>
         <p:spPr>
           <a:xfrm>
-            <a:off x="2543856" y="1690688"/>
-            <a:ext cx="882678" cy="369332"/>
+            <a:off x="2538598" y="1690688"/>
+            <a:ext cx="887936" cy="369332"/>
           </a:xfrm>
           <a:prstGeom prst="rect">
             <a:avLst/>
@@ -35607,11 +35669,11 @@
           </a:bodyPr>
           <a:lstStyle/>
           <a:p>
-            <a:r>
-              <a:rPr lang="en-US" dirty="0" err="1"/>
-              <a:t>waarde</a:t>
-            </a:r>
-            <a:endParaRPr lang="en-US" dirty="0"/>
+            <a:pPr algn="r"/>
+            <a:r>
+              <a:rPr lang="en-US" dirty="0"/>
+              <a:t>Leeftijd</a:t>
+            </a:r>
           </a:p>
         </p:txBody>
       </p:sp>
@@ -36879,8 +36941,8 @@
         </p:nvSpPr>
         <p:spPr>
           <a:xfrm>
-            <a:off x="1992790" y="5564416"/>
-            <a:ext cx="7651525" cy="437105"/>
+            <a:off x="1872176" y="5564416"/>
+            <a:ext cx="8804292" cy="437105"/>
           </a:xfrm>
           <a:prstGeom prst="rect">
             <a:avLst/>
@@ -37061,7 +37123,7 @@
             </a:pPr>
             <a:r>
               <a:rPr lang="nl-NL" sz="2000" noProof="0" dirty="0"/>
-              <a:t>Boomstructuur maakt nog efficiënter gebruik van de volgorde.</a:t>
+              <a:t>Boomstructuur maakt index nog efficiënter.</a:t>
             </a:r>
           </a:p>
         </p:txBody>
@@ -37898,7 +37960,7 @@
           <a:p>
             <a:r>
               <a:rPr lang="nl-NL" sz="3600" noProof="0" dirty="0"/>
-              <a:t>Syntax index aanmaken</a:t>
+              <a:t>Syntax index</a:t>
             </a:r>
           </a:p>
         </p:txBody>
@@ -38307,7 +38369,7 @@
           <a:p>
             <a:r>
               <a:rPr lang="nl-NL" sz="3600" noProof="0" dirty="0"/>
-              <a:t>Syntax index aanmaken</a:t>
+              <a:t>Syntax index</a:t>
             </a:r>
           </a:p>
         </p:txBody>
@@ -38833,7 +38895,7 @@
           <a:p>
             <a:r>
               <a:rPr lang="nl-NL" sz="3600" noProof="0" dirty="0"/>
-              <a:t>Syntax index aanmaken</a:t>
+              <a:t>Syntax index</a:t>
             </a:r>
           </a:p>
         </p:txBody>
@@ -39834,7 +39896,15 @@
             </a:r>
             <a:r>
               <a:rPr lang="nl-NL" sz="2000" noProof="0" dirty="0"/>
-              <a:t> een query uitvoert.</a:t>
+              <a:t> </a:t>
+            </a:r>
+            <a:r>
+              <a:rPr lang="nl-NL" sz="2000" dirty="0"/>
+              <a:t>de</a:t>
+            </a:r>
+            <a:r>
+              <a:rPr lang="nl-NL" sz="2000" noProof="0" dirty="0"/>
+              <a:t> query uitvoert.</a:t>
             </a:r>
           </a:p>
           <a:p>
@@ -39850,47 +39920,119 @@
               <a:buNone/>
             </a:pPr>
             <a:r>
-              <a:rPr lang="nl-NL" sz="2000" noProof="0" dirty="0"/>
-              <a:t>Als </a:t>
-            </a:r>
-            <a:r>
               <a:rPr lang="nl-NL" sz="2000" noProof="0" dirty="0">
+                <a:solidFill>
+                  <a:schemeClr val="accent5">
+                    <a:lumMod val="75000"/>
+                  </a:schemeClr>
+                </a:solidFill>
                 <a:latin typeface="Courier New" panose="02070309020205020404" pitchFamily="49" charset="0"/>
                 <a:cs typeface="Courier New" panose="02070309020205020404" pitchFamily="49" charset="0"/>
               </a:rPr>
-              <a:t>SCAN TABLE</a:t>
-            </a:r>
-            <a:r>
-              <a:rPr lang="nl-NL" sz="2000" noProof="0" dirty="0"/>
-              <a:t> in de output staat wordt de hele tabel doorzocht…</a:t>
-            </a:r>
+              <a:t>SCAN &lt;</a:t>
+            </a:r>
+            <a:r>
+              <a:rPr lang="nl-NL" sz="2000" noProof="0" dirty="0" err="1">
+                <a:solidFill>
+                  <a:schemeClr val="accent5">
+                    <a:lumMod val="75000"/>
+                  </a:schemeClr>
+                </a:solidFill>
+                <a:latin typeface="Courier New" panose="02070309020205020404" pitchFamily="49" charset="0"/>
+                <a:cs typeface="Courier New" panose="02070309020205020404" pitchFamily="49" charset="0"/>
+              </a:rPr>
+              <a:t>table</a:t>
+            </a:r>
+            <a:r>
+              <a:rPr lang="nl-NL" sz="2000" noProof="0" dirty="0">
+                <a:solidFill>
+                  <a:schemeClr val="accent5">
+                    <a:lumMod val="75000"/>
+                  </a:schemeClr>
+                </a:solidFill>
+                <a:latin typeface="Courier New" panose="02070309020205020404" pitchFamily="49" charset="0"/>
+                <a:cs typeface="Courier New" panose="02070309020205020404" pitchFamily="49" charset="0"/>
+              </a:rPr>
+              <a:t>&gt;</a:t>
+            </a:r>
+            <a:endParaRPr lang="nl-NL" sz="2000" noProof="0" dirty="0"/>
           </a:p>
           <a:p>
             <a:pPr marL="0" indent="0">
               <a:buFont typeface="Arial" panose="020B0604020202020204" pitchFamily="34" charset="0"/>
               <a:buNone/>
             </a:pPr>
-            <a:endParaRPr lang="nl-NL" sz="2000" noProof="0" dirty="0"/>
+            <a:r>
+              <a:rPr lang="nl-NL" sz="2000" noProof="0" dirty="0"/>
+              <a:t>Geen index, de hele tabel wordt doorzocht…</a:t>
+            </a:r>
           </a:p>
           <a:p>
             <a:pPr marL="0" indent="0">
               <a:buFont typeface="Arial" panose="020B0604020202020204" pitchFamily="34" charset="0"/>
               <a:buNone/>
             </a:pPr>
-            <a:r>
-              <a:rPr lang="nl-NL" sz="2000" noProof="0" dirty="0"/>
-              <a:t>Als </a:t>
-            </a:r>
+            <a:endParaRPr lang="nl-NL" sz="2000" noProof="0" dirty="0"/>
+          </a:p>
+          <a:p>
+            <a:pPr marL="0" indent="0">
+              <a:buFont typeface="Arial" panose="020B0604020202020204" pitchFamily="34" charset="0"/>
+              <a:buNone/>
+            </a:pPr>
             <a:r>
               <a:rPr lang="nl-NL" sz="2000" noProof="0" dirty="0">
+                <a:solidFill>
+                  <a:schemeClr val="accent5">
+                    <a:lumMod val="75000"/>
+                  </a:schemeClr>
+                </a:solidFill>
                 <a:latin typeface="Courier New" panose="02070309020205020404" pitchFamily="49" charset="0"/>
                 <a:cs typeface="Courier New" panose="02070309020205020404" pitchFamily="49" charset="0"/>
               </a:rPr>
-              <a:t>SEARCH TABLE ... USING INDEX</a:t>
-            </a:r>
+              <a:t>SEARCH &lt;</a:t>
+            </a:r>
+            <a:r>
+              <a:rPr lang="nl-NL" sz="2000" noProof="0" dirty="0" err="1">
+                <a:solidFill>
+                  <a:schemeClr val="accent5">
+                    <a:lumMod val="75000"/>
+                  </a:schemeClr>
+                </a:solidFill>
+                <a:latin typeface="Courier New" panose="02070309020205020404" pitchFamily="49" charset="0"/>
+                <a:cs typeface="Courier New" panose="02070309020205020404" pitchFamily="49" charset="0"/>
+              </a:rPr>
+              <a:t>table</a:t>
+            </a:r>
+            <a:r>
+              <a:rPr lang="nl-NL" sz="2000" noProof="0" dirty="0">
+                <a:solidFill>
+                  <a:schemeClr val="accent5">
+                    <a:lumMod val="75000"/>
+                  </a:schemeClr>
+                </a:solidFill>
+                <a:latin typeface="Courier New" panose="02070309020205020404" pitchFamily="49" charset="0"/>
+                <a:cs typeface="Courier New" panose="02070309020205020404" pitchFamily="49" charset="0"/>
+              </a:rPr>
+              <a:t>&gt; USING INDEX &lt;index&gt;</a:t>
+            </a:r>
+            <a:endParaRPr lang="nl-NL" sz="2000" dirty="0">
+              <a:solidFill>
+                <a:schemeClr val="accent5">
+                  <a:lumMod val="75000"/>
+                </a:schemeClr>
+              </a:solidFill>
+              <a:latin typeface="Courier New" panose="02070309020205020404" pitchFamily="49" charset="0"/>
+              <a:cs typeface="Courier New" panose="02070309020205020404" pitchFamily="49" charset="0"/>
+            </a:endParaRPr>
+          </a:p>
+          <a:p>
+            <a:pPr marL="0" indent="0">
+              <a:buFont typeface="Arial" panose="020B0604020202020204" pitchFamily="34" charset="0"/>
+              <a:buNone/>
+            </a:pPr>
             <a:r>
               <a:rPr lang="nl-NL" sz="2000" noProof="0" dirty="0"/>
-              <a:t> verschijnt wordt de index gebruikt!</a:t>
+              <a:t>De index wordt gebruikt!</a:t>
             </a:r>
           </a:p>
         </p:txBody>
@@ -40552,7 +40694,7 @@
           <p:nvPr>
             <p:extLst>
               <p:ext uri="{D42A27DB-BD31-4B8C-83A1-F6EECF244321}">
-                <p14:modId xmlns:p14="http://schemas.microsoft.com/office/powerpoint/2010/main" val="270708489"/>
+                <p14:modId xmlns:p14="http://schemas.microsoft.com/office/powerpoint/2010/main" val="1864030726"/>
               </p:ext>
             </p:extLst>
           </p:nvPr>
@@ -40751,7 +40893,13 @@
                     <a:p>
                       <a:r>
                         <a:rPr lang="nl-NL" noProof="0" dirty="0"/>
-                        <a:t>Twee tabellen met gekoppelde sleutel (</a:t>
+                        <a:t>Twee tabellen met koppel sleutel.</a:t>
+                      </a:r>
+                    </a:p>
+                    <a:p>
+                      <a:r>
+                        <a:rPr lang="nl-NL" noProof="0" dirty="0"/>
+                        <a:t>(</a:t>
                       </a:r>
                       <a:r>
                         <a:rPr lang="nl-NL" noProof="0" dirty="0">
@@ -40773,7 +40921,7 @@
                       </a:r>
                       <a:r>
                         <a:rPr lang="nl-NL" noProof="0" dirty="0"/>
-                        <a:t>).</a:t>
+                        <a:t>)</a:t>
                       </a:r>
                     </a:p>
                   </a:txBody>
@@ -41960,7 +42108,7 @@
           <p:nvPr>
             <p:extLst>
               <p:ext uri="{D42A27DB-BD31-4B8C-83A1-F6EECF244321}">
-                <p14:modId xmlns:p14="http://schemas.microsoft.com/office/powerpoint/2010/main" val="1341604374"/>
+                <p14:modId xmlns:p14="http://schemas.microsoft.com/office/powerpoint/2010/main" val="123653338"/>
               </p:ext>
             </p:extLst>
           </p:nvPr>
@@ -42159,7 +42307,7 @@
                     <a:p>
                       <a:r>
                         <a:rPr lang="nl-NL" noProof="0" dirty="0"/>
-                        <a:t>Twee tabellen met gekoppelde sleutel (</a:t>
+                        <a:t>Twee tabellen met koppel sleutel (</a:t>
                       </a:r>
                       <a:r>
                         <a:rPr lang="nl-NL" noProof="0" dirty="0">
@@ -42275,14 +42423,14 @@
                       </a:r>
                       <a:r>
                         <a:rPr lang="nl-NL" noProof="0" dirty="0"/>
-                        <a:t>) en koppeltabel (</a:t>
+                        <a:t>) en koppel tabel (</a:t>
                       </a:r>
                       <a:r>
                         <a:rPr lang="nl-NL" noProof="0" dirty="0" err="1">
                           <a:latin typeface="Courier New" panose="02070309020205020404" pitchFamily="49" charset="0"/>
                           <a:cs typeface="Courier New" panose="02070309020205020404" pitchFamily="49" charset="0"/>
                         </a:rPr>
-                        <a:t>TransactieProducten</a:t>
+                        <a:t>TransactieRegel</a:t>
                       </a:r>
                       <a:r>
                         <a:rPr lang="nl-NL" noProof="0" dirty="0"/>

</xml_diff>

<commit_message>
Final touch up to SQL P2
</commit_message>
<xml_diff>
--- a/sql_course_2p/2_database_design/2_database_design.pptx
+++ b/sql_course_2p/2_database_design/2_database_design.pptx
@@ -5,7 +5,7 @@
     <p:sldMasterId id="2147483648" r:id="rId1"/>
   </p:sldMasterIdLst>
   <p:notesMasterIdLst>
-    <p:notesMasterId r:id="rId65"/>
+    <p:notesMasterId r:id="rId66"/>
   </p:notesMasterIdLst>
   <p:sldIdLst>
     <p:sldId id="256" r:id="rId2"/>
@@ -57,20 +57,21 @@
     <p:sldId id="333" r:id="rId48"/>
     <p:sldId id="392" r:id="rId49"/>
     <p:sldId id="343" r:id="rId50"/>
-    <p:sldId id="377" r:id="rId51"/>
-    <p:sldId id="380" r:id="rId52"/>
-    <p:sldId id="378" r:id="rId53"/>
-    <p:sldId id="398" r:id="rId54"/>
-    <p:sldId id="394" r:id="rId55"/>
-    <p:sldId id="367" r:id="rId56"/>
-    <p:sldId id="372" r:id="rId57"/>
-    <p:sldId id="374" r:id="rId58"/>
-    <p:sldId id="373" r:id="rId59"/>
-    <p:sldId id="297" r:id="rId60"/>
-    <p:sldId id="376" r:id="rId61"/>
-    <p:sldId id="375" r:id="rId62"/>
-    <p:sldId id="341" r:id="rId63"/>
-    <p:sldId id="342" r:id="rId64"/>
+    <p:sldId id="394" r:id="rId51"/>
+    <p:sldId id="377" r:id="rId52"/>
+    <p:sldId id="380" r:id="rId53"/>
+    <p:sldId id="378" r:id="rId54"/>
+    <p:sldId id="398" r:id="rId55"/>
+    <p:sldId id="408" r:id="rId56"/>
+    <p:sldId id="367" r:id="rId57"/>
+    <p:sldId id="372" r:id="rId58"/>
+    <p:sldId id="374" r:id="rId59"/>
+    <p:sldId id="373" r:id="rId60"/>
+    <p:sldId id="297" r:id="rId61"/>
+    <p:sldId id="376" r:id="rId62"/>
+    <p:sldId id="375" r:id="rId63"/>
+    <p:sldId id="341" r:id="rId64"/>
+    <p:sldId id="342" r:id="rId65"/>
   </p:sldIdLst>
   <p:sldSz cx="12192000" cy="6858000"/>
   <p:notesSz cx="6858000" cy="9144000"/>
@@ -259,7 +260,7 @@
           <a:p>
             <a:fld id="{61CE90D0-176A-4BE5-B54F-392F0A16E3B3}" type="datetimeFigureOut">
               <a:rPr lang="en-NL" smtClean="0"/>
-              <a:t>20/10/2026</a:t>
+              <a:t>21/10/2026</a:t>
             </a:fld>
             <a:endParaRPr lang="en-NL"/>
           </a:p>
@@ -2300,7 +2301,7 @@
           <a:p>
             <a:fld id="{F847AAA1-0A2D-4E17-BD7E-ECD1F2F24FF1}" type="slidenum">
               <a:rPr lang="en-NL" smtClean="0"/>
-              <a:t>55</a:t>
+              <a:t>56</a:t>
             </a:fld>
             <a:endParaRPr lang="en-NL"/>
           </a:p>
@@ -2408,7 +2409,7 @@
           <a:p>
             <a:fld id="{F847AAA1-0A2D-4E17-BD7E-ECD1F2F24FF1}" type="slidenum">
               <a:rPr lang="en-NL" smtClean="0"/>
-              <a:t>56</a:t>
+              <a:t>57</a:t>
             </a:fld>
             <a:endParaRPr lang="en-NL"/>
           </a:p>
@@ -2516,7 +2517,7 @@
           <a:p>
             <a:fld id="{F847AAA1-0A2D-4E17-BD7E-ECD1F2F24FF1}" type="slidenum">
               <a:rPr lang="en-NL" smtClean="0"/>
-              <a:t>57</a:t>
+              <a:t>58</a:t>
             </a:fld>
             <a:endParaRPr lang="en-NL"/>
           </a:p>
@@ -2624,7 +2625,7 @@
           <a:p>
             <a:fld id="{F847AAA1-0A2D-4E17-BD7E-ECD1F2F24FF1}" type="slidenum">
               <a:rPr lang="en-NL" smtClean="0"/>
-              <a:t>58</a:t>
+              <a:t>59</a:t>
             </a:fld>
             <a:endParaRPr lang="en-NL"/>
           </a:p>
@@ -2708,7 +2709,7 @@
           <a:p>
             <a:fld id="{F847AAA1-0A2D-4E17-BD7E-ECD1F2F24FF1}" type="slidenum">
               <a:rPr lang="en-NL" smtClean="0"/>
-              <a:t>59</a:t>
+              <a:t>60</a:t>
             </a:fld>
             <a:endParaRPr lang="en-NL"/>
           </a:p>
@@ -2924,7 +2925,7 @@
           <a:p>
             <a:fld id="{F847AAA1-0A2D-4E17-BD7E-ECD1F2F24FF1}" type="slidenum">
               <a:rPr lang="en-NL" smtClean="0"/>
-              <a:t>60</a:t>
+              <a:t>61</a:t>
             </a:fld>
             <a:endParaRPr lang="en-NL"/>
           </a:p>
@@ -3032,7 +3033,7 @@
           <a:p>
             <a:fld id="{F847AAA1-0A2D-4E17-BD7E-ECD1F2F24FF1}" type="slidenum">
               <a:rPr lang="en-NL" smtClean="0"/>
-              <a:t>61</a:t>
+              <a:t>62</a:t>
             </a:fld>
             <a:endParaRPr lang="en-NL"/>
           </a:p>
@@ -3116,7 +3117,7 @@
           <a:p>
             <a:fld id="{F847AAA1-0A2D-4E17-BD7E-ECD1F2F24FF1}" type="slidenum">
               <a:rPr lang="en-NL" smtClean="0"/>
-              <a:t>62</a:t>
+              <a:t>63</a:t>
             </a:fld>
             <a:endParaRPr lang="en-NL"/>
           </a:p>
@@ -3846,7 +3847,7 @@
           <a:p>
             <a:fld id="{7B15CBDA-B49C-4B0F-9869-5B15867EA611}" type="datetimeFigureOut">
               <a:rPr lang="en-NL" smtClean="0"/>
-              <a:t>20/10/2026</a:t>
+              <a:t>21/10/2026</a:t>
             </a:fld>
             <a:endParaRPr lang="en-NL"/>
           </a:p>
@@ -4046,7 +4047,7 @@
           <a:p>
             <a:fld id="{7B15CBDA-B49C-4B0F-9869-5B15867EA611}" type="datetimeFigureOut">
               <a:rPr lang="en-NL" smtClean="0"/>
-              <a:t>20/10/2026</a:t>
+              <a:t>21/10/2026</a:t>
             </a:fld>
             <a:endParaRPr lang="en-NL"/>
           </a:p>
@@ -4256,7 +4257,7 @@
           <a:p>
             <a:fld id="{7B15CBDA-B49C-4B0F-9869-5B15867EA611}" type="datetimeFigureOut">
               <a:rPr lang="en-NL" smtClean="0"/>
-              <a:t>20/10/2026</a:t>
+              <a:t>21/10/2026</a:t>
             </a:fld>
             <a:endParaRPr lang="en-NL"/>
           </a:p>
@@ -4456,7 +4457,7 @@
           <a:p>
             <a:fld id="{7B15CBDA-B49C-4B0F-9869-5B15867EA611}" type="datetimeFigureOut">
               <a:rPr lang="en-NL" smtClean="0"/>
-              <a:t>20/10/2026</a:t>
+              <a:t>21/10/2026</a:t>
             </a:fld>
             <a:endParaRPr lang="en-NL"/>
           </a:p>
@@ -4732,7 +4733,7 @@
           <a:p>
             <a:fld id="{7B15CBDA-B49C-4B0F-9869-5B15867EA611}" type="datetimeFigureOut">
               <a:rPr lang="en-NL" smtClean="0"/>
-              <a:t>20/10/2026</a:t>
+              <a:t>21/10/2026</a:t>
             </a:fld>
             <a:endParaRPr lang="en-NL"/>
           </a:p>
@@ -5000,7 +5001,7 @@
           <a:p>
             <a:fld id="{7B15CBDA-B49C-4B0F-9869-5B15867EA611}" type="datetimeFigureOut">
               <a:rPr lang="en-NL" smtClean="0"/>
-              <a:t>20/10/2026</a:t>
+              <a:t>21/10/2026</a:t>
             </a:fld>
             <a:endParaRPr lang="en-NL"/>
           </a:p>
@@ -5415,7 +5416,7 @@
           <a:p>
             <a:fld id="{7B15CBDA-B49C-4B0F-9869-5B15867EA611}" type="datetimeFigureOut">
               <a:rPr lang="en-NL" smtClean="0"/>
-              <a:t>20/10/2026</a:t>
+              <a:t>21/10/2026</a:t>
             </a:fld>
             <a:endParaRPr lang="en-NL"/>
           </a:p>
@@ -5557,7 +5558,7 @@
           <a:p>
             <a:fld id="{7B15CBDA-B49C-4B0F-9869-5B15867EA611}" type="datetimeFigureOut">
               <a:rPr lang="en-NL" smtClean="0"/>
-              <a:t>20/10/2026</a:t>
+              <a:t>21/10/2026</a:t>
             </a:fld>
             <a:endParaRPr lang="en-NL"/>
           </a:p>
@@ -5670,7 +5671,7 @@
           <a:p>
             <a:fld id="{7B15CBDA-B49C-4B0F-9869-5B15867EA611}" type="datetimeFigureOut">
               <a:rPr lang="en-NL" smtClean="0"/>
-              <a:t>20/10/2026</a:t>
+              <a:t>21/10/2026</a:t>
             </a:fld>
             <a:endParaRPr lang="en-NL"/>
           </a:p>
@@ -5983,7 +5984,7 @@
           <a:p>
             <a:fld id="{7B15CBDA-B49C-4B0F-9869-5B15867EA611}" type="datetimeFigureOut">
               <a:rPr lang="en-NL" smtClean="0"/>
-              <a:t>20/10/2026</a:t>
+              <a:t>21/10/2026</a:t>
             </a:fld>
             <a:endParaRPr lang="en-NL"/>
           </a:p>
@@ -6272,7 +6273,7 @@
           <a:p>
             <a:fld id="{7B15CBDA-B49C-4B0F-9869-5B15867EA611}" type="datetimeFigureOut">
               <a:rPr lang="en-NL" smtClean="0"/>
-              <a:t>20/10/2026</a:t>
+              <a:t>21/10/2026</a:t>
             </a:fld>
             <a:endParaRPr lang="en-NL"/>
           </a:p>
@@ -6515,7 +6516,7 @@
           <a:p>
             <a:fld id="{7B15CBDA-B49C-4B0F-9869-5B15867EA611}" type="datetimeFigureOut">
               <a:rPr lang="en-NL" smtClean="0"/>
-              <a:t>20/10/2026</a:t>
+              <a:t>21/10/2026</a:t>
             </a:fld>
             <a:endParaRPr lang="en-NL"/>
           </a:p>
@@ -22349,8 +22350,14 @@
             </a:pPr>
             <a:r>
               <a:rPr lang="nl-NL" sz="2000" dirty="0"/>
-              <a:t>Leden    =&gt;     Betaalstatus: Inschrijving	           1:n</a:t>
-            </a:r>
+              <a:t>Leden    =&gt;    Betaalstatus: Contributie	           1:n</a:t>
+            </a:r>
+          </a:p>
+          <a:p>
+            <a:pPr marL="0" indent="0">
+              <a:buNone/>
+            </a:pPr>
+            <a:endParaRPr lang="nl-NL" sz="2000" dirty="0"/>
           </a:p>
           <a:p>
             <a:pPr>
@@ -22359,14 +22366,8 @@
             </a:pPr>
             <a:r>
               <a:rPr lang="nl-NL" sz="2000" dirty="0"/>
-              <a:t>Leden    =&gt;     Betaalstatus: Contributie	           1:n</a:t>
-            </a:r>
-          </a:p>
-          <a:p>
-            <a:pPr marL="0" indent="0">
-              <a:buNone/>
-            </a:pPr>
-            <a:endParaRPr lang="nl-NL" sz="2000" dirty="0"/>
+              <a:t>Toernooien    =&gt;    Toernooi inschrijving	           1:n</a:t>
+            </a:r>
           </a:p>
           <a:p>
             <a:pPr>
@@ -22375,13 +22376,28 @@
             </a:pPr>
             <a:r>
               <a:rPr lang="nl-NL" sz="2000" dirty="0"/>
-              <a:t>Toernooien    =&gt;    Toernooi inschrijving	           1:n</a:t>
-            </a:r>
-          </a:p>
-          <a:p>
-            <a:pPr>
-              <a:buFontTx/>
-              <a:buChar char="-"/>
+              <a:t>Inschrijving    </a:t>
+            </a:r>
+            <a:r>
+              <a:rPr lang="nl-NL" sz="2000"/>
+              <a:t>=&gt;    Betaalstatus</a:t>
+            </a:r>
+            <a:r>
+              <a:rPr lang="nl-NL" sz="2000" dirty="0"/>
+              <a:t>: </a:t>
+            </a:r>
+            <a:r>
+              <a:rPr lang="nl-NL" sz="2000"/>
+              <a:t>Inschrijving         </a:t>
+            </a:r>
+            <a:r>
+              <a:rPr lang="nl-NL" sz="2000" dirty="0"/>
+              <a:t>1:n</a:t>
+            </a:r>
+          </a:p>
+          <a:p>
+            <a:pPr marL="0" indent="0">
+              <a:buNone/>
             </a:pPr>
             <a:endParaRPr lang="nl-NL" sz="2000" dirty="0"/>
           </a:p>
@@ -32977,6 +32993,97 @@
         <p:cNvPr id="1" name="">
           <a:extLst>
             <a:ext uri="{FF2B5EF4-FFF2-40B4-BE49-F238E27FC236}">
+              <a16:creationId xmlns:a16="http://schemas.microsoft.com/office/drawing/2014/main" id="{42F01F3E-CB49-03B6-A9A1-EF324F50C3A5}"/>
+            </a:ext>
+          </a:extLst>
+        </p:cNvPr>
+        <p:cNvGrpSpPr/>
+        <p:nvPr/>
+      </p:nvGrpSpPr>
+      <p:grpSpPr>
+        <a:xfrm>
+          <a:off x="0" y="0"/>
+          <a:ext cx="0" cy="0"/>
+          <a:chOff x="0" y="0"/>
+          <a:chExt cx="0" cy="0"/>
+        </a:xfrm>
+      </p:grpSpPr>
+      <p:sp>
+        <p:nvSpPr>
+          <p:cNvPr id="4" name="Title 3">
+            <a:extLst>
+              <a:ext uri="{FF2B5EF4-FFF2-40B4-BE49-F238E27FC236}">
+                <a16:creationId xmlns:a16="http://schemas.microsoft.com/office/drawing/2014/main" id="{DE6FF54E-64FF-4096-770F-3700E4F68C22}"/>
+              </a:ext>
+            </a:extLst>
+          </p:cNvPr>
+          <p:cNvSpPr>
+            <a:spLocks noGrp="1"/>
+          </p:cNvSpPr>
+          <p:nvPr>
+            <p:ph type="title"/>
+          </p:nvPr>
+        </p:nvSpPr>
+        <p:spPr/>
+        <p:txBody>
+          <a:bodyPr>
+            <a:normAutofit/>
+          </a:bodyPr>
+          <a:lstStyle/>
+          <a:p>
+            <a:r>
+              <a:rPr lang="nl-NL" sz="4400" noProof="0" dirty="0"/>
+              <a:t>Views</a:t>
+            </a:r>
+          </a:p>
+        </p:txBody>
+      </p:sp>
+      <p:sp>
+        <p:nvSpPr>
+          <p:cNvPr id="5" name="Text Placeholder 4">
+            <a:extLst>
+              <a:ext uri="{FF2B5EF4-FFF2-40B4-BE49-F238E27FC236}">
+                <a16:creationId xmlns:a16="http://schemas.microsoft.com/office/drawing/2014/main" id="{C139FB1B-A047-E71C-74C7-CFA610D12EC8}"/>
+              </a:ext>
+            </a:extLst>
+          </p:cNvPr>
+          <p:cNvSpPr>
+            <a:spLocks noGrp="1"/>
+          </p:cNvSpPr>
+          <p:nvPr>
+            <p:ph type="body" idx="1"/>
+          </p:nvPr>
+        </p:nvSpPr>
+        <p:spPr/>
+        <p:txBody>
+          <a:bodyPr/>
+          <a:lstStyle/>
+          <a:p>
+            <a:endParaRPr lang="nl-NL" noProof="0" dirty="0"/>
+          </a:p>
+        </p:txBody>
+      </p:sp>
+    </p:spTree>
+    <p:extLst>
+      <p:ext uri="{BB962C8B-B14F-4D97-AF65-F5344CB8AC3E}">
+        <p14:creationId xmlns:p14="http://schemas.microsoft.com/office/powerpoint/2010/main" val="2797826000"/>
+      </p:ext>
+    </p:extLst>
+  </p:cSld>
+  <p:clrMapOvr>
+    <a:masterClrMapping/>
+  </p:clrMapOvr>
+</p:sld>
+</file>
+
+<file path=ppt/slides/slide51.xml><?xml version="1.0" encoding="utf-8"?>
+<p:sld xmlns:a="http://schemas.openxmlformats.org/drawingml/2006/main" xmlns:r="http://schemas.openxmlformats.org/officeDocument/2006/relationships" xmlns:p="http://schemas.openxmlformats.org/presentationml/2006/main">
+  <p:cSld>
+    <p:spTree>
+      <p:nvGrpSpPr>
+        <p:cNvPr id="1" name="">
+          <a:extLst>
+            <a:ext uri="{FF2B5EF4-FFF2-40B4-BE49-F238E27FC236}">
               <a16:creationId xmlns:a16="http://schemas.microsoft.com/office/drawing/2014/main" id="{33BDE829-6C23-396D-336E-27FE9A497B11}"/>
             </a:ext>
           </a:extLst>
@@ -34334,7 +34441,7 @@
 </p:sld>
 </file>
 
-<file path=ppt/slides/slide51.xml><?xml version="1.0" encoding="utf-8"?>
+<file path=ppt/slides/slide52.xml><?xml version="1.0" encoding="utf-8"?>
 <p:sld xmlns:a="http://schemas.openxmlformats.org/drawingml/2006/main" xmlns:r="http://schemas.openxmlformats.org/officeDocument/2006/relationships" xmlns:p="http://schemas.openxmlformats.org/presentationml/2006/main">
   <p:cSld>
     <p:spTree>
@@ -35077,7 +35184,7 @@
 </p:sld>
 </file>
 
-<file path=ppt/slides/slide52.xml><?xml version="1.0" encoding="utf-8"?>
+<file path=ppt/slides/slide53.xml><?xml version="1.0" encoding="utf-8"?>
 <p:sld xmlns:a="http://schemas.openxmlformats.org/drawingml/2006/main" xmlns:r="http://schemas.openxmlformats.org/officeDocument/2006/relationships" xmlns:p="http://schemas.openxmlformats.org/presentationml/2006/main">
   <p:cSld>
     <p:spTree>
@@ -35521,7 +35628,7 @@
 </p:sld>
 </file>
 
-<file path=ppt/slides/slide53.xml><?xml version="1.0" encoding="utf-8"?>
+<file path=ppt/slides/slide54.xml><?xml version="1.0" encoding="utf-8"?>
 <p:sld xmlns:a="http://schemas.openxmlformats.org/drawingml/2006/main" xmlns:r="http://schemas.openxmlformats.org/officeDocument/2006/relationships" xmlns:p="http://schemas.openxmlformats.org/presentationml/2006/main">
   <p:cSld>
     <p:spTree>
@@ -35746,7 +35853,7 @@
 </p:sld>
 </file>
 
-<file path=ppt/slides/slide54.xml><?xml version="1.0" encoding="utf-8"?>
+<file path=ppt/slides/slide55.xml><?xml version="1.0" encoding="utf-8"?>
 <p:sld xmlns:a="http://schemas.openxmlformats.org/drawingml/2006/main" xmlns:r="http://schemas.openxmlformats.org/officeDocument/2006/relationships" xmlns:p="http://schemas.openxmlformats.org/presentationml/2006/main">
   <p:cSld>
     <p:spTree>
@@ -35754,7 +35861,7 @@
         <p:cNvPr id="1" name="">
           <a:extLst>
             <a:ext uri="{FF2B5EF4-FFF2-40B4-BE49-F238E27FC236}">
-              <a16:creationId xmlns:a16="http://schemas.microsoft.com/office/drawing/2014/main" id="{42F01F3E-CB49-03B6-A9A1-EF324F50C3A5}"/>
+              <a16:creationId xmlns:a16="http://schemas.microsoft.com/office/drawing/2014/main" id="{69170319-3824-F997-6292-EF74F0208F32}"/>
             </a:ext>
           </a:extLst>
         </p:cNvPr>
@@ -35774,7 +35881,7 @@
           <p:cNvPr id="4" name="Title 3">
             <a:extLst>
               <a:ext uri="{FF2B5EF4-FFF2-40B4-BE49-F238E27FC236}">
-                <a16:creationId xmlns:a16="http://schemas.microsoft.com/office/drawing/2014/main" id="{DE6FF54E-64FF-4096-770F-3700E4F68C22}"/>
+                <a16:creationId xmlns:a16="http://schemas.microsoft.com/office/drawing/2014/main" id="{F92571A1-C7A1-FC26-3B89-9AE3F9A6EF15}"/>
               </a:ext>
             </a:extLst>
           </p:cNvPr>
@@ -35804,7 +35911,7 @@
           <p:cNvPr id="5" name="Text Placeholder 4">
             <a:extLst>
               <a:ext uri="{FF2B5EF4-FFF2-40B4-BE49-F238E27FC236}">
-                <a16:creationId xmlns:a16="http://schemas.microsoft.com/office/drawing/2014/main" id="{C139FB1B-A047-E71C-74C7-CFA610D12EC8}"/>
+                <a16:creationId xmlns:a16="http://schemas.microsoft.com/office/drawing/2014/main" id="{46493E2C-AEC1-5878-DD0C-9AEAB99691AB}"/>
               </a:ext>
             </a:extLst>
           </p:cNvPr>
@@ -35827,7 +35934,7 @@
     </p:spTree>
     <p:extLst>
       <p:ext uri="{BB962C8B-B14F-4D97-AF65-F5344CB8AC3E}">
-        <p14:creationId xmlns:p14="http://schemas.microsoft.com/office/powerpoint/2010/main" val="2797826000"/>
+        <p14:creationId xmlns:p14="http://schemas.microsoft.com/office/powerpoint/2010/main" val="2131446514"/>
       </p:ext>
     </p:extLst>
   </p:cSld>
@@ -35837,7 +35944,7 @@
 </p:sld>
 </file>
 
-<file path=ppt/slides/slide55.xml><?xml version="1.0" encoding="utf-8"?>
+<file path=ppt/slides/slide56.xml><?xml version="1.0" encoding="utf-8"?>
 <p:sld xmlns:a="http://schemas.openxmlformats.org/drawingml/2006/main" xmlns:r="http://schemas.openxmlformats.org/officeDocument/2006/relationships" xmlns:p="http://schemas.openxmlformats.org/presentationml/2006/main">
   <p:cSld>
     <p:spTree>
@@ -36878,7 +36985,7 @@
 </p:sld>
 </file>
 
-<file path=ppt/slides/slide56.xml><?xml version="1.0" encoding="utf-8"?>
+<file path=ppt/slides/slide57.xml><?xml version="1.0" encoding="utf-8"?>
 <p:sld xmlns:a="http://schemas.openxmlformats.org/drawingml/2006/main" xmlns:r="http://schemas.openxmlformats.org/officeDocument/2006/relationships" xmlns:p="http://schemas.openxmlformats.org/presentationml/2006/main">
   <p:cSld>
     <p:spTree>
@@ -37894,7 +38001,7 @@
 </p:sld>
 </file>
 
-<file path=ppt/slides/slide57.xml><?xml version="1.0" encoding="utf-8"?>
+<file path=ppt/slides/slide58.xml><?xml version="1.0" encoding="utf-8"?>
 <p:sld xmlns:a="http://schemas.openxmlformats.org/drawingml/2006/main" xmlns:r="http://schemas.openxmlformats.org/officeDocument/2006/relationships" xmlns:p="http://schemas.openxmlformats.org/presentationml/2006/main">
   <p:cSld>
     <p:spTree>
@@ -39717,7 +39824,7 @@
 </p:sld>
 </file>
 
-<file path=ppt/slides/slide58.xml><?xml version="1.0" encoding="utf-8"?>
+<file path=ppt/slides/slide59.xml><?xml version="1.0" encoding="utf-8"?>
 <p:sld xmlns:a="http://schemas.openxmlformats.org/drawingml/2006/main" xmlns:r="http://schemas.openxmlformats.org/officeDocument/2006/relationships" xmlns:p="http://schemas.openxmlformats.org/presentationml/2006/main">
   <p:cSld>
     <p:spTree>
@@ -41720,7 +41827,242 @@
 </p:sld>
 </file>
 
-<file path=ppt/slides/slide59.xml><?xml version="1.0" encoding="utf-8"?>
+<file path=ppt/slides/slide6.xml><?xml version="1.0" encoding="utf-8"?>
+<p:sld xmlns:a="http://schemas.openxmlformats.org/drawingml/2006/main" xmlns:r="http://schemas.openxmlformats.org/officeDocument/2006/relationships" xmlns:p="http://schemas.openxmlformats.org/presentationml/2006/main">
+  <p:cSld>
+    <p:spTree>
+      <p:nvGrpSpPr>
+        <p:cNvPr id="1" name=""/>
+        <p:cNvGrpSpPr/>
+        <p:nvPr/>
+      </p:nvGrpSpPr>
+      <p:grpSpPr>
+        <a:xfrm>
+          <a:off x="0" y="0"/>
+          <a:ext cx="0" cy="0"/>
+          <a:chOff x="0" y="0"/>
+          <a:chExt cx="0" cy="0"/>
+        </a:xfrm>
+      </p:grpSpPr>
+      <p:sp>
+        <p:nvSpPr>
+          <p:cNvPr id="2" name="Title 1">
+            <a:extLst>
+              <a:ext uri="{FF2B5EF4-FFF2-40B4-BE49-F238E27FC236}">
+                <a16:creationId xmlns:a16="http://schemas.microsoft.com/office/drawing/2014/main" id="{9BDFD261-0D2C-41B9-9E28-43DF575D40E0}"/>
+              </a:ext>
+            </a:extLst>
+          </p:cNvPr>
+          <p:cNvSpPr>
+            <a:spLocks noGrp="1"/>
+          </p:cNvSpPr>
+          <p:nvPr>
+            <p:ph type="title"/>
+          </p:nvPr>
+        </p:nvSpPr>
+        <p:spPr/>
+        <p:txBody>
+          <a:bodyPr>
+            <a:normAutofit/>
+          </a:bodyPr>
+          <a:lstStyle/>
+          <a:p>
+            <a:r>
+              <a:rPr lang="nl-NL" sz="3600" noProof="0" dirty="0"/>
+              <a:t>Drie soorten relaties</a:t>
+            </a:r>
+          </a:p>
+        </p:txBody>
+      </p:sp>
+      <p:graphicFrame>
+        <p:nvGraphicFramePr>
+          <p:cNvPr id="4" name="Table 6">
+            <a:extLst>
+              <a:ext uri="{FF2B5EF4-FFF2-40B4-BE49-F238E27FC236}">
+                <a16:creationId xmlns:a16="http://schemas.microsoft.com/office/drawing/2014/main" id="{03C5159B-CC96-B768-65C5-6D3F2D193877}"/>
+              </a:ext>
+            </a:extLst>
+          </p:cNvPr>
+          <p:cNvGraphicFramePr>
+            <a:graphicFrameLocks noGrp="1"/>
+          </p:cNvGraphicFramePr>
+          <p:nvPr>
+            <p:extLst>
+              <p:ext uri="{D42A27DB-BD31-4B8C-83A1-F6EECF244321}">
+                <p14:modId xmlns:p14="http://schemas.microsoft.com/office/powerpoint/2010/main" val="2438666545"/>
+              </p:ext>
+            </p:extLst>
+          </p:nvPr>
+        </p:nvGraphicFramePr>
+        <p:xfrm>
+          <a:off x="838200" y="1635709"/>
+          <a:ext cx="10442826" cy="1735556"/>
+        </p:xfrm>
+        <a:graphic>
+          <a:graphicData uri="http://schemas.openxmlformats.org/drawingml/2006/table">
+            <a:tbl>
+              <a:tblPr firstRow="1" bandRow="1">
+                <a:tableStyleId>{5C22544A-7EE6-4342-B048-85BDC9FD1C3A}</a:tableStyleId>
+              </a:tblPr>
+              <a:tblGrid>
+                <a:gridCol w="1461868">
+                  <a:extLst>
+                    <a:ext uri="{9D8B030D-6E8A-4147-A177-3AD203B41FA5}">
+                      <a16:colId xmlns:a16="http://schemas.microsoft.com/office/drawing/2014/main" val="2462131715"/>
+                    </a:ext>
+                  </a:extLst>
+                </a:gridCol>
+                <a:gridCol w="4424290">
+                  <a:extLst>
+                    <a:ext uri="{9D8B030D-6E8A-4147-A177-3AD203B41FA5}">
+                      <a16:colId xmlns:a16="http://schemas.microsoft.com/office/drawing/2014/main" val="2197458734"/>
+                    </a:ext>
+                  </a:extLst>
+                </a:gridCol>
+                <a:gridCol w="4556668">
+                  <a:extLst>
+                    <a:ext uri="{9D8B030D-6E8A-4147-A177-3AD203B41FA5}">
+                      <a16:colId xmlns:a16="http://schemas.microsoft.com/office/drawing/2014/main" val="1150342863"/>
+                    </a:ext>
+                  </a:extLst>
+                </a:gridCol>
+              </a:tblGrid>
+              <a:tr h="456205">
+                <a:tc>
+                  <a:txBody>
+                    <a:bodyPr/>
+                    <a:lstStyle/>
+                    <a:p>
+                      <a:r>
+                        <a:rPr lang="nl-NL" noProof="0" dirty="0"/>
+                        <a:t>Soort relatie</a:t>
+                      </a:r>
+                    </a:p>
+                  </a:txBody>
+                  <a:tcPr anchor="ctr"/>
+                </a:tc>
+                <a:tc>
+                  <a:txBody>
+                    <a:bodyPr/>
+                    <a:lstStyle/>
+                    <a:p>
+                      <a:r>
+                        <a:rPr lang="nl-NL" noProof="0" dirty="0"/>
+                        <a:t>Voorbeeld</a:t>
+                      </a:r>
+                    </a:p>
+                  </a:txBody>
+                  <a:tcPr anchor="ctr"/>
+                </a:tc>
+                <a:tc>
+                  <a:txBody>
+                    <a:bodyPr/>
+                    <a:lstStyle/>
+                    <a:p>
+                      <a:r>
+                        <a:rPr lang="nl-NL" noProof="0" dirty="0"/>
+                        <a:t>Structuur</a:t>
+                      </a:r>
+                    </a:p>
+                  </a:txBody>
+                  <a:tcPr anchor="ctr"/>
+                </a:tc>
+                <a:extLst>
+                  <a:ext uri="{0D108BD9-81ED-4DB2-BD59-A6C34878D82A}">
+                    <a16:rowId xmlns:a16="http://schemas.microsoft.com/office/drawing/2014/main" val="58239531"/>
+                  </a:ext>
+                </a:extLst>
+              </a:tr>
+              <a:tr h="1279351">
+                <a:tc>
+                  <a:txBody>
+                    <a:bodyPr/>
+                    <a:lstStyle/>
+                    <a:p>
+                      <a:r>
+                        <a:rPr lang="nl-NL" noProof="0" dirty="0"/>
+                        <a:t>één op één</a:t>
+                      </a:r>
+                    </a:p>
+                  </a:txBody>
+                  <a:tcPr anchor="ctr"/>
+                </a:tc>
+                <a:tc>
+                  <a:txBody>
+                    <a:bodyPr/>
+                    <a:lstStyle/>
+                    <a:p>
+                      <a:r>
+                        <a:rPr lang="nl-NL" noProof="0" dirty="0"/>
+                        <a:t>Een klant heeft één BSN.</a:t>
+                      </a:r>
+                    </a:p>
+                    <a:p>
+                      <a:endParaRPr lang="nl-NL" noProof="0" dirty="0"/>
+                    </a:p>
+                    <a:p>
+                      <a:r>
+                        <a:rPr lang="nl-NL" noProof="0" dirty="0"/>
+                        <a:t>Een BSN hoort bij één klant.</a:t>
+                      </a:r>
+                    </a:p>
+                  </a:txBody>
+                  <a:tcPr anchor="ctr"/>
+                </a:tc>
+                <a:tc>
+                  <a:txBody>
+                    <a:bodyPr/>
+                    <a:lstStyle/>
+                    <a:p>
+                      <a:r>
+                        <a:rPr lang="nl-NL" noProof="0" dirty="0"/>
+                        <a:t>Opnemen als attribuut in de tabel.</a:t>
+                      </a:r>
+                    </a:p>
+                    <a:p>
+                      <a:r>
+                        <a:rPr lang="nl-NL" noProof="0" dirty="0"/>
+                        <a:t>(</a:t>
+                      </a:r>
+                      <a:r>
+                        <a:rPr lang="nl-NL" noProof="0" dirty="0">
+                          <a:latin typeface="Courier New" panose="02070309020205020404" pitchFamily="49" charset="0"/>
+                          <a:cs typeface="Courier New" panose="02070309020205020404" pitchFamily="49" charset="0"/>
+                        </a:rPr>
+                        <a:t>Klanten</a:t>
+                      </a:r>
+                      <a:r>
+                        <a:rPr lang="nl-NL" noProof="0" dirty="0"/>
+                        <a:t>)</a:t>
+                      </a:r>
+                    </a:p>
+                  </a:txBody>
+                  <a:tcPr anchor="ctr"/>
+                </a:tc>
+                <a:extLst>
+                  <a:ext uri="{0D108BD9-81ED-4DB2-BD59-A6C34878D82A}">
+                    <a16:rowId xmlns:a16="http://schemas.microsoft.com/office/drawing/2014/main" val="2768827451"/>
+                  </a:ext>
+                </a:extLst>
+              </a:tr>
+            </a:tbl>
+          </a:graphicData>
+        </a:graphic>
+      </p:graphicFrame>
+    </p:spTree>
+    <p:extLst>
+      <p:ext uri="{BB962C8B-B14F-4D97-AF65-F5344CB8AC3E}">
+        <p14:creationId xmlns:p14="http://schemas.microsoft.com/office/powerpoint/2010/main" val="1796087029"/>
+      </p:ext>
+    </p:extLst>
+  </p:cSld>
+  <p:clrMapOvr>
+    <a:masterClrMapping/>
+  </p:clrMapOvr>
+</p:sld>
+</file>
+
+<file path=ppt/slides/slide60.xml><?xml version="1.0" encoding="utf-8"?>
 <p:sld xmlns:a="http://schemas.openxmlformats.org/drawingml/2006/main" xmlns:r="http://schemas.openxmlformats.org/officeDocument/2006/relationships" xmlns:p="http://schemas.openxmlformats.org/presentationml/2006/main">
   <p:cSld>
     <p:spTree>
@@ -42123,242 +42465,7 @@
 </p:sld>
 </file>
 
-<file path=ppt/slides/slide6.xml><?xml version="1.0" encoding="utf-8"?>
-<p:sld xmlns:a="http://schemas.openxmlformats.org/drawingml/2006/main" xmlns:r="http://schemas.openxmlformats.org/officeDocument/2006/relationships" xmlns:p="http://schemas.openxmlformats.org/presentationml/2006/main">
-  <p:cSld>
-    <p:spTree>
-      <p:nvGrpSpPr>
-        <p:cNvPr id="1" name=""/>
-        <p:cNvGrpSpPr/>
-        <p:nvPr/>
-      </p:nvGrpSpPr>
-      <p:grpSpPr>
-        <a:xfrm>
-          <a:off x="0" y="0"/>
-          <a:ext cx="0" cy="0"/>
-          <a:chOff x="0" y="0"/>
-          <a:chExt cx="0" cy="0"/>
-        </a:xfrm>
-      </p:grpSpPr>
-      <p:sp>
-        <p:nvSpPr>
-          <p:cNvPr id="2" name="Title 1">
-            <a:extLst>
-              <a:ext uri="{FF2B5EF4-FFF2-40B4-BE49-F238E27FC236}">
-                <a16:creationId xmlns:a16="http://schemas.microsoft.com/office/drawing/2014/main" id="{9BDFD261-0D2C-41B9-9E28-43DF575D40E0}"/>
-              </a:ext>
-            </a:extLst>
-          </p:cNvPr>
-          <p:cNvSpPr>
-            <a:spLocks noGrp="1"/>
-          </p:cNvSpPr>
-          <p:nvPr>
-            <p:ph type="title"/>
-          </p:nvPr>
-        </p:nvSpPr>
-        <p:spPr/>
-        <p:txBody>
-          <a:bodyPr>
-            <a:normAutofit/>
-          </a:bodyPr>
-          <a:lstStyle/>
-          <a:p>
-            <a:r>
-              <a:rPr lang="nl-NL" sz="3600" noProof="0" dirty="0"/>
-              <a:t>Drie soorten relaties</a:t>
-            </a:r>
-          </a:p>
-        </p:txBody>
-      </p:sp>
-      <p:graphicFrame>
-        <p:nvGraphicFramePr>
-          <p:cNvPr id="4" name="Table 6">
-            <a:extLst>
-              <a:ext uri="{FF2B5EF4-FFF2-40B4-BE49-F238E27FC236}">
-                <a16:creationId xmlns:a16="http://schemas.microsoft.com/office/drawing/2014/main" id="{03C5159B-CC96-B768-65C5-6D3F2D193877}"/>
-              </a:ext>
-            </a:extLst>
-          </p:cNvPr>
-          <p:cNvGraphicFramePr>
-            <a:graphicFrameLocks noGrp="1"/>
-          </p:cNvGraphicFramePr>
-          <p:nvPr>
-            <p:extLst>
-              <p:ext uri="{D42A27DB-BD31-4B8C-83A1-F6EECF244321}">
-                <p14:modId xmlns:p14="http://schemas.microsoft.com/office/powerpoint/2010/main" val="2438666545"/>
-              </p:ext>
-            </p:extLst>
-          </p:nvPr>
-        </p:nvGraphicFramePr>
-        <p:xfrm>
-          <a:off x="838200" y="1635709"/>
-          <a:ext cx="10442826" cy="1735556"/>
-        </p:xfrm>
-        <a:graphic>
-          <a:graphicData uri="http://schemas.openxmlformats.org/drawingml/2006/table">
-            <a:tbl>
-              <a:tblPr firstRow="1" bandRow="1">
-                <a:tableStyleId>{5C22544A-7EE6-4342-B048-85BDC9FD1C3A}</a:tableStyleId>
-              </a:tblPr>
-              <a:tblGrid>
-                <a:gridCol w="1461868">
-                  <a:extLst>
-                    <a:ext uri="{9D8B030D-6E8A-4147-A177-3AD203B41FA5}">
-                      <a16:colId xmlns:a16="http://schemas.microsoft.com/office/drawing/2014/main" val="2462131715"/>
-                    </a:ext>
-                  </a:extLst>
-                </a:gridCol>
-                <a:gridCol w="4424290">
-                  <a:extLst>
-                    <a:ext uri="{9D8B030D-6E8A-4147-A177-3AD203B41FA5}">
-                      <a16:colId xmlns:a16="http://schemas.microsoft.com/office/drawing/2014/main" val="2197458734"/>
-                    </a:ext>
-                  </a:extLst>
-                </a:gridCol>
-                <a:gridCol w="4556668">
-                  <a:extLst>
-                    <a:ext uri="{9D8B030D-6E8A-4147-A177-3AD203B41FA5}">
-                      <a16:colId xmlns:a16="http://schemas.microsoft.com/office/drawing/2014/main" val="1150342863"/>
-                    </a:ext>
-                  </a:extLst>
-                </a:gridCol>
-              </a:tblGrid>
-              <a:tr h="456205">
-                <a:tc>
-                  <a:txBody>
-                    <a:bodyPr/>
-                    <a:lstStyle/>
-                    <a:p>
-                      <a:r>
-                        <a:rPr lang="nl-NL" noProof="0" dirty="0"/>
-                        <a:t>Soort relatie</a:t>
-                      </a:r>
-                    </a:p>
-                  </a:txBody>
-                  <a:tcPr anchor="ctr"/>
-                </a:tc>
-                <a:tc>
-                  <a:txBody>
-                    <a:bodyPr/>
-                    <a:lstStyle/>
-                    <a:p>
-                      <a:r>
-                        <a:rPr lang="nl-NL" noProof="0" dirty="0"/>
-                        <a:t>Voorbeeld</a:t>
-                      </a:r>
-                    </a:p>
-                  </a:txBody>
-                  <a:tcPr anchor="ctr"/>
-                </a:tc>
-                <a:tc>
-                  <a:txBody>
-                    <a:bodyPr/>
-                    <a:lstStyle/>
-                    <a:p>
-                      <a:r>
-                        <a:rPr lang="nl-NL" noProof="0" dirty="0"/>
-                        <a:t>Structuur</a:t>
-                      </a:r>
-                    </a:p>
-                  </a:txBody>
-                  <a:tcPr anchor="ctr"/>
-                </a:tc>
-                <a:extLst>
-                  <a:ext uri="{0D108BD9-81ED-4DB2-BD59-A6C34878D82A}">
-                    <a16:rowId xmlns:a16="http://schemas.microsoft.com/office/drawing/2014/main" val="58239531"/>
-                  </a:ext>
-                </a:extLst>
-              </a:tr>
-              <a:tr h="1279351">
-                <a:tc>
-                  <a:txBody>
-                    <a:bodyPr/>
-                    <a:lstStyle/>
-                    <a:p>
-                      <a:r>
-                        <a:rPr lang="nl-NL" noProof="0" dirty="0"/>
-                        <a:t>één op één</a:t>
-                      </a:r>
-                    </a:p>
-                  </a:txBody>
-                  <a:tcPr anchor="ctr"/>
-                </a:tc>
-                <a:tc>
-                  <a:txBody>
-                    <a:bodyPr/>
-                    <a:lstStyle/>
-                    <a:p>
-                      <a:r>
-                        <a:rPr lang="nl-NL" noProof="0" dirty="0"/>
-                        <a:t>Een klant heeft één BSN.</a:t>
-                      </a:r>
-                    </a:p>
-                    <a:p>
-                      <a:endParaRPr lang="nl-NL" noProof="0" dirty="0"/>
-                    </a:p>
-                    <a:p>
-                      <a:r>
-                        <a:rPr lang="nl-NL" noProof="0" dirty="0"/>
-                        <a:t>Een BSN hoort bij één klant.</a:t>
-                      </a:r>
-                    </a:p>
-                  </a:txBody>
-                  <a:tcPr anchor="ctr"/>
-                </a:tc>
-                <a:tc>
-                  <a:txBody>
-                    <a:bodyPr/>
-                    <a:lstStyle/>
-                    <a:p>
-                      <a:r>
-                        <a:rPr lang="nl-NL" noProof="0" dirty="0"/>
-                        <a:t>Opnemen als attribuut in de tabel.</a:t>
-                      </a:r>
-                    </a:p>
-                    <a:p>
-                      <a:r>
-                        <a:rPr lang="nl-NL" noProof="0" dirty="0"/>
-                        <a:t>(</a:t>
-                      </a:r>
-                      <a:r>
-                        <a:rPr lang="nl-NL" noProof="0" dirty="0">
-                          <a:latin typeface="Courier New" panose="02070309020205020404" pitchFamily="49" charset="0"/>
-                          <a:cs typeface="Courier New" panose="02070309020205020404" pitchFamily="49" charset="0"/>
-                        </a:rPr>
-                        <a:t>Klanten</a:t>
-                      </a:r>
-                      <a:r>
-                        <a:rPr lang="nl-NL" noProof="0" dirty="0"/>
-                        <a:t>)</a:t>
-                      </a:r>
-                    </a:p>
-                  </a:txBody>
-                  <a:tcPr anchor="ctr"/>
-                </a:tc>
-                <a:extLst>
-                  <a:ext uri="{0D108BD9-81ED-4DB2-BD59-A6C34878D82A}">
-                    <a16:rowId xmlns:a16="http://schemas.microsoft.com/office/drawing/2014/main" val="2768827451"/>
-                  </a:ext>
-                </a:extLst>
-              </a:tr>
-            </a:tbl>
-          </a:graphicData>
-        </a:graphic>
-      </p:graphicFrame>
-    </p:spTree>
-    <p:extLst>
-      <p:ext uri="{BB962C8B-B14F-4D97-AF65-F5344CB8AC3E}">
-        <p14:creationId xmlns:p14="http://schemas.microsoft.com/office/powerpoint/2010/main" val="1796087029"/>
-      </p:ext>
-    </p:extLst>
-  </p:cSld>
-  <p:clrMapOvr>
-    <a:masterClrMapping/>
-  </p:clrMapOvr>
-</p:sld>
-</file>
-
-<file path=ppt/slides/slide60.xml><?xml version="1.0" encoding="utf-8"?>
+<file path=ppt/slides/slide61.xml><?xml version="1.0" encoding="utf-8"?>
 <p:sld xmlns:a="http://schemas.openxmlformats.org/drawingml/2006/main" xmlns:r="http://schemas.openxmlformats.org/officeDocument/2006/relationships" xmlns:p="http://schemas.openxmlformats.org/presentationml/2006/main">
   <p:cSld>
     <p:spTree>
@@ -42884,7 +42991,7 @@
 </p:sld>
 </file>
 
-<file path=ppt/slides/slide61.xml><?xml version="1.0" encoding="utf-8"?>
+<file path=ppt/slides/slide62.xml><?xml version="1.0" encoding="utf-8"?>
 <p:sld xmlns:a="http://schemas.openxmlformats.org/drawingml/2006/main" xmlns:r="http://schemas.openxmlformats.org/officeDocument/2006/relationships" xmlns:p="http://schemas.openxmlformats.org/presentationml/2006/main">
   <p:cSld>
     <p:spTree>
@@ -43515,7 +43622,7 @@
 </p:sld>
 </file>
 
-<file path=ppt/slides/slide62.xml><?xml version="1.0" encoding="utf-8"?>
+<file path=ppt/slides/slide63.xml><?xml version="1.0" encoding="utf-8"?>
 <p:sld xmlns:a="http://schemas.openxmlformats.org/drawingml/2006/main" xmlns:r="http://schemas.openxmlformats.org/officeDocument/2006/relationships" xmlns:p="http://schemas.openxmlformats.org/presentationml/2006/main">
   <p:cSld>
     <p:spTree>
@@ -44123,7 +44230,7 @@
 </p:sld>
 </file>
 
-<file path=ppt/slides/slide63.xml><?xml version="1.0" encoding="utf-8"?>
+<file path=ppt/slides/slide64.xml><?xml version="1.0" encoding="utf-8"?>
 <p:sld xmlns:a="http://schemas.openxmlformats.org/drawingml/2006/main" xmlns:r="http://schemas.openxmlformats.org/officeDocument/2006/relationships" xmlns:p="http://schemas.openxmlformats.org/presentationml/2006/main">
   <p:cSld>
     <p:spTree>

</xml_diff>